<commit_message>
docs: clarify X11M quarter-equivalent comparison
</commit_message>
<xml_diff>
--- a/hermes_docs/exadata-x9m-to-exacc-x11m-transition.pptx
+++ b/hermes_docs/exadata-x9m-to-exacc-x11m-transition.pptx
@@ -6879,7 +6879,7 @@
                 <a:ea typeface="Noto Sans KR" pitchFamily="34" charset="-122"/>
                 <a:cs typeface="Noto Sans KR" pitchFamily="34" charset="-120"/>
               </a:rPr>
-              <a:t>2+3 동일</a:t>
+              <a:t>노드 수 2+3 동일</a:t>
             </a:r>
             <a:endParaRPr lang="en-US" sz="920" dirty="0"/>
           </a:p>
@@ -7722,7 +7722,7 @@
                 <a:ea typeface="Noto Sans KR" pitchFamily="34" charset="-122"/>
                 <a:cs typeface="Noto Sans KR" pitchFamily="34" charset="-120"/>
               </a:rPr>
-              <a:t>disk 26%↑</a:t>
+              <a:t>Disk 26%↑ · Flash 6%↑</a:t>
             </a:r>
             <a:endParaRPr lang="en-US" sz="920" dirty="0"/>
           </a:p>
@@ -8531,7 +8531,24 @@
                 <a:ea typeface="Noto Sans KR" pitchFamily="34" charset="-122"/>
                 <a:cs typeface="Noto Sans KR" pitchFamily="34" charset="-120"/>
               </a:rPr>
-              <a:t>쓰기 63%↑</a:t>
+              <a:t>읽기 동일</a:t>
+            </a:r>
+            <a:endParaRPr lang="en-US" sz="920" dirty="0"/>
+          </a:p>
+          <a:p>
+            <a:pPr algn="ctr" indent="0" marL="0">
+              <a:buNone/>
+            </a:pPr>
+            <a:r>
+              <a:rPr lang="en-US" sz="920" b="1" dirty="0">
+                <a:solidFill>
+                  <a:srgbClr val="2DD4BF"/>
+                </a:solidFill>
+                <a:latin typeface="Noto Sans KR" pitchFamily="34" charset="0"/>
+                <a:ea typeface="Noto Sans KR" pitchFamily="34" charset="-122"/>
+                <a:cs typeface="Noto Sans KR" pitchFamily="34" charset="-120"/>
+              </a:rPr>
+              <a:t>쓰기 약 63%↑</a:t>
             </a:r>
             <a:endParaRPr lang="en-US" sz="920" dirty="0"/>
           </a:p>
@@ -8870,7 +8887,7 @@
                 <a:ea typeface="Noto Sans KR" pitchFamily="34" charset="-122"/>
                 <a:cs typeface="Noto Sans KR" pitchFamily="34" charset="-120"/>
               </a:rPr>
-              <a:t>주의: “Quarter 상당”은 비교 편의 표현이며 Oracle 공식 X11M shape명은 Elastic 구성 · OCPU/ECPU 직접 등가 비교 불가</a:t>
+              <a:t>ExaCC X11M에는 공식 Quarter Rack shape가 없음 · 본 장표는 2 Standard DB + 3 HC w/XRMEM Elastic 구성 비교 · OCPU/ECPU 직접 등가 비교 불가</a:t>
             </a:r>
             <a:endParaRPr lang="en-US" sz="810" dirty="0"/>
           </a:p>

</xml_diff>

<commit_message>
docs: compare X9M eighth rack with X11M options
</commit_message>
<xml_diff>
--- a/hermes_docs/exadata-x9m-to-exacc-x11m-transition.pptx
+++ b/hermes_docs/exadata-x9m-to-exacc-x11m-transition.pptx
@@ -685,7 +685,7 @@
           <a:p>
             <a:r>
               <a:rPr lang="en-US" dirty="0"/>
-              <a:t>ExaCC X11M does not publish a Quarter Rack shape name. This slide compares the analogous 2 Standard DB Server + 3 High Capacity Storage Server with XRMEM elastic configuration.,Published performance metrics are maxima, not workload guarantees. Validate with AWR/ASH and representative workload POC.</a:t>
+              <a:t>X9M-2 Eighth Rack values are from the on-premises Exadata Database Machine X9M-2 data sheet: 2 database servers, 3 Eighth Rack HC storage servers, 64 physical database cores, and 96.2 TB usable capacity at ASM high redundancy.,ExaC@C X11M does not publish a Quarter Rack shape name. The Elastic comparison uses 2 Standard database servers and 3 High Capacity storage servers with XRMEM.,Physical cores, usable cores, OCPUs, and ECPUs are different service and licensing measures. Do not treat them as direct equivalents; final sizing requires AWR/ASH and workload validation.</a:t>
             </a:r>
             <a:endParaRPr lang="en-US" dirty="0"/>
           </a:p>
@@ -6310,7 +6310,7 @@
                 <a:ea typeface="Noto Sans KR" pitchFamily="34" charset="-122"/>
                 <a:cs typeface="Noto Sans KR" pitchFamily="34" charset="-120"/>
               </a:rPr>
-              <a:t>X9M Quarter와 ExaCC X11M “Quarter 상당 2+3” 구성 비교</a:t>
+              <a:t>X9M Eighth Rack vs ExaC@C X11M Base·Elastic 사양 비교</a:t>
             </a:r>
             <a:endParaRPr lang="en-US" sz="2500" dirty="0"/>
           </a:p>
@@ -6351,7 +6351,7 @@
                 <a:ea typeface="Noto Sans KR" pitchFamily="34" charset="-122"/>
                 <a:cs typeface="Noto Sans KR" pitchFamily="34" charset="-120"/>
               </a:rPr>
-              <a:t>ExaCC X11M은 Quarter Rack 명칭 대신 Elastic 구성 사용 · 비교 기준: 2 Standard DB + 3 HC Storage with XRMEM</a:t>
+              <a:t>온프레미스 최소 구성과 Cloud@Customer의 Base 및 Quarter 상당 2+3 Elastic 구성을 동일 지표로 비교</a:t>
             </a:r>
             <a:endParaRPr lang="en-US" sz="1050" dirty="0"/>
           </a:p>
@@ -6366,7 +6366,7 @@
         <p:spPr>
           <a:xfrm>
             <a:off x="512064" y="1463040"/>
-            <a:ext cx="2322576" cy="429768"/>
+            <a:ext cx="1984248" cy="484632"/>
           </a:xfrm>
           <a:prstGeom prst="rect">
             <a:avLst/>
@@ -6391,7 +6391,7 @@
         <p:spPr>
           <a:xfrm>
             <a:off x="603504" y="1517904"/>
-            <a:ext cx="2139696" cy="274320"/>
+            <a:ext cx="1801368" cy="365760"/>
           </a:xfrm>
           <a:prstGeom prst="rect">
             <a:avLst/>
@@ -6409,7 +6409,7 @@
               <a:buNone/>
             </a:pPr>
             <a:r>
-              <a:rPr lang="en-US" sz="940" b="1" dirty="0">
+              <a:rPr lang="en-US" sz="910" b="1" dirty="0">
                 <a:solidFill>
                   <a:srgbClr val="F7F9FC"/>
                 </a:solidFill>
@@ -6419,7 +6419,7 @@
               </a:rPr>
               <a:t>비교 항목</a:t>
             </a:r>
-            <a:endParaRPr lang="en-US" sz="940" dirty="0"/>
+            <a:endParaRPr lang="en-US" sz="910" dirty="0"/>
           </a:p>
         </p:txBody>
       </p:sp>
@@ -6431,8 +6431,8 @@
         </p:nvSpPr>
         <p:spPr>
           <a:xfrm>
-            <a:off x="2834640" y="1463040"/>
-            <a:ext cx="3703320" cy="429768"/>
+            <a:off x="2496312" y="1463040"/>
+            <a:ext cx="3008376" cy="484632"/>
           </a:xfrm>
           <a:prstGeom prst="rect">
             <a:avLst/>
@@ -6456,8 +6456,257 @@
         </p:nvSpPr>
         <p:spPr>
           <a:xfrm>
-            <a:off x="2926080" y="1517904"/>
-            <a:ext cx="3520440" cy="274320"/>
+            <a:off x="2587752" y="1517904"/>
+            <a:ext cx="2825496" cy="365760"/>
+          </a:xfrm>
+          <a:prstGeom prst="rect">
+            <a:avLst/>
+          </a:prstGeom>
+          <a:noFill/>
+          <a:ln/>
+        </p:spPr>
+        <p:txBody>
+          <a:bodyPr wrap="square" lIns="0" tIns="0" rIns="0" bIns="0" rtlCol="0" anchor="ctr">
+            <a:normAutofit/>
+          </a:bodyPr>
+          <a:lstStyle/>
+          <a:p>
+            <a:pPr algn="ctr" indent="0" marL="0">
+              <a:buNone/>
+            </a:pPr>
+            <a:r>
+              <a:rPr lang="en-US" sz="910" b="1" dirty="0">
+                <a:solidFill>
+                  <a:srgbClr val="F7F9FC"/>
+                </a:solidFill>
+                <a:latin typeface="Noto Sans KR" pitchFamily="34" charset="0"/>
+                <a:ea typeface="Noto Sans KR" pitchFamily="34" charset="-122"/>
+                <a:cs typeface="Noto Sans KR" pitchFamily="34" charset="-120"/>
+              </a:rPr>
+              <a:t>X9M-2 Eighth Rack</a:t>
+            </a:r>
+            <a:endParaRPr lang="en-US" sz="910" dirty="0"/>
+          </a:p>
+          <a:p>
+            <a:pPr algn="ctr" indent="0" marL="0">
+              <a:buNone/>
+            </a:pPr>
+            <a:r>
+              <a:rPr lang="en-US" sz="910" b="1" dirty="0">
+                <a:solidFill>
+                  <a:srgbClr val="F7F9FC"/>
+                </a:solidFill>
+                <a:latin typeface="Noto Sans KR" pitchFamily="34" charset="0"/>
+                <a:ea typeface="Noto Sans KR" pitchFamily="34" charset="-122"/>
+                <a:cs typeface="Noto Sans KR" pitchFamily="34" charset="-120"/>
+              </a:rPr>
+              <a:t>On-premises</a:t>
+            </a:r>
+            <a:endParaRPr lang="en-US" sz="910" dirty="0"/>
+          </a:p>
+        </p:txBody>
+      </p:sp>
+      <p:sp>
+        <p:nvSpPr>
+          <p:cNvPr id="9" name="Shape 7"/>
+          <p:cNvSpPr/>
+          <p:nvPr/>
+        </p:nvSpPr>
+        <p:spPr>
+          <a:xfrm>
+            <a:off x="5504688" y="1463040"/>
+            <a:ext cx="3008376" cy="484632"/>
+          </a:xfrm>
+          <a:prstGeom prst="rect">
+            <a:avLst/>
+          </a:prstGeom>
+          <a:solidFill>
+            <a:srgbClr val="203247"/>
+          </a:solidFill>
+          <a:ln w="8890">
+            <a:solidFill>
+              <a:srgbClr val="36465C"/>
+            </a:solidFill>
+            <a:prstDash val="solid"/>
+          </a:ln>
+        </p:spPr>
+      </p:sp>
+      <p:sp>
+        <p:nvSpPr>
+          <p:cNvPr id="10" name="Text 8"/>
+          <p:cNvSpPr/>
+          <p:nvPr/>
+        </p:nvSpPr>
+        <p:spPr>
+          <a:xfrm>
+            <a:off x="5596128" y="1517904"/>
+            <a:ext cx="2825496" cy="365760"/>
+          </a:xfrm>
+          <a:prstGeom prst="rect">
+            <a:avLst/>
+          </a:prstGeom>
+          <a:noFill/>
+          <a:ln/>
+        </p:spPr>
+        <p:txBody>
+          <a:bodyPr wrap="square" lIns="0" tIns="0" rIns="0" bIns="0" rtlCol="0" anchor="ctr">
+            <a:normAutofit/>
+          </a:bodyPr>
+          <a:lstStyle/>
+          <a:p>
+            <a:pPr algn="ctr" indent="0" marL="0">
+              <a:buNone/>
+            </a:pPr>
+            <a:r>
+              <a:rPr lang="en-US" sz="910" b="1" dirty="0">
+                <a:solidFill>
+                  <a:srgbClr val="F7F9FC"/>
+                </a:solidFill>
+                <a:latin typeface="Noto Sans KR" pitchFamily="34" charset="0"/>
+                <a:ea typeface="Noto Sans KR" pitchFamily="34" charset="-122"/>
+                <a:cs typeface="Noto Sans KR" pitchFamily="34" charset="-120"/>
+              </a:rPr>
+              <a:t>ExaC@C X11M</a:t>
+            </a:r>
+            <a:endParaRPr lang="en-US" sz="910" dirty="0"/>
+          </a:p>
+          <a:p>
+            <a:pPr algn="ctr" indent="0" marL="0">
+              <a:buNone/>
+            </a:pPr>
+            <a:r>
+              <a:rPr lang="en-US" sz="910" b="1" dirty="0">
+                <a:solidFill>
+                  <a:srgbClr val="F7F9FC"/>
+                </a:solidFill>
+                <a:latin typeface="Noto Sans KR" pitchFamily="34" charset="0"/>
+                <a:ea typeface="Noto Sans KR" pitchFamily="34" charset="-122"/>
+                <a:cs typeface="Noto Sans KR" pitchFamily="34" charset="-120"/>
+              </a:rPr>
+              <a:t>Base System</a:t>
+            </a:r>
+            <a:endParaRPr lang="en-US" sz="910" dirty="0"/>
+          </a:p>
+        </p:txBody>
+      </p:sp>
+      <p:sp>
+        <p:nvSpPr>
+          <p:cNvPr id="11" name="Shape 9"/>
+          <p:cNvSpPr/>
+          <p:nvPr/>
+        </p:nvSpPr>
+        <p:spPr>
+          <a:xfrm>
+            <a:off x="8513064" y="1463040"/>
+            <a:ext cx="3008376" cy="484632"/>
+          </a:xfrm>
+          <a:prstGeom prst="rect">
+            <a:avLst/>
+          </a:prstGeom>
+          <a:solidFill>
+            <a:srgbClr val="173A3D"/>
+          </a:solidFill>
+          <a:ln w="8890">
+            <a:solidFill>
+              <a:srgbClr val="36465C"/>
+            </a:solidFill>
+            <a:prstDash val="solid"/>
+          </a:ln>
+        </p:spPr>
+      </p:sp>
+      <p:sp>
+        <p:nvSpPr>
+          <p:cNvPr id="12" name="Text 10"/>
+          <p:cNvSpPr/>
+          <p:nvPr/>
+        </p:nvSpPr>
+        <p:spPr>
+          <a:xfrm>
+            <a:off x="8604504" y="1517904"/>
+            <a:ext cx="2825496" cy="365760"/>
+          </a:xfrm>
+          <a:prstGeom prst="rect">
+            <a:avLst/>
+          </a:prstGeom>
+          <a:noFill/>
+          <a:ln/>
+        </p:spPr>
+        <p:txBody>
+          <a:bodyPr wrap="square" lIns="0" tIns="0" rIns="0" bIns="0" rtlCol="0" anchor="ctr">
+            <a:normAutofit/>
+          </a:bodyPr>
+          <a:lstStyle/>
+          <a:p>
+            <a:pPr algn="ctr" indent="0" marL="0">
+              <a:buNone/>
+            </a:pPr>
+            <a:r>
+              <a:rPr lang="en-US" sz="910" b="1" dirty="0">
+                <a:solidFill>
+                  <a:srgbClr val="2DD4BF"/>
+                </a:solidFill>
+                <a:latin typeface="Noto Sans KR" pitchFamily="34" charset="0"/>
+                <a:ea typeface="Noto Sans KR" pitchFamily="34" charset="-122"/>
+                <a:cs typeface="Noto Sans KR" pitchFamily="34" charset="-120"/>
+              </a:rPr>
+              <a:t>ExaC@C X11M Elastic</a:t>
+            </a:r>
+            <a:endParaRPr lang="en-US" sz="910" dirty="0"/>
+          </a:p>
+          <a:p>
+            <a:pPr algn="ctr" indent="0" marL="0">
+              <a:buNone/>
+            </a:pPr>
+            <a:r>
+              <a:rPr lang="en-US" sz="910" b="1" dirty="0">
+                <a:solidFill>
+                  <a:srgbClr val="2DD4BF"/>
+                </a:solidFill>
+                <a:latin typeface="Noto Sans KR" pitchFamily="34" charset="0"/>
+                <a:ea typeface="Noto Sans KR" pitchFamily="34" charset="-122"/>
+                <a:cs typeface="Noto Sans KR" pitchFamily="34" charset="-120"/>
+              </a:rPr>
+              <a:t>2 Standard DB + 3 HC</a:t>
+            </a:r>
+            <a:endParaRPr lang="en-US" sz="910" dirty="0"/>
+          </a:p>
+        </p:txBody>
+      </p:sp>
+      <p:sp>
+        <p:nvSpPr>
+          <p:cNvPr id="13" name="Shape 11"/>
+          <p:cNvSpPr/>
+          <p:nvPr/>
+        </p:nvSpPr>
+        <p:spPr>
+          <a:xfrm>
+            <a:off x="512064" y="1947672"/>
+            <a:ext cx="1984248" cy="457200"/>
+          </a:xfrm>
+          <a:prstGeom prst="rect">
+            <a:avLst/>
+          </a:prstGeom>
+          <a:solidFill>
+            <a:srgbClr val="101925"/>
+          </a:solidFill>
+          <a:ln w="8255">
+            <a:solidFill>
+              <a:srgbClr val="33445B"/>
+            </a:solidFill>
+            <a:prstDash val="solid"/>
+          </a:ln>
+        </p:spPr>
+      </p:sp>
+      <p:sp>
+        <p:nvSpPr>
+          <p:cNvPr id="14" name="Text 12"/>
+          <p:cNvSpPr/>
+          <p:nvPr/>
+        </p:nvSpPr>
+        <p:spPr>
+          <a:xfrm>
+            <a:off x="603504" y="1979676"/>
+            <a:ext cx="1801368" cy="393192"/>
           </a:xfrm>
           <a:prstGeom prst="rect">
             <a:avLst/>
@@ -6475,7 +6724,7 @@
               <a:buNone/>
             </a:pPr>
             <a:r>
-              <a:rPr lang="en-US" sz="940" b="1" dirty="0">
+              <a:rPr lang="en-US" sz="900" b="1" dirty="0">
                 <a:solidFill>
                   <a:srgbClr val="F7F9FC"/>
                 </a:solidFill>
@@ -6483,47 +6732,245 @@
                 <a:ea typeface="Noto Sans KR" pitchFamily="34" charset="-122"/>
                 <a:cs typeface="Noto Sans KR" pitchFamily="34" charset="-120"/>
               </a:rPr>
-              <a:t>X9M Cloud Infra Quarter</a:t>
-            </a:r>
-            <a:endParaRPr lang="en-US" sz="940" dirty="0"/>
-          </a:p>
-        </p:txBody>
-      </p:sp>
-      <p:sp>
-        <p:nvSpPr>
-          <p:cNvPr id="9" name="Shape 7"/>
-          <p:cNvSpPr/>
-          <p:nvPr/>
-        </p:nvSpPr>
-        <p:spPr>
-          <a:xfrm>
-            <a:off x="6537960" y="1463040"/>
-            <a:ext cx="3703320" cy="429768"/>
-          </a:xfrm>
-          <a:prstGeom prst="rect">
-            <a:avLst/>
-          </a:prstGeom>
-          <a:solidFill>
-            <a:srgbClr val="173A3D"/>
-          </a:solidFill>
-          <a:ln w="8890">
-            <a:solidFill>
-              <a:srgbClr val="36465C"/>
-            </a:solidFill>
-            <a:prstDash val="solid"/>
-          </a:ln>
-        </p:spPr>
-      </p:sp>
-      <p:sp>
-        <p:nvSpPr>
-          <p:cNvPr id="10" name="Text 8"/>
-          <p:cNvSpPr/>
-          <p:nvPr/>
-        </p:nvSpPr>
-        <p:spPr>
-          <a:xfrm>
-            <a:off x="6629400" y="1517904"/>
-            <a:ext cx="3520440" cy="274320"/>
+              <a:t>물리 구성</a:t>
+            </a:r>
+            <a:endParaRPr lang="en-US" sz="900" dirty="0"/>
+          </a:p>
+        </p:txBody>
+      </p:sp>
+      <p:sp>
+        <p:nvSpPr>
+          <p:cNvPr id="15" name="Shape 13"/>
+          <p:cNvSpPr/>
+          <p:nvPr/>
+        </p:nvSpPr>
+        <p:spPr>
+          <a:xfrm>
+            <a:off x="2496312" y="1947672"/>
+            <a:ext cx="3008376" cy="457200"/>
+          </a:xfrm>
+          <a:prstGeom prst="rect">
+            <a:avLst/>
+          </a:prstGeom>
+          <a:solidFill>
+            <a:srgbClr val="101925"/>
+          </a:solidFill>
+          <a:ln w="8255">
+            <a:solidFill>
+              <a:srgbClr val="33445B"/>
+            </a:solidFill>
+            <a:prstDash val="solid"/>
+          </a:ln>
+        </p:spPr>
+      </p:sp>
+      <p:sp>
+        <p:nvSpPr>
+          <p:cNvPr id="16" name="Text 14"/>
+          <p:cNvSpPr/>
+          <p:nvPr/>
+        </p:nvSpPr>
+        <p:spPr>
+          <a:xfrm>
+            <a:off x="2587752" y="1979676"/>
+            <a:ext cx="2825496" cy="393192"/>
+          </a:xfrm>
+          <a:prstGeom prst="rect">
+            <a:avLst/>
+          </a:prstGeom>
+          <a:noFill/>
+          <a:ln/>
+        </p:spPr>
+        <p:txBody>
+          <a:bodyPr wrap="square" lIns="0" tIns="0" rIns="0" bIns="0" rtlCol="0" anchor="ctr">
+            <a:normAutofit/>
+          </a:bodyPr>
+          <a:lstStyle/>
+          <a:p>
+            <a:pPr algn="ctr" indent="0" marL="0">
+              <a:buNone/>
+            </a:pPr>
+            <a:r>
+              <a:rPr lang="en-US" sz="890" dirty="0">
+                <a:solidFill>
+                  <a:srgbClr val="D9E1EC"/>
+                </a:solidFill>
+                <a:latin typeface="Noto Sans KR" pitchFamily="34" charset="0"/>
+                <a:ea typeface="Noto Sans KR" pitchFamily="34" charset="-122"/>
+                <a:cs typeface="Noto Sans KR" pitchFamily="34" charset="-120"/>
+              </a:rPr>
+              <a:t>2 DB + 3 Eighth HC</a:t>
+            </a:r>
+            <a:endParaRPr lang="en-US" sz="890" dirty="0"/>
+          </a:p>
+        </p:txBody>
+      </p:sp>
+      <p:sp>
+        <p:nvSpPr>
+          <p:cNvPr id="17" name="Shape 15"/>
+          <p:cNvSpPr/>
+          <p:nvPr/>
+        </p:nvSpPr>
+        <p:spPr>
+          <a:xfrm>
+            <a:off x="5504688" y="1947672"/>
+            <a:ext cx="3008376" cy="457200"/>
+          </a:xfrm>
+          <a:prstGeom prst="rect">
+            <a:avLst/>
+          </a:prstGeom>
+          <a:solidFill>
+            <a:srgbClr val="101925"/>
+          </a:solidFill>
+          <a:ln w="8255">
+            <a:solidFill>
+              <a:srgbClr val="33445B"/>
+            </a:solidFill>
+            <a:prstDash val="solid"/>
+          </a:ln>
+        </p:spPr>
+      </p:sp>
+      <p:sp>
+        <p:nvSpPr>
+          <p:cNvPr id="18" name="Text 16"/>
+          <p:cNvSpPr/>
+          <p:nvPr/>
+        </p:nvSpPr>
+        <p:spPr>
+          <a:xfrm>
+            <a:off x="5596128" y="1979676"/>
+            <a:ext cx="2825496" cy="393192"/>
+          </a:xfrm>
+          <a:prstGeom prst="rect">
+            <a:avLst/>
+          </a:prstGeom>
+          <a:noFill/>
+          <a:ln/>
+        </p:spPr>
+        <p:txBody>
+          <a:bodyPr wrap="square" lIns="0" tIns="0" rIns="0" bIns="0" rtlCol="0" anchor="ctr">
+            <a:normAutofit/>
+          </a:bodyPr>
+          <a:lstStyle/>
+          <a:p>
+            <a:pPr algn="ctr" indent="0" marL="0">
+              <a:buNone/>
+            </a:pPr>
+            <a:r>
+              <a:rPr lang="en-US" sz="890" dirty="0">
+                <a:solidFill>
+                  <a:srgbClr val="D9E1EC"/>
+                </a:solidFill>
+                <a:latin typeface="Noto Sans KR" pitchFamily="34" charset="0"/>
+                <a:ea typeface="Noto Sans KR" pitchFamily="34" charset="-122"/>
+                <a:cs typeface="Noto Sans KR" pitchFamily="34" charset="-120"/>
+              </a:rPr>
+              <a:t>2 Base DB + 3 Base Storage</a:t>
+            </a:r>
+            <a:endParaRPr lang="en-US" sz="890" dirty="0"/>
+          </a:p>
+        </p:txBody>
+      </p:sp>
+      <p:sp>
+        <p:nvSpPr>
+          <p:cNvPr id="19" name="Shape 17"/>
+          <p:cNvSpPr/>
+          <p:nvPr/>
+        </p:nvSpPr>
+        <p:spPr>
+          <a:xfrm>
+            <a:off x="8513064" y="1947672"/>
+            <a:ext cx="3008376" cy="457200"/>
+          </a:xfrm>
+          <a:prstGeom prst="rect">
+            <a:avLst/>
+          </a:prstGeom>
+          <a:solidFill>
+            <a:srgbClr val="101925"/>
+          </a:solidFill>
+          <a:ln w="8255">
+            <a:solidFill>
+              <a:srgbClr val="33445B"/>
+            </a:solidFill>
+            <a:prstDash val="solid"/>
+          </a:ln>
+        </p:spPr>
+      </p:sp>
+      <p:sp>
+        <p:nvSpPr>
+          <p:cNvPr id="20" name="Text 18"/>
+          <p:cNvSpPr/>
+          <p:nvPr/>
+        </p:nvSpPr>
+        <p:spPr>
+          <a:xfrm>
+            <a:off x="8604504" y="1979676"/>
+            <a:ext cx="2825496" cy="393192"/>
+          </a:xfrm>
+          <a:prstGeom prst="rect">
+            <a:avLst/>
+          </a:prstGeom>
+          <a:noFill/>
+          <a:ln/>
+        </p:spPr>
+        <p:txBody>
+          <a:bodyPr wrap="square" lIns="0" tIns="0" rIns="0" bIns="0" rtlCol="0" anchor="ctr">
+            <a:normAutofit/>
+          </a:bodyPr>
+          <a:lstStyle/>
+          <a:p>
+            <a:pPr algn="ctr" indent="0" marL="0">
+              <a:buNone/>
+            </a:pPr>
+            <a:r>
+              <a:rPr lang="en-US" sz="890" dirty="0">
+                <a:solidFill>
+                  <a:srgbClr val="2DD4BF"/>
+                </a:solidFill>
+                <a:latin typeface="Noto Sans KR" pitchFamily="34" charset="0"/>
+                <a:ea typeface="Noto Sans KR" pitchFamily="34" charset="-122"/>
+                <a:cs typeface="Noto Sans KR" pitchFamily="34" charset="-120"/>
+              </a:rPr>
+              <a:t>2 Standard DB + 3 HC w/XRMEM</a:t>
+            </a:r>
+            <a:endParaRPr lang="en-US" sz="890" dirty="0"/>
+          </a:p>
+        </p:txBody>
+      </p:sp>
+      <p:sp>
+        <p:nvSpPr>
+          <p:cNvPr id="21" name="Shape 19"/>
+          <p:cNvSpPr/>
+          <p:nvPr/>
+        </p:nvSpPr>
+        <p:spPr>
+          <a:xfrm>
+            <a:off x="512064" y="2404872"/>
+            <a:ext cx="1984248" cy="457200"/>
+          </a:xfrm>
+          <a:prstGeom prst="rect">
+            <a:avLst/>
+          </a:prstGeom>
+          <a:solidFill>
+            <a:srgbClr val="0D1621"/>
+          </a:solidFill>
+          <a:ln w="8255">
+            <a:solidFill>
+              <a:srgbClr val="33445B"/>
+            </a:solidFill>
+            <a:prstDash val="solid"/>
+          </a:ln>
+        </p:spPr>
+      </p:sp>
+      <p:sp>
+        <p:nvSpPr>
+          <p:cNvPr id="22" name="Text 20"/>
+          <p:cNvSpPr/>
+          <p:nvPr/>
+        </p:nvSpPr>
+        <p:spPr>
+          <a:xfrm>
+            <a:off x="603504" y="2436876"/>
+            <a:ext cx="1801368" cy="393192"/>
           </a:xfrm>
           <a:prstGeom prst="rect">
             <a:avLst/>
@@ -6541,7 +6988,222 @@
               <a:buNone/>
             </a:pPr>
             <a:r>
-              <a:rPr lang="en-US" sz="940" b="1" dirty="0">
+              <a:rPr lang="en-US" sz="900" b="1" dirty="0">
+                <a:solidFill>
+                  <a:srgbClr val="F7F9FC"/>
+                </a:solidFill>
+                <a:latin typeface="Noto Sans KR" pitchFamily="34" charset="0"/>
+                <a:ea typeface="Noto Sans KR" pitchFamily="34" charset="-122"/>
+                <a:cs typeface="Noto Sans KR" pitchFamily="34" charset="-120"/>
+              </a:rPr>
+              <a:t>DB compute</a:t>
+            </a:r>
+            <a:endParaRPr lang="en-US" sz="900" dirty="0"/>
+          </a:p>
+        </p:txBody>
+      </p:sp>
+      <p:sp>
+        <p:nvSpPr>
+          <p:cNvPr id="23" name="Shape 21"/>
+          <p:cNvSpPr/>
+          <p:nvPr/>
+        </p:nvSpPr>
+        <p:spPr>
+          <a:xfrm>
+            <a:off x="2496312" y="2404872"/>
+            <a:ext cx="3008376" cy="457200"/>
+          </a:xfrm>
+          <a:prstGeom prst="rect">
+            <a:avLst/>
+          </a:prstGeom>
+          <a:solidFill>
+            <a:srgbClr val="0D1621"/>
+          </a:solidFill>
+          <a:ln w="8255">
+            <a:solidFill>
+              <a:srgbClr val="33445B"/>
+            </a:solidFill>
+            <a:prstDash val="solid"/>
+          </a:ln>
+        </p:spPr>
+      </p:sp>
+      <p:sp>
+        <p:nvSpPr>
+          <p:cNvPr id="24" name="Text 22"/>
+          <p:cNvSpPr/>
+          <p:nvPr/>
+        </p:nvSpPr>
+        <p:spPr>
+          <a:xfrm>
+            <a:off x="2587752" y="2436876"/>
+            <a:ext cx="2825496" cy="393192"/>
+          </a:xfrm>
+          <a:prstGeom prst="rect">
+            <a:avLst/>
+          </a:prstGeom>
+          <a:noFill/>
+          <a:ln/>
+        </p:spPr>
+        <p:txBody>
+          <a:bodyPr wrap="square" lIns="0" tIns="0" rIns="0" bIns="0" rtlCol="0" anchor="ctr">
+            <a:normAutofit/>
+          </a:bodyPr>
+          <a:lstStyle/>
+          <a:p>
+            <a:pPr algn="ctr" indent="0" marL="0">
+              <a:buNone/>
+            </a:pPr>
+            <a:r>
+              <a:rPr lang="en-US" sz="890" dirty="0">
+                <a:solidFill>
+                  <a:srgbClr val="D9E1EC"/>
+                </a:solidFill>
+                <a:latin typeface="Noto Sans KR" pitchFamily="34" charset="0"/>
+                <a:ea typeface="Noto Sans KR" pitchFamily="34" charset="-122"/>
+                <a:cs typeface="Noto Sans KR" pitchFamily="34" charset="-120"/>
+              </a:rPr>
+              <a:t>64 physical cores</a:t>
+            </a:r>
+            <a:endParaRPr lang="en-US" sz="890" dirty="0"/>
+          </a:p>
+        </p:txBody>
+      </p:sp>
+      <p:sp>
+        <p:nvSpPr>
+          <p:cNvPr id="25" name="Shape 23"/>
+          <p:cNvSpPr/>
+          <p:nvPr/>
+        </p:nvSpPr>
+        <p:spPr>
+          <a:xfrm>
+            <a:off x="5504688" y="2404872"/>
+            <a:ext cx="3008376" cy="457200"/>
+          </a:xfrm>
+          <a:prstGeom prst="rect">
+            <a:avLst/>
+          </a:prstGeom>
+          <a:solidFill>
+            <a:srgbClr val="0D1621"/>
+          </a:solidFill>
+          <a:ln w="8255">
+            <a:solidFill>
+              <a:srgbClr val="33445B"/>
+            </a:solidFill>
+            <a:prstDash val="solid"/>
+          </a:ln>
+        </p:spPr>
+      </p:sp>
+      <p:sp>
+        <p:nvSpPr>
+          <p:cNvPr id="26" name="Text 24"/>
+          <p:cNvSpPr/>
+          <p:nvPr/>
+        </p:nvSpPr>
+        <p:spPr>
+          <a:xfrm>
+            <a:off x="5596128" y="2436876"/>
+            <a:ext cx="2825496" cy="393192"/>
+          </a:xfrm>
+          <a:prstGeom prst="rect">
+            <a:avLst/>
+          </a:prstGeom>
+          <a:noFill/>
+          <a:ln/>
+        </p:spPr>
+        <p:txBody>
+          <a:bodyPr wrap="square" lIns="0" tIns="0" rIns="0" bIns="0" rtlCol="0" anchor="ctr">
+            <a:normAutofit/>
+          </a:bodyPr>
+          <a:lstStyle/>
+          <a:p>
+            <a:pPr algn="ctr" indent="0" marL="0">
+              <a:buNone/>
+            </a:pPr>
+            <a:r>
+              <a:rPr lang="en-US" sz="890" dirty="0">
+                <a:solidFill>
+                  <a:srgbClr val="D9E1EC"/>
+                </a:solidFill>
+                <a:latin typeface="Noto Sans KR" pitchFamily="34" charset="0"/>
+                <a:ea typeface="Noto Sans KR" pitchFamily="34" charset="-122"/>
+                <a:cs typeface="Noto Sans KR" pitchFamily="34" charset="-120"/>
+              </a:rPr>
+              <a:t>60 usable cores</a:t>
+            </a:r>
+            <a:endParaRPr lang="en-US" sz="890" dirty="0"/>
+          </a:p>
+          <a:p>
+            <a:pPr algn="ctr" indent="0" marL="0">
+              <a:buNone/>
+            </a:pPr>
+            <a:r>
+              <a:rPr lang="en-US" sz="890" dirty="0">
+                <a:solidFill>
+                  <a:srgbClr val="D9E1EC"/>
+                </a:solidFill>
+                <a:latin typeface="Noto Sans KR" pitchFamily="34" charset="0"/>
+                <a:ea typeface="Noto Sans KR" pitchFamily="34" charset="-122"/>
+                <a:cs typeface="Noto Sans KR" pitchFamily="34" charset="-120"/>
+              </a:rPr>
+              <a:t>240 ECPUs</a:t>
+            </a:r>
+            <a:endParaRPr lang="en-US" sz="890" dirty="0"/>
+          </a:p>
+        </p:txBody>
+      </p:sp>
+      <p:sp>
+        <p:nvSpPr>
+          <p:cNvPr id="27" name="Shape 25"/>
+          <p:cNvSpPr/>
+          <p:nvPr/>
+        </p:nvSpPr>
+        <p:spPr>
+          <a:xfrm>
+            <a:off x="8513064" y="2404872"/>
+            <a:ext cx="3008376" cy="457200"/>
+          </a:xfrm>
+          <a:prstGeom prst="rect">
+            <a:avLst/>
+          </a:prstGeom>
+          <a:solidFill>
+            <a:srgbClr val="0D1621"/>
+          </a:solidFill>
+          <a:ln w="8255">
+            <a:solidFill>
+              <a:srgbClr val="33445B"/>
+            </a:solidFill>
+            <a:prstDash val="solid"/>
+          </a:ln>
+        </p:spPr>
+      </p:sp>
+      <p:sp>
+        <p:nvSpPr>
+          <p:cNvPr id="28" name="Text 26"/>
+          <p:cNvSpPr/>
+          <p:nvPr/>
+        </p:nvSpPr>
+        <p:spPr>
+          <a:xfrm>
+            <a:off x="8604504" y="2436876"/>
+            <a:ext cx="2825496" cy="393192"/>
+          </a:xfrm>
+          <a:prstGeom prst="rect">
+            <a:avLst/>
+          </a:prstGeom>
+          <a:noFill/>
+          <a:ln/>
+        </p:spPr>
+        <p:txBody>
+          <a:bodyPr wrap="square" lIns="0" tIns="0" rIns="0" bIns="0" rtlCol="0" anchor="ctr">
+            <a:normAutofit/>
+          </a:bodyPr>
+          <a:lstStyle/>
+          <a:p>
+            <a:pPr algn="ctr" indent="0" marL="0">
+              <a:buNone/>
+            </a:pPr>
+            <a:r>
+              <a:rPr lang="en-US" sz="890" dirty="0">
                 <a:solidFill>
                   <a:srgbClr val="2DD4BF"/>
                 </a:solidFill>
@@ -6549,65 +7211,82 @@
                 <a:ea typeface="Noto Sans KR" pitchFamily="34" charset="-122"/>
                 <a:cs typeface="Noto Sans KR" pitchFamily="34" charset="-120"/>
               </a:rPr>
-              <a:t>ExaCC X11M 2+3 Elastic</a:t>
-            </a:r>
-            <a:endParaRPr lang="en-US" sz="940" dirty="0"/>
-          </a:p>
-        </p:txBody>
-      </p:sp>
-      <p:sp>
-        <p:nvSpPr>
-          <p:cNvPr id="11" name="Shape 9"/>
-          <p:cNvSpPr/>
-          <p:nvPr/>
-        </p:nvSpPr>
-        <p:spPr>
-          <a:xfrm>
-            <a:off x="10241280" y="1463040"/>
-            <a:ext cx="1261872" cy="429768"/>
-          </a:xfrm>
-          <a:prstGeom prst="rect">
-            <a:avLst/>
-          </a:prstGeom>
-          <a:solidFill>
-            <a:srgbClr val="182331"/>
-          </a:solidFill>
-          <a:ln w="8890">
-            <a:solidFill>
-              <a:srgbClr val="36465C"/>
-            </a:solidFill>
-            <a:prstDash val="solid"/>
-          </a:ln>
-        </p:spPr>
-      </p:sp>
-      <p:sp>
-        <p:nvSpPr>
-          <p:cNvPr id="12" name="Text 10"/>
-          <p:cNvSpPr/>
-          <p:nvPr/>
-        </p:nvSpPr>
-        <p:spPr>
-          <a:xfrm>
-            <a:off x="10332720" y="1517904"/>
-            <a:ext cx="1078992" cy="274320"/>
-          </a:xfrm>
-          <a:prstGeom prst="rect">
-            <a:avLst/>
-          </a:prstGeom>
-          <a:noFill/>
-          <a:ln/>
-        </p:spPr>
-        <p:txBody>
-          <a:bodyPr wrap="square" lIns="0" tIns="0" rIns="0" bIns="0" rtlCol="0" anchor="ctr">
-            <a:normAutofit/>
-          </a:bodyPr>
-          <a:lstStyle/>
+              <a:t>380 usable cores</a:t>
+            </a:r>
+            <a:endParaRPr lang="en-US" sz="890" dirty="0"/>
+          </a:p>
           <a:p>
             <a:pPr algn="ctr" indent="0" marL="0">
               <a:buNone/>
             </a:pPr>
             <a:r>
-              <a:rPr lang="en-US" sz="940" b="1" dirty="0">
+              <a:rPr lang="en-US" sz="890" dirty="0">
+                <a:solidFill>
+                  <a:srgbClr val="2DD4BF"/>
+                </a:solidFill>
+                <a:latin typeface="Noto Sans KR" pitchFamily="34" charset="0"/>
+                <a:ea typeface="Noto Sans KR" pitchFamily="34" charset="-122"/>
+                <a:cs typeface="Noto Sans KR" pitchFamily="34" charset="-120"/>
+              </a:rPr>
+              <a:t>1,520 ECPUs</a:t>
+            </a:r>
+            <a:endParaRPr lang="en-US" sz="890" dirty="0"/>
+          </a:p>
+        </p:txBody>
+      </p:sp>
+      <p:sp>
+        <p:nvSpPr>
+          <p:cNvPr id="29" name="Shape 27"/>
+          <p:cNvSpPr/>
+          <p:nvPr/>
+        </p:nvSpPr>
+        <p:spPr>
+          <a:xfrm>
+            <a:off x="512064" y="2862072"/>
+            <a:ext cx="1984248" cy="457200"/>
+          </a:xfrm>
+          <a:prstGeom prst="rect">
+            <a:avLst/>
+          </a:prstGeom>
+          <a:solidFill>
+            <a:srgbClr val="101925"/>
+          </a:solidFill>
+          <a:ln w="8255">
+            <a:solidFill>
+              <a:srgbClr val="33445B"/>
+            </a:solidFill>
+            <a:prstDash val="solid"/>
+          </a:ln>
+        </p:spPr>
+      </p:sp>
+      <p:sp>
+        <p:nvSpPr>
+          <p:cNvPr id="30" name="Text 28"/>
+          <p:cNvSpPr/>
+          <p:nvPr/>
+        </p:nvSpPr>
+        <p:spPr>
+          <a:xfrm>
+            <a:off x="603504" y="2894076"/>
+            <a:ext cx="1801368" cy="393192"/>
+          </a:xfrm>
+          <a:prstGeom prst="rect">
+            <a:avLst/>
+          </a:prstGeom>
+          <a:noFill/>
+          <a:ln/>
+        </p:spPr>
+        <p:txBody>
+          <a:bodyPr wrap="square" lIns="0" tIns="0" rIns="0" bIns="0" rtlCol="0" anchor="ctr">
+            <a:normAutofit/>
+          </a:bodyPr>
+          <a:lstStyle/>
+          <a:p>
+            <a:pPr algn="l" indent="0" marL="0">
+              <a:buNone/>
+            </a:pPr>
+            <a:r>
+              <a:rPr lang="en-US" sz="900" b="1" dirty="0">
                 <a:solidFill>
                   <a:srgbClr val="F7F9FC"/>
                 </a:solidFill>
@@ -6615,22 +7294,22 @@
                 <a:ea typeface="Noto Sans KR" pitchFamily="34" charset="-122"/>
                 <a:cs typeface="Noto Sans KR" pitchFamily="34" charset="-120"/>
               </a:rPr>
-              <a:t>변화</a:t>
-            </a:r>
-            <a:endParaRPr lang="en-US" sz="940" dirty="0"/>
-          </a:p>
-        </p:txBody>
-      </p:sp>
-      <p:sp>
-        <p:nvSpPr>
-          <p:cNvPr id="13" name="Shape 11"/>
-          <p:cNvSpPr/>
-          <p:nvPr/>
-        </p:nvSpPr>
-        <p:spPr>
-          <a:xfrm>
-            <a:off x="512064" y="1892808"/>
-            <a:ext cx="2322576" cy="539496"/>
+              <a:t>DB memory</a:t>
+            </a:r>
+            <a:endParaRPr lang="en-US" sz="900" dirty="0"/>
+          </a:p>
+        </p:txBody>
+      </p:sp>
+      <p:sp>
+        <p:nvSpPr>
+          <p:cNvPr id="31" name="Shape 29"/>
+          <p:cNvSpPr/>
+          <p:nvPr/>
+        </p:nvSpPr>
+        <p:spPr>
+          <a:xfrm>
+            <a:off x="2496312" y="2862072"/>
+            <a:ext cx="3008376" cy="457200"/>
           </a:xfrm>
           <a:prstGeom prst="rect">
             <a:avLst/>
@@ -6648,14 +7327,263 @@
       </p:sp>
       <p:sp>
         <p:nvSpPr>
-          <p:cNvPr id="14" name="Text 12"/>
-          <p:cNvSpPr/>
-          <p:nvPr/>
-        </p:nvSpPr>
-        <p:spPr>
-          <a:xfrm>
-            <a:off x="612648" y="1938528"/>
-            <a:ext cx="2121408" cy="438912"/>
+          <p:cNvPr id="32" name="Text 30"/>
+          <p:cNvSpPr/>
+          <p:nvPr/>
+        </p:nvSpPr>
+        <p:spPr>
+          <a:xfrm>
+            <a:off x="2587752" y="2894076"/>
+            <a:ext cx="2825496" cy="393192"/>
+          </a:xfrm>
+          <a:prstGeom prst="rect">
+            <a:avLst/>
+          </a:prstGeom>
+          <a:noFill/>
+          <a:ln/>
+        </p:spPr>
+        <p:txBody>
+          <a:bodyPr wrap="square" lIns="0" tIns="0" rIns="0" bIns="0" rtlCol="0" anchor="ctr">
+            <a:normAutofit/>
+          </a:bodyPr>
+          <a:lstStyle/>
+          <a:p>
+            <a:pPr algn="ctr" indent="0" marL="0">
+              <a:buNone/>
+            </a:pPr>
+            <a:r>
+              <a:rPr lang="en-US" sz="890" dirty="0">
+                <a:solidFill>
+                  <a:srgbClr val="D9E1EC"/>
+                </a:solidFill>
+                <a:latin typeface="Noto Sans KR" pitchFamily="34" charset="0"/>
+                <a:ea typeface="Noto Sans KR" pitchFamily="34" charset="-122"/>
+                <a:cs typeface="Noto Sans KR" pitchFamily="34" charset="-120"/>
+              </a:rPr>
+              <a:t>768 GB default</a:t>
+            </a:r>
+            <a:endParaRPr lang="en-US" sz="890" dirty="0"/>
+          </a:p>
+          <a:p>
+            <a:pPr algn="ctr" indent="0" marL="0">
+              <a:buNone/>
+            </a:pPr>
+            <a:r>
+              <a:rPr lang="en-US" sz="890" dirty="0">
+                <a:solidFill>
+                  <a:srgbClr val="D9E1EC"/>
+                </a:solidFill>
+                <a:latin typeface="Noto Sans KR" pitchFamily="34" charset="0"/>
+                <a:ea typeface="Noto Sans KR" pitchFamily="34" charset="-122"/>
+                <a:cs typeface="Noto Sans KR" pitchFamily="34" charset="-120"/>
+              </a:rPr>
+              <a:t>최대 2,048 GB</a:t>
+            </a:r>
+            <a:endParaRPr lang="en-US" sz="890" dirty="0"/>
+          </a:p>
+        </p:txBody>
+      </p:sp>
+      <p:sp>
+        <p:nvSpPr>
+          <p:cNvPr id="33" name="Shape 31"/>
+          <p:cNvSpPr/>
+          <p:nvPr/>
+        </p:nvSpPr>
+        <p:spPr>
+          <a:xfrm>
+            <a:off x="5504688" y="2862072"/>
+            <a:ext cx="3008376" cy="457200"/>
+          </a:xfrm>
+          <a:prstGeom prst="rect">
+            <a:avLst/>
+          </a:prstGeom>
+          <a:solidFill>
+            <a:srgbClr val="101925"/>
+          </a:solidFill>
+          <a:ln w="8255">
+            <a:solidFill>
+              <a:srgbClr val="33445B"/>
+            </a:solidFill>
+            <a:prstDash val="solid"/>
+          </a:ln>
+        </p:spPr>
+      </p:sp>
+      <p:sp>
+        <p:nvSpPr>
+          <p:cNvPr id="34" name="Text 32"/>
+          <p:cNvSpPr/>
+          <p:nvPr/>
+        </p:nvSpPr>
+        <p:spPr>
+          <a:xfrm>
+            <a:off x="5596128" y="2894076"/>
+            <a:ext cx="2825496" cy="393192"/>
+          </a:xfrm>
+          <a:prstGeom prst="rect">
+            <a:avLst/>
+          </a:prstGeom>
+          <a:noFill/>
+          <a:ln/>
+        </p:spPr>
+        <p:txBody>
+          <a:bodyPr wrap="square" lIns="0" tIns="0" rIns="0" bIns="0" rtlCol="0" anchor="ctr">
+            <a:normAutofit/>
+          </a:bodyPr>
+          <a:lstStyle/>
+          <a:p>
+            <a:pPr algn="ctr" indent="0" marL="0">
+              <a:buNone/>
+            </a:pPr>
+            <a:r>
+              <a:rPr lang="en-US" sz="890" dirty="0">
+                <a:solidFill>
+                  <a:srgbClr val="D9E1EC"/>
+                </a:solidFill>
+                <a:latin typeface="Noto Sans KR" pitchFamily="34" charset="0"/>
+                <a:ea typeface="Noto Sans KR" pitchFamily="34" charset="-122"/>
+                <a:cs typeface="Noto Sans KR" pitchFamily="34" charset="-120"/>
+              </a:rPr>
+              <a:t>1,320 GB</a:t>
+            </a:r>
+            <a:endParaRPr lang="en-US" sz="890" dirty="0"/>
+          </a:p>
+          <a:p>
+            <a:pPr algn="ctr" indent="0" marL="0">
+              <a:buNone/>
+            </a:pPr>
+            <a:r>
+              <a:rPr lang="en-US" sz="890" dirty="0">
+                <a:solidFill>
+                  <a:srgbClr val="D9E1EC"/>
+                </a:solidFill>
+                <a:latin typeface="Noto Sans KR" pitchFamily="34" charset="0"/>
+                <a:ea typeface="Noto Sans KR" pitchFamily="34" charset="-122"/>
+                <a:cs typeface="Noto Sans KR" pitchFamily="34" charset="-120"/>
+              </a:rPr>
+              <a:t>available to VMs</a:t>
+            </a:r>
+            <a:endParaRPr lang="en-US" sz="890" dirty="0"/>
+          </a:p>
+        </p:txBody>
+      </p:sp>
+      <p:sp>
+        <p:nvSpPr>
+          <p:cNvPr id="35" name="Shape 33"/>
+          <p:cNvSpPr/>
+          <p:nvPr/>
+        </p:nvSpPr>
+        <p:spPr>
+          <a:xfrm>
+            <a:off x="8513064" y="2862072"/>
+            <a:ext cx="3008376" cy="457200"/>
+          </a:xfrm>
+          <a:prstGeom prst="rect">
+            <a:avLst/>
+          </a:prstGeom>
+          <a:solidFill>
+            <a:srgbClr val="101925"/>
+          </a:solidFill>
+          <a:ln w="8255">
+            <a:solidFill>
+              <a:srgbClr val="33445B"/>
+            </a:solidFill>
+            <a:prstDash val="solid"/>
+          </a:ln>
+        </p:spPr>
+      </p:sp>
+      <p:sp>
+        <p:nvSpPr>
+          <p:cNvPr id="36" name="Text 34"/>
+          <p:cNvSpPr/>
+          <p:nvPr/>
+        </p:nvSpPr>
+        <p:spPr>
+          <a:xfrm>
+            <a:off x="8604504" y="2894076"/>
+            <a:ext cx="2825496" cy="393192"/>
+          </a:xfrm>
+          <a:prstGeom prst="rect">
+            <a:avLst/>
+          </a:prstGeom>
+          <a:noFill/>
+          <a:ln/>
+        </p:spPr>
+        <p:txBody>
+          <a:bodyPr wrap="square" lIns="0" tIns="0" rIns="0" bIns="0" rtlCol="0" anchor="ctr">
+            <a:normAutofit/>
+          </a:bodyPr>
+          <a:lstStyle/>
+          <a:p>
+            <a:pPr algn="ctr" indent="0" marL="0">
+              <a:buNone/>
+            </a:pPr>
+            <a:r>
+              <a:rPr lang="en-US" sz="890" dirty="0">
+                <a:solidFill>
+                  <a:srgbClr val="2DD4BF"/>
+                </a:solidFill>
+                <a:latin typeface="Noto Sans KR" pitchFamily="34" charset="0"/>
+                <a:ea typeface="Noto Sans KR" pitchFamily="34" charset="-122"/>
+                <a:cs typeface="Noto Sans KR" pitchFamily="34" charset="-120"/>
+              </a:rPr>
+              <a:t>2,780 GB</a:t>
+            </a:r>
+            <a:endParaRPr lang="en-US" sz="890" dirty="0"/>
+          </a:p>
+          <a:p>
+            <a:pPr algn="ctr" indent="0" marL="0">
+              <a:buNone/>
+            </a:pPr>
+            <a:r>
+              <a:rPr lang="en-US" sz="890" dirty="0">
+                <a:solidFill>
+                  <a:srgbClr val="2DD4BF"/>
+                </a:solidFill>
+                <a:latin typeface="Noto Sans KR" pitchFamily="34" charset="0"/>
+                <a:ea typeface="Noto Sans KR" pitchFamily="34" charset="-122"/>
+                <a:cs typeface="Noto Sans KR" pitchFamily="34" charset="-120"/>
+              </a:rPr>
+              <a:t>available to VMs</a:t>
+            </a:r>
+            <a:endParaRPr lang="en-US" sz="890" dirty="0"/>
+          </a:p>
+        </p:txBody>
+      </p:sp>
+      <p:sp>
+        <p:nvSpPr>
+          <p:cNvPr id="37" name="Shape 35"/>
+          <p:cNvSpPr/>
+          <p:nvPr/>
+        </p:nvSpPr>
+        <p:spPr>
+          <a:xfrm>
+            <a:off x="512064" y="3319272"/>
+            <a:ext cx="1984248" cy="457200"/>
+          </a:xfrm>
+          <a:prstGeom prst="rect">
+            <a:avLst/>
+          </a:prstGeom>
+          <a:solidFill>
+            <a:srgbClr val="0D1621"/>
+          </a:solidFill>
+          <a:ln w="8255">
+            <a:solidFill>
+              <a:srgbClr val="33445B"/>
+            </a:solidFill>
+            <a:prstDash val="solid"/>
+          </a:ln>
+        </p:spPr>
+      </p:sp>
+      <p:sp>
+        <p:nvSpPr>
+          <p:cNvPr id="38" name="Text 36"/>
+          <p:cNvSpPr/>
+          <p:nvPr/>
+        </p:nvSpPr>
+        <p:spPr>
+          <a:xfrm>
+            <a:off x="603504" y="3351276"/>
+            <a:ext cx="1801368" cy="393192"/>
           </a:xfrm>
           <a:prstGeom prst="rect">
             <a:avLst/>
@@ -6673,7 +7601,7 @@
               <a:buNone/>
             </a:pPr>
             <a:r>
-              <a:rPr lang="en-US" sz="960" b="1" dirty="0">
+              <a:rPr lang="en-US" sz="900" b="1" dirty="0">
                 <a:solidFill>
                   <a:srgbClr val="F7F9FC"/>
                 </a:solidFill>
@@ -6681,22 +7609,220 @@
                 <a:ea typeface="Noto Sans KR" pitchFamily="34" charset="-122"/>
                 <a:cs typeface="Noto Sans KR" pitchFamily="34" charset="-120"/>
               </a:rPr>
-              <a:t>물리 구성</a:t>
-            </a:r>
-            <a:endParaRPr lang="en-US" sz="960" dirty="0"/>
-          </a:p>
-        </p:txBody>
-      </p:sp>
-      <p:sp>
-        <p:nvSpPr>
-          <p:cNvPr id="15" name="Shape 13"/>
-          <p:cNvSpPr/>
-          <p:nvPr/>
-        </p:nvSpPr>
-        <p:spPr>
-          <a:xfrm>
-            <a:off x="2834640" y="1892808"/>
-            <a:ext cx="3703320" cy="539496"/>
+              <a:t>Storage compute</a:t>
+            </a:r>
+            <a:endParaRPr lang="en-US" sz="900" dirty="0"/>
+          </a:p>
+        </p:txBody>
+      </p:sp>
+      <p:sp>
+        <p:nvSpPr>
+          <p:cNvPr id="39" name="Shape 37"/>
+          <p:cNvSpPr/>
+          <p:nvPr/>
+        </p:nvSpPr>
+        <p:spPr>
+          <a:xfrm>
+            <a:off x="2496312" y="3319272"/>
+            <a:ext cx="3008376" cy="457200"/>
+          </a:xfrm>
+          <a:prstGeom prst="rect">
+            <a:avLst/>
+          </a:prstGeom>
+          <a:solidFill>
+            <a:srgbClr val="0D1621"/>
+          </a:solidFill>
+          <a:ln w="8255">
+            <a:solidFill>
+              <a:srgbClr val="33445B"/>
+            </a:solidFill>
+            <a:prstDash val="solid"/>
+          </a:ln>
+        </p:spPr>
+      </p:sp>
+      <p:sp>
+        <p:nvSpPr>
+          <p:cNvPr id="40" name="Text 38"/>
+          <p:cNvSpPr/>
+          <p:nvPr/>
+        </p:nvSpPr>
+        <p:spPr>
+          <a:xfrm>
+            <a:off x="2587752" y="3351276"/>
+            <a:ext cx="2825496" cy="393192"/>
+          </a:xfrm>
+          <a:prstGeom prst="rect">
+            <a:avLst/>
+          </a:prstGeom>
+          <a:noFill/>
+          <a:ln/>
+        </p:spPr>
+        <p:txBody>
+          <a:bodyPr wrap="square" lIns="0" tIns="0" rIns="0" bIns="0" rtlCol="0" anchor="ctr">
+            <a:normAutofit/>
+          </a:bodyPr>
+          <a:lstStyle/>
+          <a:p>
+            <a:pPr algn="ctr" indent="0" marL="0">
+              <a:buNone/>
+            </a:pPr>
+            <a:r>
+              <a:rPr lang="en-US" sz="890" dirty="0">
+                <a:solidFill>
+                  <a:srgbClr val="D9E1EC"/>
+                </a:solidFill>
+                <a:latin typeface="Noto Sans KR" pitchFamily="34" charset="0"/>
+                <a:ea typeface="Noto Sans KR" pitchFamily="34" charset="-122"/>
+                <a:cs typeface="Noto Sans KR" pitchFamily="34" charset="-120"/>
+              </a:rPr>
+              <a:t>48 storage cores</a:t>
+            </a:r>
+            <a:endParaRPr lang="en-US" sz="890" dirty="0"/>
+          </a:p>
+        </p:txBody>
+      </p:sp>
+      <p:sp>
+        <p:nvSpPr>
+          <p:cNvPr id="41" name="Shape 39"/>
+          <p:cNvSpPr/>
+          <p:nvPr/>
+        </p:nvSpPr>
+        <p:spPr>
+          <a:xfrm>
+            <a:off x="5504688" y="3319272"/>
+            <a:ext cx="3008376" cy="457200"/>
+          </a:xfrm>
+          <a:prstGeom prst="rect">
+            <a:avLst/>
+          </a:prstGeom>
+          <a:solidFill>
+            <a:srgbClr val="0D1621"/>
+          </a:solidFill>
+          <a:ln w="8255">
+            <a:solidFill>
+              <a:srgbClr val="33445B"/>
+            </a:solidFill>
+            <a:prstDash val="solid"/>
+          </a:ln>
+        </p:spPr>
+      </p:sp>
+      <p:sp>
+        <p:nvSpPr>
+          <p:cNvPr id="42" name="Text 40"/>
+          <p:cNvSpPr/>
+          <p:nvPr/>
+        </p:nvSpPr>
+        <p:spPr>
+          <a:xfrm>
+            <a:off x="5596128" y="3351276"/>
+            <a:ext cx="2825496" cy="393192"/>
+          </a:xfrm>
+          <a:prstGeom prst="rect">
+            <a:avLst/>
+          </a:prstGeom>
+          <a:noFill/>
+          <a:ln/>
+        </p:spPr>
+        <p:txBody>
+          <a:bodyPr wrap="square" lIns="0" tIns="0" rIns="0" bIns="0" rtlCol="0" anchor="ctr">
+            <a:normAutofit/>
+          </a:bodyPr>
+          <a:lstStyle/>
+          <a:p>
+            <a:pPr algn="ctr" indent="0" marL="0">
+              <a:buNone/>
+            </a:pPr>
+            <a:r>
+              <a:rPr lang="en-US" sz="890" dirty="0">
+                <a:solidFill>
+                  <a:srgbClr val="D9E1EC"/>
+                </a:solidFill>
+                <a:latin typeface="Noto Sans KR" pitchFamily="34" charset="0"/>
+                <a:ea typeface="Noto Sans KR" pitchFamily="34" charset="-122"/>
+                <a:cs typeface="Noto Sans KR" pitchFamily="34" charset="-120"/>
+              </a:rPr>
+              <a:t>96 storage cores</a:t>
+            </a:r>
+            <a:endParaRPr lang="en-US" sz="890" dirty="0"/>
+          </a:p>
+        </p:txBody>
+      </p:sp>
+      <p:sp>
+        <p:nvSpPr>
+          <p:cNvPr id="43" name="Shape 41"/>
+          <p:cNvSpPr/>
+          <p:nvPr/>
+        </p:nvSpPr>
+        <p:spPr>
+          <a:xfrm>
+            <a:off x="8513064" y="3319272"/>
+            <a:ext cx="3008376" cy="457200"/>
+          </a:xfrm>
+          <a:prstGeom prst="rect">
+            <a:avLst/>
+          </a:prstGeom>
+          <a:solidFill>
+            <a:srgbClr val="0D1621"/>
+          </a:solidFill>
+          <a:ln w="8255">
+            <a:solidFill>
+              <a:srgbClr val="33445B"/>
+            </a:solidFill>
+            <a:prstDash val="solid"/>
+          </a:ln>
+        </p:spPr>
+      </p:sp>
+      <p:sp>
+        <p:nvSpPr>
+          <p:cNvPr id="44" name="Text 42"/>
+          <p:cNvSpPr/>
+          <p:nvPr/>
+        </p:nvSpPr>
+        <p:spPr>
+          <a:xfrm>
+            <a:off x="8604504" y="3351276"/>
+            <a:ext cx="2825496" cy="393192"/>
+          </a:xfrm>
+          <a:prstGeom prst="rect">
+            <a:avLst/>
+          </a:prstGeom>
+          <a:noFill/>
+          <a:ln/>
+        </p:spPr>
+        <p:txBody>
+          <a:bodyPr wrap="square" lIns="0" tIns="0" rIns="0" bIns="0" rtlCol="0" anchor="ctr">
+            <a:normAutofit/>
+          </a:bodyPr>
+          <a:lstStyle/>
+          <a:p>
+            <a:pPr algn="ctr" indent="0" marL="0">
+              <a:buNone/>
+            </a:pPr>
+            <a:r>
+              <a:rPr lang="en-US" sz="890" dirty="0">
+                <a:solidFill>
+                  <a:srgbClr val="2DD4BF"/>
+                </a:solidFill>
+                <a:latin typeface="Noto Sans KR" pitchFamily="34" charset="0"/>
+                <a:ea typeface="Noto Sans KR" pitchFamily="34" charset="-122"/>
+                <a:cs typeface="Noto Sans KR" pitchFamily="34" charset="-120"/>
+              </a:rPr>
+              <a:t>192 storage cores</a:t>
+            </a:r>
+            <a:endParaRPr lang="en-US" sz="890" dirty="0"/>
+          </a:p>
+        </p:txBody>
+      </p:sp>
+      <p:sp>
+        <p:nvSpPr>
+          <p:cNvPr id="45" name="Shape 43"/>
+          <p:cNvSpPr/>
+          <p:nvPr/>
+        </p:nvSpPr>
+        <p:spPr>
+          <a:xfrm>
+            <a:off x="512064" y="3776472"/>
+            <a:ext cx="1984248" cy="457200"/>
           </a:xfrm>
           <a:prstGeom prst="rect">
             <a:avLst/>
@@ -6714,14 +7840,14 @@
       </p:sp>
       <p:sp>
         <p:nvSpPr>
-          <p:cNvPr id="16" name="Text 14"/>
-          <p:cNvSpPr/>
-          <p:nvPr/>
-        </p:nvSpPr>
-        <p:spPr>
-          <a:xfrm>
-            <a:off x="2935224" y="1938528"/>
-            <a:ext cx="3502152" cy="438912"/>
+          <p:cNvPr id="46" name="Text 44"/>
+          <p:cNvSpPr/>
+          <p:nvPr/>
+        </p:nvSpPr>
+        <p:spPr>
+          <a:xfrm>
+            <a:off x="603504" y="3808476"/>
+            <a:ext cx="1801368" cy="393192"/>
           </a:xfrm>
           <a:prstGeom prst="rect">
             <a:avLst/>
@@ -6739,7 +7865,73 @@
               <a:buNone/>
             </a:pPr>
             <a:r>
-              <a:rPr lang="en-US" sz="960" dirty="0">
+              <a:rPr lang="en-US" sz="900" b="1" dirty="0">
+                <a:solidFill>
+                  <a:srgbClr val="F7F9FC"/>
+                </a:solidFill>
+                <a:latin typeface="Noto Sans KR" pitchFamily="34" charset="0"/>
+                <a:ea typeface="Noto Sans KR" pitchFamily="34" charset="-122"/>
+                <a:cs typeface="Noto Sans KR" pitchFamily="34" charset="-120"/>
+              </a:rPr>
+              <a:t>HC usable (ASM HR)¹</a:t>
+            </a:r>
+            <a:endParaRPr lang="en-US" sz="900" dirty="0"/>
+          </a:p>
+        </p:txBody>
+      </p:sp>
+      <p:sp>
+        <p:nvSpPr>
+          <p:cNvPr id="47" name="Shape 45"/>
+          <p:cNvSpPr/>
+          <p:nvPr/>
+        </p:nvSpPr>
+        <p:spPr>
+          <a:xfrm>
+            <a:off x="2496312" y="3776472"/>
+            <a:ext cx="3008376" cy="457200"/>
+          </a:xfrm>
+          <a:prstGeom prst="rect">
+            <a:avLst/>
+          </a:prstGeom>
+          <a:solidFill>
+            <a:srgbClr val="101925"/>
+          </a:solidFill>
+          <a:ln w="8255">
+            <a:solidFill>
+              <a:srgbClr val="33445B"/>
+            </a:solidFill>
+            <a:prstDash val="solid"/>
+          </a:ln>
+        </p:spPr>
+      </p:sp>
+      <p:sp>
+        <p:nvSpPr>
+          <p:cNvPr id="48" name="Text 46"/>
+          <p:cNvSpPr/>
+          <p:nvPr/>
+        </p:nvSpPr>
+        <p:spPr>
+          <a:xfrm>
+            <a:off x="2587752" y="3808476"/>
+            <a:ext cx="2825496" cy="393192"/>
+          </a:xfrm>
+          <a:prstGeom prst="rect">
+            <a:avLst/>
+          </a:prstGeom>
+          <a:noFill/>
+          <a:ln/>
+        </p:spPr>
+        <p:txBody>
+          <a:bodyPr wrap="square" lIns="0" tIns="0" rIns="0" bIns="0" rtlCol="0" anchor="ctr">
+            <a:normAutofit/>
+          </a:bodyPr>
+          <a:lstStyle/>
+          <a:p>
+            <a:pPr algn="ctr" indent="0" marL="0">
+              <a:buNone/>
+            </a:pPr>
+            <a:r>
+              <a:rPr lang="en-US" sz="890" dirty="0">
                 <a:solidFill>
                   <a:srgbClr val="D9E1EC"/>
                 </a:solidFill>
@@ -6747,22 +7939,22 @@
                 <a:ea typeface="Noto Sans KR" pitchFamily="34" charset="-122"/>
                 <a:cs typeface="Noto Sans KR" pitchFamily="34" charset="-120"/>
               </a:rPr>
-              <a:t>2 DB + 3 HC Storage</a:t>
-            </a:r>
-            <a:endParaRPr lang="en-US" sz="960" dirty="0"/>
-          </a:p>
-        </p:txBody>
-      </p:sp>
-      <p:sp>
-        <p:nvSpPr>
-          <p:cNvPr id="17" name="Shape 15"/>
-          <p:cNvSpPr/>
-          <p:nvPr/>
-        </p:nvSpPr>
-        <p:spPr>
-          <a:xfrm>
-            <a:off x="6537960" y="1892808"/>
-            <a:ext cx="3703320" cy="539496"/>
+              <a:t>96.2 TB</a:t>
+            </a:r>
+            <a:endParaRPr lang="en-US" sz="890" dirty="0"/>
+          </a:p>
+        </p:txBody>
+      </p:sp>
+      <p:sp>
+        <p:nvSpPr>
+          <p:cNvPr id="49" name="Shape 47"/>
+          <p:cNvSpPr/>
+          <p:nvPr/>
+        </p:nvSpPr>
+        <p:spPr>
+          <a:xfrm>
+            <a:off x="5504688" y="3776472"/>
+            <a:ext cx="3008376" cy="457200"/>
           </a:xfrm>
           <a:prstGeom prst="rect">
             <a:avLst/>
@@ -6780,14 +7972,146 @@
       </p:sp>
       <p:sp>
         <p:nvSpPr>
-          <p:cNvPr id="18" name="Text 16"/>
-          <p:cNvSpPr/>
-          <p:nvPr/>
-        </p:nvSpPr>
-        <p:spPr>
-          <a:xfrm>
-            <a:off x="6638544" y="1938528"/>
-            <a:ext cx="3502152" cy="438912"/>
+          <p:cNvPr id="50" name="Text 48"/>
+          <p:cNvSpPr/>
+          <p:nvPr/>
+        </p:nvSpPr>
+        <p:spPr>
+          <a:xfrm>
+            <a:off x="5596128" y="3808476"/>
+            <a:ext cx="2825496" cy="393192"/>
+          </a:xfrm>
+          <a:prstGeom prst="rect">
+            <a:avLst/>
+          </a:prstGeom>
+          <a:noFill/>
+          <a:ln/>
+        </p:spPr>
+        <p:txBody>
+          <a:bodyPr wrap="square" lIns="0" tIns="0" rIns="0" bIns="0" rtlCol="0" anchor="ctr">
+            <a:normAutofit/>
+          </a:bodyPr>
+          <a:lstStyle/>
+          <a:p>
+            <a:pPr algn="ctr" indent="0" marL="0">
+              <a:buNone/>
+            </a:pPr>
+            <a:r>
+              <a:rPr lang="en-US" sz="890" dirty="0">
+                <a:solidFill>
+                  <a:srgbClr val="D9E1EC"/>
+                </a:solidFill>
+                <a:latin typeface="Noto Sans KR" pitchFamily="34" charset="0"/>
+                <a:ea typeface="Noto Sans KR" pitchFamily="34" charset="-122"/>
+                <a:cs typeface="Noto Sans KR" pitchFamily="34" charset="-120"/>
+              </a:rPr>
+              <a:t>106 TB</a:t>
+            </a:r>
+            <a:endParaRPr lang="en-US" sz="890" dirty="0"/>
+          </a:p>
+        </p:txBody>
+      </p:sp>
+      <p:sp>
+        <p:nvSpPr>
+          <p:cNvPr id="51" name="Shape 49"/>
+          <p:cNvSpPr/>
+          <p:nvPr/>
+        </p:nvSpPr>
+        <p:spPr>
+          <a:xfrm>
+            <a:off x="8513064" y="3776472"/>
+            <a:ext cx="3008376" cy="457200"/>
+          </a:xfrm>
+          <a:prstGeom prst="rect">
+            <a:avLst/>
+          </a:prstGeom>
+          <a:solidFill>
+            <a:srgbClr val="101925"/>
+          </a:solidFill>
+          <a:ln w="8255">
+            <a:solidFill>
+              <a:srgbClr val="33445B"/>
+            </a:solidFill>
+            <a:prstDash val="solid"/>
+          </a:ln>
+        </p:spPr>
+      </p:sp>
+      <p:sp>
+        <p:nvSpPr>
+          <p:cNvPr id="52" name="Text 50"/>
+          <p:cNvSpPr/>
+          <p:nvPr/>
+        </p:nvSpPr>
+        <p:spPr>
+          <a:xfrm>
+            <a:off x="8604504" y="3808476"/>
+            <a:ext cx="2825496" cy="393192"/>
+          </a:xfrm>
+          <a:prstGeom prst="rect">
+            <a:avLst/>
+          </a:prstGeom>
+          <a:noFill/>
+          <a:ln/>
+        </p:spPr>
+        <p:txBody>
+          <a:bodyPr wrap="square" lIns="0" tIns="0" rIns="0" bIns="0" rtlCol="0" anchor="ctr">
+            <a:normAutofit/>
+          </a:bodyPr>
+          <a:lstStyle/>
+          <a:p>
+            <a:pPr algn="ctr" indent="0" marL="0">
+              <a:buNone/>
+            </a:pPr>
+            <a:r>
+              <a:rPr lang="en-US" sz="890" dirty="0">
+                <a:solidFill>
+                  <a:srgbClr val="2DD4BF"/>
+                </a:solidFill>
+                <a:latin typeface="Noto Sans KR" pitchFamily="34" charset="0"/>
+                <a:ea typeface="Noto Sans KR" pitchFamily="34" charset="-122"/>
+                <a:cs typeface="Noto Sans KR" pitchFamily="34" charset="-120"/>
+              </a:rPr>
+              <a:t>240 TB</a:t>
+            </a:r>
+            <a:endParaRPr lang="en-US" sz="890" dirty="0"/>
+          </a:p>
+        </p:txBody>
+      </p:sp>
+      <p:sp>
+        <p:nvSpPr>
+          <p:cNvPr id="53" name="Shape 51"/>
+          <p:cNvSpPr/>
+          <p:nvPr/>
+        </p:nvSpPr>
+        <p:spPr>
+          <a:xfrm>
+            <a:off x="512064" y="4233672"/>
+            <a:ext cx="1984248" cy="457200"/>
+          </a:xfrm>
+          <a:prstGeom prst="rect">
+            <a:avLst/>
+          </a:prstGeom>
+          <a:solidFill>
+            <a:srgbClr val="0D1621"/>
+          </a:solidFill>
+          <a:ln w="8255">
+            <a:solidFill>
+              <a:srgbClr val="33445B"/>
+            </a:solidFill>
+            <a:prstDash val="solid"/>
+          </a:ln>
+        </p:spPr>
+      </p:sp>
+      <p:sp>
+        <p:nvSpPr>
+          <p:cNvPr id="54" name="Text 52"/>
+          <p:cNvSpPr/>
+          <p:nvPr/>
+        </p:nvSpPr>
+        <p:spPr>
+          <a:xfrm>
+            <a:off x="603504" y="4265676"/>
+            <a:ext cx="1801368" cy="393192"/>
           </a:xfrm>
           <a:prstGeom prst="rect">
             <a:avLst/>
@@ -6805,7 +8129,73 @@
               <a:buNone/>
             </a:pPr>
             <a:r>
-              <a:rPr lang="en-US" sz="960" dirty="0">
+              <a:rPr lang="en-US" sz="900" b="1" dirty="0">
+                <a:solidFill>
+                  <a:srgbClr val="F7F9FC"/>
+                </a:solidFill>
+                <a:latin typeface="Noto Sans KR" pitchFamily="34" charset="0"/>
+                <a:ea typeface="Noto Sans KR" pitchFamily="34" charset="-122"/>
+                <a:cs typeface="Noto Sans KR" pitchFamily="34" charset="-120"/>
+              </a:rPr>
+              <a:t>Flash · PMEM/XRMEM</a:t>
+            </a:r>
+            <a:endParaRPr lang="en-US" sz="900" dirty="0"/>
+          </a:p>
+        </p:txBody>
+      </p:sp>
+      <p:sp>
+        <p:nvSpPr>
+          <p:cNvPr id="55" name="Shape 53"/>
+          <p:cNvSpPr/>
+          <p:nvPr/>
+        </p:nvSpPr>
+        <p:spPr>
+          <a:xfrm>
+            <a:off x="2496312" y="4233672"/>
+            <a:ext cx="3008376" cy="457200"/>
+          </a:xfrm>
+          <a:prstGeom prst="rect">
+            <a:avLst/>
+          </a:prstGeom>
+          <a:solidFill>
+            <a:srgbClr val="0D1621"/>
+          </a:solidFill>
+          <a:ln w="8255">
+            <a:solidFill>
+              <a:srgbClr val="33445B"/>
+            </a:solidFill>
+            <a:prstDash val="solid"/>
+          </a:ln>
+        </p:spPr>
+      </p:sp>
+      <p:sp>
+        <p:nvSpPr>
+          <p:cNvPr id="56" name="Text 54"/>
+          <p:cNvSpPr/>
+          <p:nvPr/>
+        </p:nvSpPr>
+        <p:spPr>
+          <a:xfrm>
+            <a:off x="2587752" y="4265676"/>
+            <a:ext cx="2825496" cy="393192"/>
+          </a:xfrm>
+          <a:prstGeom prst="rect">
+            <a:avLst/>
+          </a:prstGeom>
+          <a:noFill/>
+          <a:ln/>
+        </p:spPr>
+        <p:txBody>
+          <a:bodyPr wrap="square" lIns="0" tIns="0" rIns="0" bIns="0" rtlCol="0" anchor="ctr">
+            <a:normAutofit/>
+          </a:bodyPr>
+          <a:lstStyle/>
+          <a:p>
+            <a:pPr algn="ctr" indent="0" marL="0">
+              <a:buNone/>
+            </a:pPr>
+            <a:r>
+              <a:rPr lang="en-US" sz="890" dirty="0">
                 <a:solidFill>
                   <a:srgbClr val="D9E1EC"/>
                 </a:solidFill>
@@ -6813,22 +8203,154 @@
                 <a:ea typeface="Noto Sans KR" pitchFamily="34" charset="-122"/>
                 <a:cs typeface="Noto Sans KR" pitchFamily="34" charset="-120"/>
               </a:rPr>
-              <a:t>2 Standard DB + 3 HC w/XRMEM</a:t>
-            </a:r>
-            <a:endParaRPr lang="en-US" sz="960" dirty="0"/>
-          </a:p>
-        </p:txBody>
-      </p:sp>
-      <p:sp>
-        <p:nvSpPr>
-          <p:cNvPr id="19" name="Shape 17"/>
-          <p:cNvSpPr/>
-          <p:nvPr/>
-        </p:nvSpPr>
-        <p:spPr>
-          <a:xfrm>
-            <a:off x="10241280" y="1892808"/>
-            <a:ext cx="1261872" cy="539496"/>
+              <a:t>38.4 TB · 2.3 TB PMEM</a:t>
+            </a:r>
+            <a:endParaRPr lang="en-US" sz="890" dirty="0"/>
+          </a:p>
+        </p:txBody>
+      </p:sp>
+      <p:sp>
+        <p:nvSpPr>
+          <p:cNvPr id="57" name="Shape 55"/>
+          <p:cNvSpPr/>
+          <p:nvPr/>
+        </p:nvSpPr>
+        <p:spPr>
+          <a:xfrm>
+            <a:off x="5504688" y="4233672"/>
+            <a:ext cx="3008376" cy="457200"/>
+          </a:xfrm>
+          <a:prstGeom prst="rect">
+            <a:avLst/>
+          </a:prstGeom>
+          <a:solidFill>
+            <a:srgbClr val="0D1621"/>
+          </a:solidFill>
+          <a:ln w="8255">
+            <a:solidFill>
+              <a:srgbClr val="33445B"/>
+            </a:solidFill>
+            <a:prstDash val="solid"/>
+          </a:ln>
+        </p:spPr>
+      </p:sp>
+      <p:sp>
+        <p:nvSpPr>
+          <p:cNvPr id="58" name="Text 56"/>
+          <p:cNvSpPr/>
+          <p:nvPr/>
+        </p:nvSpPr>
+        <p:spPr>
+          <a:xfrm>
+            <a:off x="5596128" y="4265676"/>
+            <a:ext cx="2825496" cy="393192"/>
+          </a:xfrm>
+          <a:prstGeom prst="rect">
+            <a:avLst/>
+          </a:prstGeom>
+          <a:noFill/>
+          <a:ln/>
+        </p:spPr>
+        <p:txBody>
+          <a:bodyPr wrap="square" lIns="0" tIns="0" rIns="0" bIns="0" rtlCol="0" anchor="ctr">
+            <a:normAutofit/>
+          </a:bodyPr>
+          <a:lstStyle/>
+          <a:p>
+            <a:pPr algn="ctr" indent="0" marL="0">
+              <a:buNone/>
+            </a:pPr>
+            <a:r>
+              <a:rPr lang="en-US" sz="890" dirty="0">
+                <a:solidFill>
+                  <a:srgbClr val="D9E1EC"/>
+                </a:solidFill>
+                <a:latin typeface="Noto Sans KR" pitchFamily="34" charset="0"/>
+                <a:ea typeface="Noto Sans KR" pitchFamily="34" charset="-122"/>
+                <a:cs typeface="Noto Sans KR" pitchFamily="34" charset="-120"/>
+              </a:rPr>
+              <a:t>38.4 TB · XRMEM 없음</a:t>
+            </a:r>
+            <a:endParaRPr lang="en-US" sz="890" dirty="0"/>
+          </a:p>
+        </p:txBody>
+      </p:sp>
+      <p:sp>
+        <p:nvSpPr>
+          <p:cNvPr id="59" name="Shape 57"/>
+          <p:cNvSpPr/>
+          <p:nvPr/>
+        </p:nvSpPr>
+        <p:spPr>
+          <a:xfrm>
+            <a:off x="8513064" y="4233672"/>
+            <a:ext cx="3008376" cy="457200"/>
+          </a:xfrm>
+          <a:prstGeom prst="rect">
+            <a:avLst/>
+          </a:prstGeom>
+          <a:solidFill>
+            <a:srgbClr val="0D1621"/>
+          </a:solidFill>
+          <a:ln w="8255">
+            <a:solidFill>
+              <a:srgbClr val="33445B"/>
+            </a:solidFill>
+            <a:prstDash val="solid"/>
+          </a:ln>
+        </p:spPr>
+      </p:sp>
+      <p:sp>
+        <p:nvSpPr>
+          <p:cNvPr id="60" name="Text 58"/>
+          <p:cNvSpPr/>
+          <p:nvPr/>
+        </p:nvSpPr>
+        <p:spPr>
+          <a:xfrm>
+            <a:off x="8604504" y="4265676"/>
+            <a:ext cx="2825496" cy="393192"/>
+          </a:xfrm>
+          <a:prstGeom prst="rect">
+            <a:avLst/>
+          </a:prstGeom>
+          <a:noFill/>
+          <a:ln/>
+        </p:spPr>
+        <p:txBody>
+          <a:bodyPr wrap="square" lIns="0" tIns="0" rIns="0" bIns="0" rtlCol="0" anchor="ctr">
+            <a:normAutofit/>
+          </a:bodyPr>
+          <a:lstStyle/>
+          <a:p>
+            <a:pPr algn="ctr" indent="0" marL="0">
+              <a:buNone/>
+            </a:pPr>
+            <a:r>
+              <a:rPr lang="en-US" sz="890" dirty="0">
+                <a:solidFill>
+                  <a:srgbClr val="2DD4BF"/>
+                </a:solidFill>
+                <a:latin typeface="Noto Sans KR" pitchFamily="34" charset="0"/>
+                <a:ea typeface="Noto Sans KR" pitchFamily="34" charset="-122"/>
+                <a:cs typeface="Noto Sans KR" pitchFamily="34" charset="-120"/>
+              </a:rPr>
+              <a:t>81.6 TB · 3.75 TB XRMEM</a:t>
+            </a:r>
+            <a:endParaRPr lang="en-US" sz="890" dirty="0"/>
+          </a:p>
+        </p:txBody>
+      </p:sp>
+      <p:sp>
+        <p:nvSpPr>
+          <p:cNvPr id="61" name="Shape 59"/>
+          <p:cNvSpPr/>
+          <p:nvPr/>
+        </p:nvSpPr>
+        <p:spPr>
+          <a:xfrm>
+            <a:off x="512064" y="4690872"/>
+            <a:ext cx="1984248" cy="457200"/>
           </a:xfrm>
           <a:prstGeom prst="rect">
             <a:avLst/>
@@ -6846,14 +8368,80 @@
       </p:sp>
       <p:sp>
         <p:nvSpPr>
-          <p:cNvPr id="20" name="Text 18"/>
-          <p:cNvSpPr/>
-          <p:nvPr/>
-        </p:nvSpPr>
-        <p:spPr>
-          <a:xfrm>
-            <a:off x="10341864" y="1938528"/>
-            <a:ext cx="1060704" cy="438912"/>
+          <p:cNvPr id="62" name="Text 60"/>
+          <p:cNvSpPr/>
+          <p:nvPr/>
+        </p:nvSpPr>
+        <p:spPr>
+          <a:xfrm>
+            <a:off x="603504" y="4722876"/>
+            <a:ext cx="1801368" cy="393192"/>
+          </a:xfrm>
+          <a:prstGeom prst="rect">
+            <a:avLst/>
+          </a:prstGeom>
+          <a:noFill/>
+          <a:ln/>
+        </p:spPr>
+        <p:txBody>
+          <a:bodyPr wrap="square" lIns="0" tIns="0" rIns="0" bIns="0" rtlCol="0" anchor="ctr">
+            <a:normAutofit/>
+          </a:bodyPr>
+          <a:lstStyle/>
+          <a:p>
+            <a:pPr algn="l" indent="0" marL="0">
+              <a:buNone/>
+            </a:pPr>
+            <a:r>
+              <a:rPr lang="en-US" sz="900" b="1" dirty="0">
+                <a:solidFill>
+                  <a:srgbClr val="F7F9FC"/>
+                </a:solidFill>
+                <a:latin typeface="Noto Sans KR" pitchFamily="34" charset="0"/>
+                <a:ea typeface="Noto Sans KR" pitchFamily="34" charset="-122"/>
+                <a:cs typeface="Noto Sans KR" pitchFamily="34" charset="-120"/>
+              </a:rPr>
+              <a:t>Max SQL flash BW</a:t>
+            </a:r>
+            <a:endParaRPr lang="en-US" sz="900" dirty="0"/>
+          </a:p>
+        </p:txBody>
+      </p:sp>
+      <p:sp>
+        <p:nvSpPr>
+          <p:cNvPr id="63" name="Shape 61"/>
+          <p:cNvSpPr/>
+          <p:nvPr/>
+        </p:nvSpPr>
+        <p:spPr>
+          <a:xfrm>
+            <a:off x="2496312" y="4690872"/>
+            <a:ext cx="3008376" cy="457200"/>
+          </a:xfrm>
+          <a:prstGeom prst="rect">
+            <a:avLst/>
+          </a:prstGeom>
+          <a:solidFill>
+            <a:srgbClr val="101925"/>
+          </a:solidFill>
+          <a:ln w="8255">
+            <a:solidFill>
+              <a:srgbClr val="33445B"/>
+            </a:solidFill>
+            <a:prstDash val="solid"/>
+          </a:ln>
+        </p:spPr>
+      </p:sp>
+      <p:sp>
+        <p:nvSpPr>
+          <p:cNvPr id="64" name="Text 62"/>
+          <p:cNvSpPr/>
+          <p:nvPr/>
+        </p:nvSpPr>
+        <p:spPr>
+          <a:xfrm>
+            <a:off x="2587752" y="4722876"/>
+            <a:ext cx="2825496" cy="393192"/>
           </a:xfrm>
           <a:prstGeom prst="rect">
             <a:avLst/>
@@ -6871,7 +8459,139 @@
               <a:buNone/>
             </a:pPr>
             <a:r>
-              <a:rPr lang="en-US" sz="920" b="1" dirty="0">
+              <a:rPr lang="en-US" sz="890" dirty="0">
+                <a:solidFill>
+                  <a:srgbClr val="D9E1EC"/>
+                </a:solidFill>
+                <a:latin typeface="Noto Sans KR" pitchFamily="34" charset="0"/>
+                <a:ea typeface="Noto Sans KR" pitchFamily="34" charset="-122"/>
+                <a:cs typeface="Noto Sans KR" pitchFamily="34" charset="-120"/>
+              </a:rPr>
+              <a:t>67.5 GB/s</a:t>
+            </a:r>
+            <a:endParaRPr lang="en-US" sz="890" dirty="0"/>
+          </a:p>
+        </p:txBody>
+      </p:sp>
+      <p:sp>
+        <p:nvSpPr>
+          <p:cNvPr id="65" name="Shape 63"/>
+          <p:cNvSpPr/>
+          <p:nvPr/>
+        </p:nvSpPr>
+        <p:spPr>
+          <a:xfrm>
+            <a:off x="5504688" y="4690872"/>
+            <a:ext cx="3008376" cy="457200"/>
+          </a:xfrm>
+          <a:prstGeom prst="rect">
+            <a:avLst/>
+          </a:prstGeom>
+          <a:solidFill>
+            <a:srgbClr val="101925"/>
+          </a:solidFill>
+          <a:ln w="8255">
+            <a:solidFill>
+              <a:srgbClr val="33445B"/>
+            </a:solidFill>
+            <a:prstDash val="solid"/>
+          </a:ln>
+        </p:spPr>
+      </p:sp>
+      <p:sp>
+        <p:nvSpPr>
+          <p:cNvPr id="66" name="Text 64"/>
+          <p:cNvSpPr/>
+          <p:nvPr/>
+        </p:nvSpPr>
+        <p:spPr>
+          <a:xfrm>
+            <a:off x="5596128" y="4722876"/>
+            <a:ext cx="2825496" cy="393192"/>
+          </a:xfrm>
+          <a:prstGeom prst="rect">
+            <a:avLst/>
+          </a:prstGeom>
+          <a:noFill/>
+          <a:ln/>
+        </p:spPr>
+        <p:txBody>
+          <a:bodyPr wrap="square" lIns="0" tIns="0" rIns="0" bIns="0" rtlCol="0" anchor="ctr">
+            <a:normAutofit/>
+          </a:bodyPr>
+          <a:lstStyle/>
+          <a:p>
+            <a:pPr algn="ctr" indent="0" marL="0">
+              <a:buNone/>
+            </a:pPr>
+            <a:r>
+              <a:rPr lang="en-US" sz="890" dirty="0">
+                <a:solidFill>
+                  <a:srgbClr val="D9E1EC"/>
+                </a:solidFill>
+                <a:latin typeface="Noto Sans KR" pitchFamily="34" charset="0"/>
+                <a:ea typeface="Noto Sans KR" pitchFamily="34" charset="-122"/>
+                <a:cs typeface="Noto Sans KR" pitchFamily="34" charset="-120"/>
+              </a:rPr>
+              <a:t>37.5 GB/s</a:t>
+            </a:r>
+            <a:endParaRPr lang="en-US" sz="890" dirty="0"/>
+          </a:p>
+        </p:txBody>
+      </p:sp>
+      <p:sp>
+        <p:nvSpPr>
+          <p:cNvPr id="67" name="Shape 65"/>
+          <p:cNvSpPr/>
+          <p:nvPr/>
+        </p:nvSpPr>
+        <p:spPr>
+          <a:xfrm>
+            <a:off x="8513064" y="4690872"/>
+            <a:ext cx="3008376" cy="457200"/>
+          </a:xfrm>
+          <a:prstGeom prst="rect">
+            <a:avLst/>
+          </a:prstGeom>
+          <a:solidFill>
+            <a:srgbClr val="101925"/>
+          </a:solidFill>
+          <a:ln w="8255">
+            <a:solidFill>
+              <a:srgbClr val="33445B"/>
+            </a:solidFill>
+            <a:prstDash val="solid"/>
+          </a:ln>
+        </p:spPr>
+      </p:sp>
+      <p:sp>
+        <p:nvSpPr>
+          <p:cNvPr id="68" name="Text 66"/>
+          <p:cNvSpPr/>
+          <p:nvPr/>
+        </p:nvSpPr>
+        <p:spPr>
+          <a:xfrm>
+            <a:off x="8604504" y="4722876"/>
+            <a:ext cx="2825496" cy="393192"/>
+          </a:xfrm>
+          <a:prstGeom prst="rect">
+            <a:avLst/>
+          </a:prstGeom>
+          <a:noFill/>
+          <a:ln/>
+        </p:spPr>
+        <p:txBody>
+          <a:bodyPr wrap="square" lIns="0" tIns="0" rIns="0" bIns="0" rtlCol="0" anchor="ctr">
+            <a:normAutofit/>
+          </a:bodyPr>
+          <a:lstStyle/>
+          <a:p>
+            <a:pPr algn="ctr" indent="0" marL="0">
+              <a:buNone/>
+            </a:pPr>
+            <a:r>
+              <a:rPr lang="en-US" sz="890" dirty="0">
                 <a:solidFill>
                   <a:srgbClr val="2DD4BF"/>
                 </a:solidFill>
@@ -6879,22 +8599,22 @@
                 <a:ea typeface="Noto Sans KR" pitchFamily="34" charset="-122"/>
                 <a:cs typeface="Noto Sans KR" pitchFamily="34" charset="-120"/>
               </a:rPr>
-              <a:t>노드 수 2+3 동일</a:t>
-            </a:r>
-            <a:endParaRPr lang="en-US" sz="920" dirty="0"/>
-          </a:p>
-        </p:txBody>
-      </p:sp>
-      <p:sp>
-        <p:nvSpPr>
-          <p:cNvPr id="21" name="Shape 19"/>
-          <p:cNvSpPr/>
-          <p:nvPr/>
-        </p:nvSpPr>
-        <p:spPr>
-          <a:xfrm>
-            <a:off x="512064" y="2432304"/>
-            <a:ext cx="2322576" cy="539496"/>
+              <a:t>300 GB/s</a:t>
+            </a:r>
+            <a:endParaRPr lang="en-US" sz="890" dirty="0"/>
+          </a:p>
+        </p:txBody>
+      </p:sp>
+      <p:sp>
+        <p:nvSpPr>
+          <p:cNvPr id="69" name="Shape 67"/>
+          <p:cNvSpPr/>
+          <p:nvPr/>
+        </p:nvSpPr>
+        <p:spPr>
+          <a:xfrm>
+            <a:off x="512064" y="5148072"/>
+            <a:ext cx="1984248" cy="457200"/>
           </a:xfrm>
           <a:prstGeom prst="rect">
             <a:avLst/>
@@ -6912,14 +8632,14 @@
       </p:sp>
       <p:sp>
         <p:nvSpPr>
-          <p:cNvPr id="22" name="Text 20"/>
-          <p:cNvSpPr/>
-          <p:nvPr/>
-        </p:nvSpPr>
-        <p:spPr>
-          <a:xfrm>
-            <a:off x="612648" y="2478024"/>
-            <a:ext cx="2121408" cy="438912"/>
+          <p:cNvPr id="70" name="Text 68"/>
+          <p:cNvSpPr/>
+          <p:nvPr/>
+        </p:nvSpPr>
+        <p:spPr>
+          <a:xfrm>
+            <a:off x="603504" y="5180076"/>
+            <a:ext cx="1801368" cy="393192"/>
           </a:xfrm>
           <a:prstGeom prst="rect">
             <a:avLst/>
@@ -6937,7 +8657,7 @@
               <a:buNone/>
             </a:pPr>
             <a:r>
-              <a:rPr lang="en-US" sz="960" b="1" dirty="0">
+              <a:rPr lang="en-US" sz="900" b="1" dirty="0">
                 <a:solidFill>
                   <a:srgbClr val="F7F9FC"/>
                 </a:solidFill>
@@ -6945,22 +8665,22 @@
                 <a:ea typeface="Noto Sans KR" pitchFamily="34" charset="-122"/>
                 <a:cs typeface="Noto Sans KR" pitchFamily="34" charset="-120"/>
               </a:rPr>
-              <a:t>DB compute</a:t>
-            </a:r>
-            <a:endParaRPr lang="en-US" sz="960" dirty="0"/>
-          </a:p>
-        </p:txBody>
-      </p:sp>
-      <p:sp>
-        <p:nvSpPr>
-          <p:cNvPr id="23" name="Shape 21"/>
-          <p:cNvSpPr/>
-          <p:nvPr/>
-        </p:nvSpPr>
-        <p:spPr>
-          <a:xfrm>
-            <a:off x="2834640" y="2432304"/>
-            <a:ext cx="3703320" cy="539496"/>
+              <a:t>SQL Read / Write IOPS</a:t>
+            </a:r>
+            <a:endParaRPr lang="en-US" sz="900" dirty="0"/>
+          </a:p>
+        </p:txBody>
+      </p:sp>
+      <p:sp>
+        <p:nvSpPr>
+          <p:cNvPr id="71" name="Shape 69"/>
+          <p:cNvSpPr/>
+          <p:nvPr/>
+        </p:nvSpPr>
+        <p:spPr>
+          <a:xfrm>
+            <a:off x="2496312" y="5148072"/>
+            <a:ext cx="3008376" cy="457200"/>
           </a:xfrm>
           <a:prstGeom prst="rect">
             <a:avLst/>
@@ -6978,14 +8698,212 @@
       </p:sp>
       <p:sp>
         <p:nvSpPr>
-          <p:cNvPr id="24" name="Text 22"/>
-          <p:cNvSpPr/>
-          <p:nvPr/>
-        </p:nvSpPr>
-        <p:spPr>
-          <a:xfrm>
-            <a:off x="2935224" y="2478024"/>
-            <a:ext cx="3502152" cy="438912"/>
+          <p:cNvPr id="72" name="Text 70"/>
+          <p:cNvSpPr/>
+          <p:nvPr/>
+        </p:nvSpPr>
+        <p:spPr>
+          <a:xfrm>
+            <a:off x="2587752" y="5180076"/>
+            <a:ext cx="2825496" cy="393192"/>
+          </a:xfrm>
+          <a:prstGeom prst="rect">
+            <a:avLst/>
+          </a:prstGeom>
+          <a:noFill/>
+          <a:ln/>
+        </p:spPr>
+        <p:txBody>
+          <a:bodyPr wrap="square" lIns="0" tIns="0" rIns="0" bIns="0" rtlCol="0" anchor="ctr">
+            <a:normAutofit/>
+          </a:bodyPr>
+          <a:lstStyle/>
+          <a:p>
+            <a:pPr algn="ctr" indent="0" marL="0">
+              <a:buNone/>
+            </a:pPr>
+            <a:r>
+              <a:rPr lang="en-US" sz="890" dirty="0">
+                <a:solidFill>
+                  <a:srgbClr val="D9E1EC"/>
+                </a:solidFill>
+                <a:latin typeface="Noto Sans KR" pitchFamily="34" charset="0"/>
+                <a:ea typeface="Noto Sans KR" pitchFamily="34" charset="-122"/>
+                <a:cs typeface="Noto Sans KR" pitchFamily="34" charset="-120"/>
+              </a:rPr>
+              <a:t>2.8M / 921K</a:t>
+            </a:r>
+            <a:endParaRPr lang="en-US" sz="890" dirty="0"/>
+          </a:p>
+        </p:txBody>
+      </p:sp>
+      <p:sp>
+        <p:nvSpPr>
+          <p:cNvPr id="73" name="Shape 71"/>
+          <p:cNvSpPr/>
+          <p:nvPr/>
+        </p:nvSpPr>
+        <p:spPr>
+          <a:xfrm>
+            <a:off x="5504688" y="5148072"/>
+            <a:ext cx="3008376" cy="457200"/>
+          </a:xfrm>
+          <a:prstGeom prst="rect">
+            <a:avLst/>
+          </a:prstGeom>
+          <a:solidFill>
+            <a:srgbClr val="0D1621"/>
+          </a:solidFill>
+          <a:ln w="8255">
+            <a:solidFill>
+              <a:srgbClr val="33445B"/>
+            </a:solidFill>
+            <a:prstDash val="solid"/>
+          </a:ln>
+        </p:spPr>
+      </p:sp>
+      <p:sp>
+        <p:nvSpPr>
+          <p:cNvPr id="74" name="Text 72"/>
+          <p:cNvSpPr/>
+          <p:nvPr/>
+        </p:nvSpPr>
+        <p:spPr>
+          <a:xfrm>
+            <a:off x="5596128" y="5180076"/>
+            <a:ext cx="2825496" cy="393192"/>
+          </a:xfrm>
+          <a:prstGeom prst="rect">
+            <a:avLst/>
+          </a:prstGeom>
+          <a:noFill/>
+          <a:ln/>
+        </p:spPr>
+        <p:txBody>
+          <a:bodyPr wrap="square" lIns="0" tIns="0" rIns="0" bIns="0" rtlCol="0" anchor="ctr">
+            <a:normAutofit/>
+          </a:bodyPr>
+          <a:lstStyle/>
+          <a:p>
+            <a:pPr algn="ctr" indent="0" marL="0">
+              <a:buNone/>
+            </a:pPr>
+            <a:r>
+              <a:rPr lang="en-US" sz="890" dirty="0">
+                <a:solidFill>
+                  <a:srgbClr val="D9E1EC"/>
+                </a:solidFill>
+                <a:latin typeface="Noto Sans KR" pitchFamily="34" charset="0"/>
+                <a:ea typeface="Noto Sans KR" pitchFamily="34" charset="-122"/>
+                <a:cs typeface="Noto Sans KR" pitchFamily="34" charset="-120"/>
+              </a:rPr>
+              <a:t>597K / 544K</a:t>
+            </a:r>
+            <a:endParaRPr lang="en-US" sz="890" dirty="0"/>
+          </a:p>
+        </p:txBody>
+      </p:sp>
+      <p:sp>
+        <p:nvSpPr>
+          <p:cNvPr id="75" name="Shape 73"/>
+          <p:cNvSpPr/>
+          <p:nvPr/>
+        </p:nvSpPr>
+        <p:spPr>
+          <a:xfrm>
+            <a:off x="8513064" y="5148072"/>
+            <a:ext cx="3008376" cy="457200"/>
+          </a:xfrm>
+          <a:prstGeom prst="rect">
+            <a:avLst/>
+          </a:prstGeom>
+          <a:solidFill>
+            <a:srgbClr val="0D1621"/>
+          </a:solidFill>
+          <a:ln w="8255">
+            <a:solidFill>
+              <a:srgbClr val="33445B"/>
+            </a:solidFill>
+            <a:prstDash val="solid"/>
+          </a:ln>
+        </p:spPr>
+      </p:sp>
+      <p:sp>
+        <p:nvSpPr>
+          <p:cNvPr id="76" name="Text 74"/>
+          <p:cNvSpPr/>
+          <p:nvPr/>
+        </p:nvSpPr>
+        <p:spPr>
+          <a:xfrm>
+            <a:off x="8604504" y="5180076"/>
+            <a:ext cx="2825496" cy="393192"/>
+          </a:xfrm>
+          <a:prstGeom prst="rect">
+            <a:avLst/>
+          </a:prstGeom>
+          <a:noFill/>
+          <a:ln/>
+        </p:spPr>
+        <p:txBody>
+          <a:bodyPr wrap="square" lIns="0" tIns="0" rIns="0" bIns="0" rtlCol="0" anchor="ctr">
+            <a:normAutofit/>
+          </a:bodyPr>
+          <a:lstStyle/>
+          <a:p>
+            <a:pPr algn="ctr" indent="0" marL="0">
+              <a:buNone/>
+            </a:pPr>
+            <a:r>
+              <a:rPr lang="en-US" sz="890" dirty="0">
+                <a:solidFill>
+                  <a:srgbClr val="2DD4BF"/>
+                </a:solidFill>
+                <a:latin typeface="Noto Sans KR" pitchFamily="34" charset="0"/>
+                <a:ea typeface="Noto Sans KR" pitchFamily="34" charset="-122"/>
+                <a:cs typeface="Noto Sans KR" pitchFamily="34" charset="-120"/>
+              </a:rPr>
+              <a:t>5.6M / 3.0M</a:t>
+            </a:r>
+            <a:endParaRPr lang="en-US" sz="890" dirty="0"/>
+          </a:p>
+        </p:txBody>
+      </p:sp>
+      <p:sp>
+        <p:nvSpPr>
+          <p:cNvPr id="77" name="Shape 75"/>
+          <p:cNvSpPr/>
+          <p:nvPr/>
+        </p:nvSpPr>
+        <p:spPr>
+          <a:xfrm>
+            <a:off x="512064" y="5605272"/>
+            <a:ext cx="1984248" cy="457200"/>
+          </a:xfrm>
+          <a:prstGeom prst="rect">
+            <a:avLst/>
+          </a:prstGeom>
+          <a:solidFill>
+            <a:srgbClr val="101925"/>
+          </a:solidFill>
+          <a:ln w="8255">
+            <a:solidFill>
+              <a:srgbClr val="33445B"/>
+            </a:solidFill>
+            <a:prstDash val="solid"/>
+          </a:ln>
+        </p:spPr>
+      </p:sp>
+      <p:sp>
+        <p:nvSpPr>
+          <p:cNvPr id="78" name="Text 76"/>
+          <p:cNvSpPr/>
+          <p:nvPr/>
+        </p:nvSpPr>
+        <p:spPr>
+          <a:xfrm>
+            <a:off x="603504" y="5637276"/>
+            <a:ext cx="1801368" cy="393192"/>
           </a:xfrm>
           <a:prstGeom prst="rect">
             <a:avLst/>
@@ -7003,7 +8921,73 @@
               <a:buNone/>
             </a:pPr>
             <a:r>
-              <a:rPr lang="en-US" sz="960" dirty="0">
+              <a:rPr lang="en-US" sz="900" b="1" dirty="0">
+                <a:solidFill>
+                  <a:srgbClr val="F7F9FC"/>
+                </a:solidFill>
+                <a:latin typeface="Noto Sans KR" pitchFamily="34" charset="0"/>
+                <a:ea typeface="Noto Sans KR" pitchFamily="34" charset="-122"/>
+                <a:cs typeface="Noto Sans KR" pitchFamily="34" charset="-120"/>
+              </a:rPr>
+              <a:t>Disk BW · IOPS · Load</a:t>
+            </a:r>
+            <a:endParaRPr lang="en-US" sz="900" dirty="0"/>
+          </a:p>
+        </p:txBody>
+      </p:sp>
+      <p:sp>
+        <p:nvSpPr>
+          <p:cNvPr id="79" name="Shape 77"/>
+          <p:cNvSpPr/>
+          <p:nvPr/>
+        </p:nvSpPr>
+        <p:spPr>
+          <a:xfrm>
+            <a:off x="2496312" y="5605272"/>
+            <a:ext cx="3008376" cy="457200"/>
+          </a:xfrm>
+          <a:prstGeom prst="rect">
+            <a:avLst/>
+          </a:prstGeom>
+          <a:solidFill>
+            <a:srgbClr val="101925"/>
+          </a:solidFill>
+          <a:ln w="8255">
+            <a:solidFill>
+              <a:srgbClr val="33445B"/>
+            </a:solidFill>
+            <a:prstDash val="solid"/>
+          </a:ln>
+        </p:spPr>
+      </p:sp>
+      <p:sp>
+        <p:nvSpPr>
+          <p:cNvPr id="80" name="Text 78"/>
+          <p:cNvSpPr/>
+          <p:nvPr/>
+        </p:nvSpPr>
+        <p:spPr>
+          <a:xfrm>
+            <a:off x="2587752" y="5637276"/>
+            <a:ext cx="2825496" cy="393192"/>
+          </a:xfrm>
+          <a:prstGeom prst="rect">
+            <a:avLst/>
+          </a:prstGeom>
+          <a:noFill/>
+          <a:ln/>
+        </p:spPr>
+        <p:txBody>
+          <a:bodyPr wrap="square" lIns="0" tIns="0" rIns="0" bIns="0" rtlCol="0" anchor="ctr">
+            <a:normAutofit/>
+          </a:bodyPr>
+          <a:lstStyle/>
+          <a:p>
+            <a:pPr algn="ctr" indent="0" marL="0">
+              <a:buNone/>
+            </a:pPr>
+            <a:r>
+              <a:rPr lang="en-US" sz="890" dirty="0">
                 <a:solidFill>
                   <a:srgbClr val="D9E1EC"/>
                 </a:solidFill>
@@ -7011,16 +8995,16 @@
                 <a:ea typeface="Noto Sans KR" pitchFamily="34" charset="-122"/>
                 <a:cs typeface="Noto Sans KR" pitchFamily="34" charset="-120"/>
               </a:rPr>
-              <a:t>252 usable cores</a:t>
-            </a:r>
-            <a:endParaRPr lang="en-US" sz="960" dirty="0"/>
-          </a:p>
-          <a:p>
-            <a:pPr algn="l" indent="0" marL="0">
-              <a:buNone/>
-            </a:pPr>
-            <a:r>
-              <a:rPr lang="en-US" sz="960" dirty="0">
+              <a:t>2.7 GB/s · 3,900</a:t>
+            </a:r>
+            <a:endParaRPr lang="en-US" sz="890" dirty="0"/>
+          </a:p>
+          <a:p>
+            <a:pPr algn="ctr" indent="0" marL="0">
+              <a:buNone/>
+            </a:pPr>
+            <a:r>
+              <a:rPr lang="en-US" sz="890" dirty="0">
                 <a:solidFill>
                   <a:srgbClr val="D9E1EC"/>
                 </a:solidFill>
@@ -7028,28 +9012,28 @@
                 <a:ea typeface="Noto Sans KR" pitchFamily="34" charset="-122"/>
                 <a:cs typeface="Noto Sans KR" pitchFamily="34" charset="-120"/>
               </a:rPr>
-              <a:t>(OCPU 기반 서비스 세대)</a:t>
-            </a:r>
-            <a:endParaRPr lang="en-US" sz="960" dirty="0"/>
-          </a:p>
-        </p:txBody>
-      </p:sp>
-      <p:sp>
-        <p:nvSpPr>
-          <p:cNvPr id="25" name="Shape 23"/>
-          <p:cNvSpPr/>
-          <p:nvPr/>
-        </p:nvSpPr>
-        <p:spPr>
-          <a:xfrm>
-            <a:off x="6537960" y="2432304"/>
-            <a:ext cx="3703320" cy="539496"/>
-          </a:xfrm>
-          <a:prstGeom prst="rect">
-            <a:avLst/>
-          </a:prstGeom>
-          <a:solidFill>
-            <a:srgbClr val="0D1621"/>
+              <a:t>3.8 TB/hr</a:t>
+            </a:r>
+            <a:endParaRPr lang="en-US" sz="890" dirty="0"/>
+          </a:p>
+        </p:txBody>
+      </p:sp>
+      <p:sp>
+        <p:nvSpPr>
+          <p:cNvPr id="81" name="Shape 79"/>
+          <p:cNvSpPr/>
+          <p:nvPr/>
+        </p:nvSpPr>
+        <p:spPr>
+          <a:xfrm>
+            <a:off x="5504688" y="5605272"/>
+            <a:ext cx="3008376" cy="457200"/>
+          </a:xfrm>
+          <a:prstGeom prst="rect">
+            <a:avLst/>
+          </a:prstGeom>
+          <a:solidFill>
+            <a:srgbClr val="101925"/>
           </a:solidFill>
           <a:ln w="8255">
             <a:solidFill>
@@ -7061,32 +9045,32 @@
       </p:sp>
       <p:sp>
         <p:nvSpPr>
-          <p:cNvPr id="26" name="Text 24"/>
-          <p:cNvSpPr/>
-          <p:nvPr/>
-        </p:nvSpPr>
-        <p:spPr>
-          <a:xfrm>
-            <a:off x="6638544" y="2478024"/>
-            <a:ext cx="3502152" cy="438912"/>
-          </a:xfrm>
-          <a:prstGeom prst="rect">
-            <a:avLst/>
-          </a:prstGeom>
-          <a:noFill/>
-          <a:ln/>
-        </p:spPr>
-        <p:txBody>
-          <a:bodyPr wrap="square" lIns="0" tIns="0" rIns="0" bIns="0" rtlCol="0" anchor="ctr">
-            <a:normAutofit/>
-          </a:bodyPr>
-          <a:lstStyle/>
-          <a:p>
-            <a:pPr algn="l" indent="0" marL="0">
-              <a:buNone/>
-            </a:pPr>
-            <a:r>
-              <a:rPr lang="en-US" sz="960" dirty="0">
+          <p:cNvPr id="82" name="Text 80"/>
+          <p:cNvSpPr/>
+          <p:nvPr/>
+        </p:nvSpPr>
+        <p:spPr>
+          <a:xfrm>
+            <a:off x="5596128" y="5637276"/>
+            <a:ext cx="2825496" cy="393192"/>
+          </a:xfrm>
+          <a:prstGeom prst="rect">
+            <a:avLst/>
+          </a:prstGeom>
+          <a:noFill/>
+          <a:ln/>
+        </p:spPr>
+        <p:txBody>
+          <a:bodyPr wrap="square" lIns="0" tIns="0" rIns="0" bIns="0" rtlCol="0" anchor="ctr">
+            <a:normAutofit/>
+          </a:bodyPr>
+          <a:lstStyle/>
+          <a:p>
+            <a:pPr algn="ctr" indent="0" marL="0">
+              <a:buNone/>
+            </a:pPr>
+            <a:r>
+              <a:rPr lang="en-US" sz="890" dirty="0">
                 <a:solidFill>
                   <a:srgbClr val="D9E1EC"/>
                 </a:solidFill>
@@ -7094,28 +9078,45 @@
                 <a:ea typeface="Noto Sans KR" pitchFamily="34" charset="-122"/>
                 <a:cs typeface="Noto Sans KR" pitchFamily="34" charset="-120"/>
               </a:rPr>
-              <a:t>380 usable cores / 1,520 ECPUs</a:t>
-            </a:r>
-            <a:endParaRPr lang="en-US" sz="960" dirty="0"/>
-          </a:p>
-        </p:txBody>
-      </p:sp>
-      <p:sp>
-        <p:nvSpPr>
-          <p:cNvPr id="27" name="Shape 25"/>
-          <p:cNvSpPr/>
-          <p:nvPr/>
-        </p:nvSpPr>
-        <p:spPr>
-          <a:xfrm>
-            <a:off x="10241280" y="2432304"/>
-            <a:ext cx="1261872" cy="539496"/>
-          </a:xfrm>
-          <a:prstGeom prst="rect">
-            <a:avLst/>
-          </a:prstGeom>
-          <a:solidFill>
-            <a:srgbClr val="0D1621"/>
+              <a:t>2.7 GB/s · 3,900</a:t>
+            </a:r>
+            <a:endParaRPr lang="en-US" sz="890" dirty="0"/>
+          </a:p>
+          <a:p>
+            <a:pPr algn="ctr" indent="0" marL="0">
+              <a:buNone/>
+            </a:pPr>
+            <a:r>
+              <a:rPr lang="en-US" sz="890" dirty="0">
+                <a:solidFill>
+                  <a:srgbClr val="D9E1EC"/>
+                </a:solidFill>
+                <a:latin typeface="Noto Sans KR" pitchFamily="34" charset="0"/>
+                <a:ea typeface="Noto Sans KR" pitchFamily="34" charset="-122"/>
+                <a:cs typeface="Noto Sans KR" pitchFamily="34" charset="-120"/>
+              </a:rPr>
+              <a:t>3.8 TB/hr</a:t>
+            </a:r>
+            <a:endParaRPr lang="en-US" sz="890" dirty="0"/>
+          </a:p>
+        </p:txBody>
+      </p:sp>
+      <p:sp>
+        <p:nvSpPr>
+          <p:cNvPr id="83" name="Shape 81"/>
+          <p:cNvSpPr/>
+          <p:nvPr/>
+        </p:nvSpPr>
+        <p:spPr>
+          <a:xfrm>
+            <a:off x="8513064" y="5605272"/>
+            <a:ext cx="3008376" cy="457200"/>
+          </a:xfrm>
+          <a:prstGeom prst="rect">
+            <a:avLst/>
+          </a:prstGeom>
+          <a:solidFill>
+            <a:srgbClr val="101925"/>
           </a:solidFill>
           <a:ln w="8255">
             <a:solidFill>
@@ -7127,14 +9128,14 @@
       </p:sp>
       <p:sp>
         <p:nvSpPr>
-          <p:cNvPr id="28" name="Text 26"/>
-          <p:cNvSpPr/>
-          <p:nvPr/>
-        </p:nvSpPr>
-        <p:spPr>
-          <a:xfrm>
-            <a:off x="10341864" y="2478024"/>
-            <a:ext cx="1060704" cy="438912"/>
+          <p:cNvPr id="84" name="Text 82"/>
+          <p:cNvSpPr/>
+          <p:nvPr/>
+        </p:nvSpPr>
+        <p:spPr>
+          <a:xfrm>
+            <a:off x="8604504" y="5637276"/>
+            <a:ext cx="2825496" cy="393192"/>
           </a:xfrm>
           <a:prstGeom prst="rect">
             <a:avLst/>
@@ -7152,7 +9153,7 @@
               <a:buNone/>
             </a:pPr>
             <a:r>
-              <a:rPr lang="en-US" sz="920" b="1" dirty="0">
+              <a:rPr lang="en-US" sz="890" dirty="0">
                 <a:solidFill>
                   <a:srgbClr val="2DD4BF"/>
                 </a:solidFill>
@@ -7160,263 +9161,16 @@
                 <a:ea typeface="Noto Sans KR" pitchFamily="34" charset="-122"/>
                 <a:cs typeface="Noto Sans KR" pitchFamily="34" charset="-120"/>
               </a:rPr>
-              <a:t>약 51%↑</a:t>
-            </a:r>
-            <a:endParaRPr lang="en-US" sz="920" dirty="0"/>
-          </a:p>
-        </p:txBody>
-      </p:sp>
-      <p:sp>
-        <p:nvSpPr>
-          <p:cNvPr id="29" name="Shape 27"/>
-          <p:cNvSpPr/>
-          <p:nvPr/>
-        </p:nvSpPr>
-        <p:spPr>
-          <a:xfrm>
-            <a:off x="512064" y="2971800"/>
-            <a:ext cx="2322576" cy="539496"/>
-          </a:xfrm>
-          <a:prstGeom prst="rect">
-            <a:avLst/>
-          </a:prstGeom>
-          <a:solidFill>
-            <a:srgbClr val="101925"/>
-          </a:solidFill>
-          <a:ln w="8255">
-            <a:solidFill>
-              <a:srgbClr val="33445B"/>
-            </a:solidFill>
-            <a:prstDash val="solid"/>
-          </a:ln>
-        </p:spPr>
-      </p:sp>
-      <p:sp>
-        <p:nvSpPr>
-          <p:cNvPr id="30" name="Text 28"/>
-          <p:cNvSpPr/>
-          <p:nvPr/>
-        </p:nvSpPr>
-        <p:spPr>
-          <a:xfrm>
-            <a:off x="612648" y="3017520"/>
-            <a:ext cx="2121408" cy="438912"/>
-          </a:xfrm>
-          <a:prstGeom prst="rect">
-            <a:avLst/>
-          </a:prstGeom>
-          <a:noFill/>
-          <a:ln/>
-        </p:spPr>
-        <p:txBody>
-          <a:bodyPr wrap="square" lIns="0" tIns="0" rIns="0" bIns="0" rtlCol="0" anchor="ctr">
-            <a:normAutofit/>
-          </a:bodyPr>
-          <a:lstStyle/>
-          <a:p>
-            <a:pPr algn="l" indent="0" marL="0">
-              <a:buNone/>
-            </a:pPr>
-            <a:r>
-              <a:rPr lang="en-US" sz="960" b="1" dirty="0">
-                <a:solidFill>
-                  <a:srgbClr val="F7F9FC"/>
-                </a:solidFill>
-                <a:latin typeface="Noto Sans KR" pitchFamily="34" charset="0"/>
-                <a:ea typeface="Noto Sans KR" pitchFamily="34" charset="-122"/>
-                <a:cs typeface="Noto Sans KR" pitchFamily="34" charset="-120"/>
-              </a:rPr>
-              <a:t>VM memory</a:t>
-            </a:r>
-            <a:endParaRPr lang="en-US" sz="960" dirty="0"/>
-          </a:p>
-        </p:txBody>
-      </p:sp>
-      <p:sp>
-        <p:nvSpPr>
-          <p:cNvPr id="31" name="Shape 29"/>
-          <p:cNvSpPr/>
-          <p:nvPr/>
-        </p:nvSpPr>
-        <p:spPr>
-          <a:xfrm>
-            <a:off x="2834640" y="2971800"/>
-            <a:ext cx="3703320" cy="539496"/>
-          </a:xfrm>
-          <a:prstGeom prst="rect">
-            <a:avLst/>
-          </a:prstGeom>
-          <a:solidFill>
-            <a:srgbClr val="101925"/>
-          </a:solidFill>
-          <a:ln w="8255">
-            <a:solidFill>
-              <a:srgbClr val="33445B"/>
-            </a:solidFill>
-            <a:prstDash val="solid"/>
-          </a:ln>
-        </p:spPr>
-      </p:sp>
-      <p:sp>
-        <p:nvSpPr>
-          <p:cNvPr id="32" name="Text 30"/>
-          <p:cNvSpPr/>
-          <p:nvPr/>
-        </p:nvSpPr>
-        <p:spPr>
-          <a:xfrm>
-            <a:off x="2935224" y="3017520"/>
-            <a:ext cx="3502152" cy="438912"/>
-          </a:xfrm>
-          <a:prstGeom prst="rect">
-            <a:avLst/>
-          </a:prstGeom>
-          <a:noFill/>
-          <a:ln/>
-        </p:spPr>
-        <p:txBody>
-          <a:bodyPr wrap="square" lIns="0" tIns="0" rIns="0" bIns="0" rtlCol="0" anchor="ctr">
-            <a:normAutofit/>
-          </a:bodyPr>
-          <a:lstStyle/>
-          <a:p>
-            <a:pPr algn="l" indent="0" marL="0">
-              <a:buNone/>
-            </a:pPr>
-            <a:r>
-              <a:rPr lang="en-US" sz="960" dirty="0">
-                <a:solidFill>
-                  <a:srgbClr val="D9E1EC"/>
-                </a:solidFill>
-                <a:latin typeface="Noto Sans KR" pitchFamily="34" charset="0"/>
-                <a:ea typeface="Noto Sans KR" pitchFamily="34" charset="-122"/>
-                <a:cs typeface="Noto Sans KR" pitchFamily="34" charset="-120"/>
-              </a:rPr>
-              <a:t>2,780 GB available to VMs</a:t>
-            </a:r>
-            <a:endParaRPr lang="en-US" sz="960" dirty="0"/>
-          </a:p>
-        </p:txBody>
-      </p:sp>
-      <p:sp>
-        <p:nvSpPr>
-          <p:cNvPr id="33" name="Shape 31"/>
-          <p:cNvSpPr/>
-          <p:nvPr/>
-        </p:nvSpPr>
-        <p:spPr>
-          <a:xfrm>
-            <a:off x="6537960" y="2971800"/>
-            <a:ext cx="3703320" cy="539496"/>
-          </a:xfrm>
-          <a:prstGeom prst="rect">
-            <a:avLst/>
-          </a:prstGeom>
-          <a:solidFill>
-            <a:srgbClr val="101925"/>
-          </a:solidFill>
-          <a:ln w="8255">
-            <a:solidFill>
-              <a:srgbClr val="33445B"/>
-            </a:solidFill>
-            <a:prstDash val="solid"/>
-          </a:ln>
-        </p:spPr>
-      </p:sp>
-      <p:sp>
-        <p:nvSpPr>
-          <p:cNvPr id="34" name="Text 32"/>
-          <p:cNvSpPr/>
-          <p:nvPr/>
-        </p:nvSpPr>
-        <p:spPr>
-          <a:xfrm>
-            <a:off x="6638544" y="3017520"/>
-            <a:ext cx="3502152" cy="438912"/>
-          </a:xfrm>
-          <a:prstGeom prst="rect">
-            <a:avLst/>
-          </a:prstGeom>
-          <a:noFill/>
-          <a:ln/>
-        </p:spPr>
-        <p:txBody>
-          <a:bodyPr wrap="square" lIns="0" tIns="0" rIns="0" bIns="0" rtlCol="0" anchor="ctr">
-            <a:normAutofit/>
-          </a:bodyPr>
-          <a:lstStyle/>
-          <a:p>
-            <a:pPr algn="l" indent="0" marL="0">
-              <a:buNone/>
-            </a:pPr>
-            <a:r>
-              <a:rPr lang="en-US" sz="960" dirty="0">
-                <a:solidFill>
-                  <a:srgbClr val="D9E1EC"/>
-                </a:solidFill>
-                <a:latin typeface="Noto Sans KR" pitchFamily="34" charset="0"/>
-                <a:ea typeface="Noto Sans KR" pitchFamily="34" charset="-122"/>
-                <a:cs typeface="Noto Sans KR" pitchFamily="34" charset="-120"/>
-              </a:rPr>
-              <a:t>2,780 GB available to VMs</a:t>
-            </a:r>
-            <a:endParaRPr lang="en-US" sz="960" dirty="0"/>
-          </a:p>
-        </p:txBody>
-      </p:sp>
-      <p:sp>
-        <p:nvSpPr>
-          <p:cNvPr id="35" name="Shape 33"/>
-          <p:cNvSpPr/>
-          <p:nvPr/>
-        </p:nvSpPr>
-        <p:spPr>
-          <a:xfrm>
-            <a:off x="10241280" y="2971800"/>
-            <a:ext cx="1261872" cy="539496"/>
-          </a:xfrm>
-          <a:prstGeom prst="rect">
-            <a:avLst/>
-          </a:prstGeom>
-          <a:solidFill>
-            <a:srgbClr val="101925"/>
-          </a:solidFill>
-          <a:ln w="8255">
-            <a:solidFill>
-              <a:srgbClr val="33445B"/>
-            </a:solidFill>
-            <a:prstDash val="solid"/>
-          </a:ln>
-        </p:spPr>
-      </p:sp>
-      <p:sp>
-        <p:nvSpPr>
-          <p:cNvPr id="36" name="Text 34"/>
-          <p:cNvSpPr/>
-          <p:nvPr/>
-        </p:nvSpPr>
-        <p:spPr>
-          <a:xfrm>
-            <a:off x="10341864" y="3017520"/>
-            <a:ext cx="1060704" cy="438912"/>
-          </a:xfrm>
-          <a:prstGeom prst="rect">
-            <a:avLst/>
-          </a:prstGeom>
-          <a:noFill/>
-          <a:ln/>
-        </p:spPr>
-        <p:txBody>
-          <a:bodyPr wrap="square" lIns="0" tIns="0" rIns="0" bIns="0" rtlCol="0" anchor="ctr">
-            <a:normAutofit/>
-          </a:bodyPr>
-          <a:lstStyle/>
+              <a:t>5.4 GB/s · 7,800</a:t>
+            </a:r>
+            <a:endParaRPr lang="en-US" sz="890" dirty="0"/>
+          </a:p>
           <a:p>
             <a:pPr algn="ctr" indent="0" marL="0">
               <a:buNone/>
             </a:pPr>
             <a:r>
-              <a:rPr lang="en-US" sz="920" b="1" dirty="0">
+              <a:rPr lang="en-US" sz="890" dirty="0">
                 <a:solidFill>
                   <a:srgbClr val="2DD4BF"/>
                 </a:solidFill>
@@ -7424,1414 +9178,26 @@
                 <a:ea typeface="Noto Sans KR" pitchFamily="34" charset="-122"/>
                 <a:cs typeface="Noto Sans KR" pitchFamily="34" charset="-120"/>
               </a:rPr>
-              <a:t>동일</a:t>
-            </a:r>
-            <a:endParaRPr lang="en-US" sz="920" dirty="0"/>
-          </a:p>
-        </p:txBody>
-      </p:sp>
-      <p:sp>
-        <p:nvSpPr>
-          <p:cNvPr id="37" name="Shape 35"/>
-          <p:cNvSpPr/>
-          <p:nvPr/>
-        </p:nvSpPr>
-        <p:spPr>
-          <a:xfrm>
-            <a:off x="512064" y="3511296"/>
-            <a:ext cx="2322576" cy="539496"/>
-          </a:xfrm>
-          <a:prstGeom prst="rect">
-            <a:avLst/>
-          </a:prstGeom>
-          <a:solidFill>
-            <a:srgbClr val="0D1621"/>
-          </a:solidFill>
-          <a:ln w="8255">
-            <a:solidFill>
-              <a:srgbClr val="33445B"/>
-            </a:solidFill>
-            <a:prstDash val="solid"/>
-          </a:ln>
-        </p:spPr>
-      </p:sp>
-      <p:sp>
-        <p:nvSpPr>
-          <p:cNvPr id="38" name="Text 36"/>
-          <p:cNvSpPr/>
-          <p:nvPr/>
-        </p:nvSpPr>
-        <p:spPr>
-          <a:xfrm>
-            <a:off x="612648" y="3557016"/>
-            <a:ext cx="2121408" cy="438912"/>
-          </a:xfrm>
-          <a:prstGeom prst="rect">
-            <a:avLst/>
-          </a:prstGeom>
-          <a:noFill/>
-          <a:ln/>
-        </p:spPr>
-        <p:txBody>
-          <a:bodyPr wrap="square" lIns="0" tIns="0" rIns="0" bIns="0" rtlCol="0" anchor="ctr">
-            <a:normAutofit/>
-          </a:bodyPr>
-          <a:lstStyle/>
-          <a:p>
-            <a:pPr algn="l" indent="0" marL="0">
-              <a:buNone/>
-            </a:pPr>
-            <a:r>
-              <a:rPr lang="en-US" sz="960" b="1" dirty="0">
-                <a:solidFill>
-                  <a:srgbClr val="F7F9FC"/>
-                </a:solidFill>
-                <a:latin typeface="Noto Sans KR" pitchFamily="34" charset="0"/>
-                <a:ea typeface="Noto Sans KR" pitchFamily="34" charset="-122"/>
-                <a:cs typeface="Noto Sans KR" pitchFamily="34" charset="-120"/>
-              </a:rPr>
-              <a:t>HC 구성 저장 계층</a:t>
-            </a:r>
-            <a:endParaRPr lang="en-US" sz="960" dirty="0"/>
-          </a:p>
-        </p:txBody>
-      </p:sp>
-      <p:sp>
-        <p:nvSpPr>
-          <p:cNvPr id="39" name="Shape 37"/>
-          <p:cNvSpPr/>
-          <p:nvPr/>
-        </p:nvSpPr>
-        <p:spPr>
-          <a:xfrm>
-            <a:off x="2834640" y="3511296"/>
-            <a:ext cx="3703320" cy="539496"/>
-          </a:xfrm>
-          <a:prstGeom prst="rect">
-            <a:avLst/>
-          </a:prstGeom>
-          <a:solidFill>
-            <a:srgbClr val="0D1621"/>
-          </a:solidFill>
-          <a:ln w="8255">
-            <a:solidFill>
-              <a:srgbClr val="33445B"/>
-            </a:solidFill>
-            <a:prstDash val="solid"/>
-          </a:ln>
-        </p:spPr>
-      </p:sp>
-      <p:sp>
-        <p:nvSpPr>
-          <p:cNvPr id="40" name="Text 38"/>
-          <p:cNvSpPr/>
-          <p:nvPr/>
-        </p:nvSpPr>
-        <p:spPr>
-          <a:xfrm>
-            <a:off x="2935224" y="3557016"/>
-            <a:ext cx="3502152" cy="438912"/>
-          </a:xfrm>
-          <a:prstGeom prst="rect">
-            <a:avLst/>
-          </a:prstGeom>
-          <a:noFill/>
-          <a:ln/>
-        </p:spPr>
-        <p:txBody>
-          <a:bodyPr wrap="square" lIns="0" tIns="0" rIns="0" bIns="0" rtlCol="0" anchor="ctr">
-            <a:normAutofit/>
-          </a:bodyPr>
-          <a:lstStyle/>
-          <a:p>
-            <a:pPr algn="l" indent="0" marL="0">
-              <a:buNone/>
-            </a:pPr>
-            <a:r>
-              <a:rPr lang="en-US" sz="960" dirty="0">
-                <a:solidFill>
-                  <a:srgbClr val="D9E1EC"/>
-                </a:solidFill>
-                <a:latin typeface="Noto Sans KR" pitchFamily="34" charset="0"/>
-                <a:ea typeface="Noto Sans KR" pitchFamily="34" charset="-122"/>
-                <a:cs typeface="Noto Sans KR" pitchFamily="34" charset="-120"/>
-              </a:rPr>
-              <a:t>190 TB usable disk</a:t>
-            </a:r>
-            <a:endParaRPr lang="en-US" sz="960" dirty="0"/>
-          </a:p>
-          <a:p>
-            <a:pPr algn="l" indent="0" marL="0">
-              <a:buNone/>
-            </a:pPr>
-            <a:r>
-              <a:rPr lang="en-US" sz="960" dirty="0">
-                <a:solidFill>
-                  <a:srgbClr val="D9E1EC"/>
-                </a:solidFill>
-                <a:latin typeface="Noto Sans KR" pitchFamily="34" charset="0"/>
-                <a:ea typeface="Noto Sans KR" pitchFamily="34" charset="-122"/>
-                <a:cs typeface="Noto Sans KR" pitchFamily="34" charset="-120"/>
-              </a:rPr>
-              <a:t>76.8 TB flash + 4.5 TB XRMEM</a:t>
-            </a:r>
-            <a:endParaRPr lang="en-US" sz="960" dirty="0"/>
-          </a:p>
-        </p:txBody>
-      </p:sp>
-      <p:sp>
-        <p:nvSpPr>
-          <p:cNvPr id="41" name="Shape 39"/>
-          <p:cNvSpPr/>
-          <p:nvPr/>
-        </p:nvSpPr>
-        <p:spPr>
-          <a:xfrm>
-            <a:off x="6537960" y="3511296"/>
-            <a:ext cx="3703320" cy="539496"/>
-          </a:xfrm>
-          <a:prstGeom prst="rect">
-            <a:avLst/>
-          </a:prstGeom>
-          <a:solidFill>
-            <a:srgbClr val="0D1621"/>
-          </a:solidFill>
-          <a:ln w="8255">
-            <a:solidFill>
-              <a:srgbClr val="33445B"/>
-            </a:solidFill>
-            <a:prstDash val="solid"/>
-          </a:ln>
-        </p:spPr>
-      </p:sp>
-      <p:sp>
-        <p:nvSpPr>
-          <p:cNvPr id="42" name="Text 40"/>
-          <p:cNvSpPr/>
-          <p:nvPr/>
-        </p:nvSpPr>
-        <p:spPr>
-          <a:xfrm>
-            <a:off x="6638544" y="3557016"/>
-            <a:ext cx="3502152" cy="438912"/>
-          </a:xfrm>
-          <a:prstGeom prst="rect">
-            <a:avLst/>
-          </a:prstGeom>
-          <a:noFill/>
-          <a:ln/>
-        </p:spPr>
-        <p:txBody>
-          <a:bodyPr wrap="square" lIns="0" tIns="0" rIns="0" bIns="0" rtlCol="0" anchor="ctr">
-            <a:normAutofit/>
-          </a:bodyPr>
-          <a:lstStyle/>
-          <a:p>
-            <a:pPr algn="l" indent="0" marL="0">
-              <a:buNone/>
-            </a:pPr>
-            <a:r>
-              <a:rPr lang="en-US" sz="960" dirty="0">
-                <a:solidFill>
-                  <a:srgbClr val="D9E1EC"/>
-                </a:solidFill>
-                <a:latin typeface="Noto Sans KR" pitchFamily="34" charset="0"/>
-                <a:ea typeface="Noto Sans KR" pitchFamily="34" charset="-122"/>
-                <a:cs typeface="Noto Sans KR" pitchFamily="34" charset="-120"/>
-              </a:rPr>
-              <a:t>240 TB usable disk</a:t>
-            </a:r>
-            <a:endParaRPr lang="en-US" sz="960" dirty="0"/>
-          </a:p>
-          <a:p>
-            <a:pPr algn="l" indent="0" marL="0">
-              <a:buNone/>
-            </a:pPr>
-            <a:r>
-              <a:rPr lang="en-US" sz="960" dirty="0">
-                <a:solidFill>
-                  <a:srgbClr val="D9E1EC"/>
-                </a:solidFill>
-                <a:latin typeface="Noto Sans KR" pitchFamily="34" charset="0"/>
-                <a:ea typeface="Noto Sans KR" pitchFamily="34" charset="-122"/>
-                <a:cs typeface="Noto Sans KR" pitchFamily="34" charset="-120"/>
-              </a:rPr>
-              <a:t>81.6 TB flash + 3.75 TB XRMEM</a:t>
-            </a:r>
-            <a:endParaRPr lang="en-US" sz="960" dirty="0"/>
-          </a:p>
-        </p:txBody>
-      </p:sp>
-      <p:sp>
-        <p:nvSpPr>
-          <p:cNvPr id="43" name="Shape 41"/>
-          <p:cNvSpPr/>
-          <p:nvPr/>
-        </p:nvSpPr>
-        <p:spPr>
-          <a:xfrm>
-            <a:off x="10241280" y="3511296"/>
-            <a:ext cx="1261872" cy="539496"/>
-          </a:xfrm>
-          <a:prstGeom prst="rect">
-            <a:avLst/>
-          </a:prstGeom>
-          <a:solidFill>
-            <a:srgbClr val="0D1621"/>
-          </a:solidFill>
-          <a:ln w="8255">
-            <a:solidFill>
-              <a:srgbClr val="33445B"/>
-            </a:solidFill>
-            <a:prstDash val="solid"/>
-          </a:ln>
-        </p:spPr>
-      </p:sp>
-      <p:sp>
-        <p:nvSpPr>
-          <p:cNvPr id="44" name="Text 42"/>
-          <p:cNvSpPr/>
-          <p:nvPr/>
-        </p:nvSpPr>
-        <p:spPr>
-          <a:xfrm>
-            <a:off x="10341864" y="3557016"/>
-            <a:ext cx="1060704" cy="438912"/>
-          </a:xfrm>
-          <a:prstGeom prst="rect">
-            <a:avLst/>
-          </a:prstGeom>
-          <a:noFill/>
-          <a:ln/>
-        </p:spPr>
-        <p:txBody>
-          <a:bodyPr wrap="square" lIns="0" tIns="0" rIns="0" bIns="0" rtlCol="0" anchor="ctr">
-            <a:normAutofit/>
-          </a:bodyPr>
-          <a:lstStyle/>
-          <a:p>
-            <a:pPr algn="ctr" indent="0" marL="0">
-              <a:buNone/>
-            </a:pPr>
-            <a:r>
-              <a:rPr lang="en-US" sz="920" b="1" dirty="0">
-                <a:solidFill>
-                  <a:srgbClr val="2DD4BF"/>
-                </a:solidFill>
-                <a:latin typeface="Noto Sans KR" pitchFamily="34" charset="0"/>
-                <a:ea typeface="Noto Sans KR" pitchFamily="34" charset="-122"/>
-                <a:cs typeface="Noto Sans KR" pitchFamily="34" charset="-120"/>
-              </a:rPr>
-              <a:t>Disk 26%↑ · Flash 6%↑</a:t>
-            </a:r>
-            <a:endParaRPr lang="en-US" sz="920" dirty="0"/>
-          </a:p>
-          <a:p>
-            <a:pPr algn="ctr" indent="0" marL="0">
-              <a:buNone/>
-            </a:pPr>
-            <a:r>
-              <a:rPr lang="en-US" sz="920" b="1" dirty="0">
-                <a:solidFill>
-                  <a:srgbClr val="2DD4BF"/>
-                </a:solidFill>
-                <a:latin typeface="Noto Sans KR" pitchFamily="34" charset="0"/>
-                <a:ea typeface="Noto Sans KR" pitchFamily="34" charset="-122"/>
-                <a:cs typeface="Noto Sans KR" pitchFamily="34" charset="-120"/>
-              </a:rPr>
-              <a:t>XRMEM 17%↓</a:t>
-            </a:r>
-            <a:endParaRPr lang="en-US" sz="920" dirty="0"/>
-          </a:p>
-        </p:txBody>
-      </p:sp>
-      <p:sp>
-        <p:nvSpPr>
-          <p:cNvPr id="45" name="Shape 43"/>
-          <p:cNvSpPr/>
-          <p:nvPr/>
-        </p:nvSpPr>
-        <p:spPr>
-          <a:xfrm>
-            <a:off x="512064" y="4050792"/>
-            <a:ext cx="2322576" cy="539496"/>
-          </a:xfrm>
-          <a:prstGeom prst="rect">
-            <a:avLst/>
-          </a:prstGeom>
-          <a:solidFill>
-            <a:srgbClr val="101925"/>
-          </a:solidFill>
-          <a:ln w="8255">
-            <a:solidFill>
-              <a:srgbClr val="33445B"/>
-            </a:solidFill>
-            <a:prstDash val="solid"/>
-          </a:ln>
-        </p:spPr>
-      </p:sp>
-      <p:sp>
-        <p:nvSpPr>
-          <p:cNvPr id="46" name="Text 44"/>
-          <p:cNvSpPr/>
-          <p:nvPr/>
-        </p:nvSpPr>
-        <p:spPr>
-          <a:xfrm>
-            <a:off x="612648" y="4096512"/>
-            <a:ext cx="2121408" cy="438912"/>
-          </a:xfrm>
-          <a:prstGeom prst="rect">
-            <a:avLst/>
-          </a:prstGeom>
-          <a:noFill/>
-          <a:ln/>
-        </p:spPr>
-        <p:txBody>
-          <a:bodyPr wrap="square" lIns="0" tIns="0" rIns="0" bIns="0" rtlCol="0" anchor="ctr">
-            <a:normAutofit/>
-          </a:bodyPr>
-          <a:lstStyle/>
-          <a:p>
-            <a:pPr algn="l" indent="0" marL="0">
-              <a:buNone/>
-            </a:pPr>
-            <a:r>
-              <a:rPr lang="en-US" sz="960" b="1" dirty="0">
-                <a:solidFill>
-                  <a:srgbClr val="F7F9FC"/>
-                </a:solidFill>
-                <a:latin typeface="Noto Sans KR" pitchFamily="34" charset="0"/>
-                <a:ea typeface="Noto Sans KR" pitchFamily="34" charset="-122"/>
-                <a:cs typeface="Noto Sans KR" pitchFamily="34" charset="-120"/>
-              </a:rPr>
-              <a:t>Max DB size · no backup</a:t>
-            </a:r>
-            <a:endParaRPr lang="en-US" sz="960" dirty="0"/>
-          </a:p>
-        </p:txBody>
-      </p:sp>
-      <p:sp>
-        <p:nvSpPr>
-          <p:cNvPr id="47" name="Shape 45"/>
-          <p:cNvSpPr/>
-          <p:nvPr/>
-        </p:nvSpPr>
-        <p:spPr>
-          <a:xfrm>
-            <a:off x="2834640" y="4050792"/>
-            <a:ext cx="3703320" cy="539496"/>
-          </a:xfrm>
-          <a:prstGeom prst="rect">
-            <a:avLst/>
-          </a:prstGeom>
-          <a:solidFill>
-            <a:srgbClr val="101925"/>
-          </a:solidFill>
-          <a:ln w="8255">
-            <a:solidFill>
-              <a:srgbClr val="33445B"/>
-            </a:solidFill>
-            <a:prstDash val="solid"/>
-          </a:ln>
-        </p:spPr>
-      </p:sp>
-      <p:sp>
-        <p:nvSpPr>
-          <p:cNvPr id="48" name="Text 46"/>
-          <p:cNvSpPr/>
-          <p:nvPr/>
-        </p:nvSpPr>
-        <p:spPr>
-          <a:xfrm>
-            <a:off x="2935224" y="4096512"/>
-            <a:ext cx="3502152" cy="438912"/>
-          </a:xfrm>
-          <a:prstGeom prst="rect">
-            <a:avLst/>
-          </a:prstGeom>
-          <a:noFill/>
-          <a:ln/>
-        </p:spPr>
-        <p:txBody>
-          <a:bodyPr wrap="square" lIns="0" tIns="0" rIns="0" bIns="0" rtlCol="0" anchor="ctr">
-            <a:normAutofit/>
-          </a:bodyPr>
-          <a:lstStyle/>
-          <a:p>
-            <a:pPr algn="l" indent="0" marL="0">
-              <a:buNone/>
-            </a:pPr>
-            <a:r>
-              <a:rPr lang="en-US" sz="960" dirty="0">
-                <a:solidFill>
-                  <a:srgbClr val="D9E1EC"/>
-                </a:solidFill>
-                <a:latin typeface="Noto Sans KR" pitchFamily="34" charset="0"/>
-                <a:ea typeface="Noto Sans KR" pitchFamily="34" charset="-122"/>
-                <a:cs typeface="Noto Sans KR" pitchFamily="34" charset="-120"/>
-              </a:rPr>
-              <a:t>152 TB</a:t>
-            </a:r>
-            <a:endParaRPr lang="en-US" sz="960" dirty="0"/>
-          </a:p>
-        </p:txBody>
-      </p:sp>
-      <p:sp>
-        <p:nvSpPr>
-          <p:cNvPr id="49" name="Shape 47"/>
-          <p:cNvSpPr/>
-          <p:nvPr/>
-        </p:nvSpPr>
-        <p:spPr>
-          <a:xfrm>
-            <a:off x="6537960" y="4050792"/>
-            <a:ext cx="3703320" cy="539496"/>
-          </a:xfrm>
-          <a:prstGeom prst="rect">
-            <a:avLst/>
-          </a:prstGeom>
-          <a:solidFill>
-            <a:srgbClr val="101925"/>
-          </a:solidFill>
-          <a:ln w="8255">
-            <a:solidFill>
-              <a:srgbClr val="33445B"/>
-            </a:solidFill>
-            <a:prstDash val="solid"/>
-          </a:ln>
-        </p:spPr>
-      </p:sp>
-      <p:sp>
-        <p:nvSpPr>
-          <p:cNvPr id="50" name="Text 48"/>
-          <p:cNvSpPr/>
-          <p:nvPr/>
-        </p:nvSpPr>
-        <p:spPr>
-          <a:xfrm>
-            <a:off x="6638544" y="4096512"/>
-            <a:ext cx="3502152" cy="438912"/>
-          </a:xfrm>
-          <a:prstGeom prst="rect">
-            <a:avLst/>
-          </a:prstGeom>
-          <a:noFill/>
-          <a:ln/>
-        </p:spPr>
-        <p:txBody>
-          <a:bodyPr wrap="square" lIns="0" tIns="0" rIns="0" bIns="0" rtlCol="0" anchor="ctr">
-            <a:normAutofit/>
-          </a:bodyPr>
-          <a:lstStyle/>
-          <a:p>
-            <a:pPr algn="l" indent="0" marL="0">
-              <a:buNone/>
-            </a:pPr>
-            <a:r>
-              <a:rPr lang="en-US" sz="960" dirty="0">
-                <a:solidFill>
-                  <a:srgbClr val="D9E1EC"/>
-                </a:solidFill>
-                <a:latin typeface="Noto Sans KR" pitchFamily="34" charset="0"/>
-                <a:ea typeface="Noto Sans KR" pitchFamily="34" charset="-122"/>
-                <a:cs typeface="Noto Sans KR" pitchFamily="34" charset="-120"/>
-              </a:rPr>
-              <a:t>192 TB</a:t>
-            </a:r>
-            <a:endParaRPr lang="en-US" sz="960" dirty="0"/>
-          </a:p>
-        </p:txBody>
-      </p:sp>
-      <p:sp>
-        <p:nvSpPr>
-          <p:cNvPr id="51" name="Shape 49"/>
-          <p:cNvSpPr/>
-          <p:nvPr/>
-        </p:nvSpPr>
-        <p:spPr>
-          <a:xfrm>
-            <a:off x="10241280" y="4050792"/>
-            <a:ext cx="1261872" cy="539496"/>
-          </a:xfrm>
-          <a:prstGeom prst="rect">
-            <a:avLst/>
-          </a:prstGeom>
-          <a:solidFill>
-            <a:srgbClr val="101925"/>
-          </a:solidFill>
-          <a:ln w="8255">
-            <a:solidFill>
-              <a:srgbClr val="33445B"/>
-            </a:solidFill>
-            <a:prstDash val="solid"/>
-          </a:ln>
-        </p:spPr>
-      </p:sp>
-      <p:sp>
-        <p:nvSpPr>
-          <p:cNvPr id="52" name="Text 50"/>
-          <p:cNvSpPr/>
-          <p:nvPr/>
-        </p:nvSpPr>
-        <p:spPr>
-          <a:xfrm>
-            <a:off x="10341864" y="4096512"/>
-            <a:ext cx="1060704" cy="438912"/>
-          </a:xfrm>
-          <a:prstGeom prst="rect">
-            <a:avLst/>
-          </a:prstGeom>
-          <a:noFill/>
-          <a:ln/>
-        </p:spPr>
-        <p:txBody>
-          <a:bodyPr wrap="square" lIns="0" tIns="0" rIns="0" bIns="0" rtlCol="0" anchor="ctr">
-            <a:normAutofit/>
-          </a:bodyPr>
-          <a:lstStyle/>
-          <a:p>
-            <a:pPr algn="ctr" indent="0" marL="0">
-              <a:buNone/>
-            </a:pPr>
-            <a:r>
-              <a:rPr lang="en-US" sz="920" b="1" dirty="0">
-                <a:solidFill>
-                  <a:srgbClr val="2DD4BF"/>
-                </a:solidFill>
-                <a:latin typeface="Noto Sans KR" pitchFamily="34" charset="0"/>
-                <a:ea typeface="Noto Sans KR" pitchFamily="34" charset="-122"/>
-                <a:cs typeface="Noto Sans KR" pitchFamily="34" charset="-120"/>
-              </a:rPr>
-              <a:t>약 26%↑</a:t>
-            </a:r>
-            <a:endParaRPr lang="en-US" sz="920" dirty="0"/>
-          </a:p>
-        </p:txBody>
-      </p:sp>
-      <p:sp>
-        <p:nvSpPr>
-          <p:cNvPr id="53" name="Shape 51"/>
-          <p:cNvSpPr/>
-          <p:nvPr/>
-        </p:nvSpPr>
-        <p:spPr>
-          <a:xfrm>
-            <a:off x="512064" y="4590288"/>
-            <a:ext cx="2322576" cy="539496"/>
-          </a:xfrm>
-          <a:prstGeom prst="rect">
-            <a:avLst/>
-          </a:prstGeom>
-          <a:solidFill>
-            <a:srgbClr val="0D1621"/>
-          </a:solidFill>
-          <a:ln w="8255">
-            <a:solidFill>
-              <a:srgbClr val="33445B"/>
-            </a:solidFill>
-            <a:prstDash val="solid"/>
-          </a:ln>
-        </p:spPr>
-      </p:sp>
-      <p:sp>
-        <p:nvSpPr>
-          <p:cNvPr id="54" name="Text 52"/>
-          <p:cNvSpPr/>
-          <p:nvPr/>
-        </p:nvSpPr>
-        <p:spPr>
-          <a:xfrm>
-            <a:off x="612648" y="4636008"/>
-            <a:ext cx="2121408" cy="438912"/>
-          </a:xfrm>
-          <a:prstGeom prst="rect">
-            <a:avLst/>
-          </a:prstGeom>
-          <a:noFill/>
-          <a:ln/>
-        </p:spPr>
-        <p:txBody>
-          <a:bodyPr wrap="square" lIns="0" tIns="0" rIns="0" bIns="0" rtlCol="0" anchor="ctr">
-            <a:normAutofit/>
-          </a:bodyPr>
-          <a:lstStyle/>
-          <a:p>
-            <a:pPr algn="l" indent="0" marL="0">
-              <a:buNone/>
-            </a:pPr>
-            <a:r>
-              <a:rPr lang="en-US" sz="960" b="1" dirty="0">
-                <a:solidFill>
-                  <a:srgbClr val="F7F9FC"/>
-                </a:solidFill>
-                <a:latin typeface="Noto Sans KR" pitchFamily="34" charset="0"/>
-                <a:ea typeface="Noto Sans KR" pitchFamily="34" charset="-122"/>
-                <a:cs typeface="Noto Sans KR" pitchFamily="34" charset="-120"/>
-              </a:rPr>
-              <a:t>Max SQL flash bandwidth</a:t>
-            </a:r>
-            <a:endParaRPr lang="en-US" sz="960" dirty="0"/>
-          </a:p>
-        </p:txBody>
-      </p:sp>
-      <p:sp>
-        <p:nvSpPr>
-          <p:cNvPr id="55" name="Shape 53"/>
-          <p:cNvSpPr/>
-          <p:nvPr/>
-        </p:nvSpPr>
-        <p:spPr>
-          <a:xfrm>
-            <a:off x="2834640" y="4590288"/>
-            <a:ext cx="3703320" cy="539496"/>
-          </a:xfrm>
-          <a:prstGeom prst="rect">
-            <a:avLst/>
-          </a:prstGeom>
-          <a:solidFill>
-            <a:srgbClr val="0D1621"/>
-          </a:solidFill>
-          <a:ln w="8255">
-            <a:solidFill>
-              <a:srgbClr val="33445B"/>
-            </a:solidFill>
-            <a:prstDash val="solid"/>
-          </a:ln>
-        </p:spPr>
-      </p:sp>
-      <p:sp>
-        <p:nvSpPr>
-          <p:cNvPr id="56" name="Text 54"/>
-          <p:cNvSpPr/>
-          <p:nvPr/>
-        </p:nvSpPr>
-        <p:spPr>
-          <a:xfrm>
-            <a:off x="2935224" y="4636008"/>
-            <a:ext cx="3502152" cy="438912"/>
-          </a:xfrm>
-          <a:prstGeom prst="rect">
-            <a:avLst/>
-          </a:prstGeom>
-          <a:noFill/>
-          <a:ln/>
-        </p:spPr>
-        <p:txBody>
-          <a:bodyPr wrap="square" lIns="0" tIns="0" rIns="0" bIns="0" rtlCol="0" anchor="ctr">
-            <a:normAutofit/>
-          </a:bodyPr>
-          <a:lstStyle/>
-          <a:p>
-            <a:pPr algn="l" indent="0" marL="0">
-              <a:buNone/>
-            </a:pPr>
-            <a:r>
-              <a:rPr lang="en-US" sz="960" dirty="0">
-                <a:solidFill>
-                  <a:srgbClr val="D9E1EC"/>
-                </a:solidFill>
-                <a:latin typeface="Noto Sans KR" pitchFamily="34" charset="0"/>
-                <a:ea typeface="Noto Sans KR" pitchFamily="34" charset="-122"/>
-                <a:cs typeface="Noto Sans KR" pitchFamily="34" charset="-120"/>
-              </a:rPr>
-              <a:t>135 GB/s</a:t>
-            </a:r>
-            <a:endParaRPr lang="en-US" sz="960" dirty="0"/>
-          </a:p>
-        </p:txBody>
-      </p:sp>
-      <p:sp>
-        <p:nvSpPr>
-          <p:cNvPr id="57" name="Shape 55"/>
-          <p:cNvSpPr/>
-          <p:nvPr/>
-        </p:nvSpPr>
-        <p:spPr>
-          <a:xfrm>
-            <a:off x="6537960" y="4590288"/>
-            <a:ext cx="3703320" cy="539496"/>
-          </a:xfrm>
-          <a:prstGeom prst="rect">
-            <a:avLst/>
-          </a:prstGeom>
-          <a:solidFill>
-            <a:srgbClr val="0D1621"/>
-          </a:solidFill>
-          <a:ln w="8255">
-            <a:solidFill>
-              <a:srgbClr val="33445B"/>
-            </a:solidFill>
-            <a:prstDash val="solid"/>
-          </a:ln>
-        </p:spPr>
-      </p:sp>
-      <p:sp>
-        <p:nvSpPr>
-          <p:cNvPr id="58" name="Text 56"/>
-          <p:cNvSpPr/>
-          <p:nvPr/>
-        </p:nvSpPr>
-        <p:spPr>
-          <a:xfrm>
-            <a:off x="6638544" y="4636008"/>
-            <a:ext cx="3502152" cy="438912"/>
-          </a:xfrm>
-          <a:prstGeom prst="rect">
-            <a:avLst/>
-          </a:prstGeom>
-          <a:noFill/>
-          <a:ln/>
-        </p:spPr>
-        <p:txBody>
-          <a:bodyPr wrap="square" lIns="0" tIns="0" rIns="0" bIns="0" rtlCol="0" anchor="ctr">
-            <a:normAutofit/>
-          </a:bodyPr>
-          <a:lstStyle/>
-          <a:p>
-            <a:pPr algn="l" indent="0" marL="0">
-              <a:buNone/>
-            </a:pPr>
-            <a:r>
-              <a:rPr lang="en-US" sz="960" dirty="0">
-                <a:solidFill>
-                  <a:srgbClr val="D9E1EC"/>
-                </a:solidFill>
-                <a:latin typeface="Noto Sans KR" pitchFamily="34" charset="0"/>
-                <a:ea typeface="Noto Sans KR" pitchFamily="34" charset="-122"/>
-                <a:cs typeface="Noto Sans KR" pitchFamily="34" charset="-120"/>
-              </a:rPr>
-              <a:t>300 GB/s</a:t>
-            </a:r>
-            <a:endParaRPr lang="en-US" sz="960" dirty="0"/>
-          </a:p>
-        </p:txBody>
-      </p:sp>
-      <p:sp>
-        <p:nvSpPr>
-          <p:cNvPr id="59" name="Shape 57"/>
-          <p:cNvSpPr/>
-          <p:nvPr/>
-        </p:nvSpPr>
-        <p:spPr>
-          <a:xfrm>
-            <a:off x="10241280" y="4590288"/>
-            <a:ext cx="1261872" cy="539496"/>
-          </a:xfrm>
-          <a:prstGeom prst="rect">
-            <a:avLst/>
-          </a:prstGeom>
-          <a:solidFill>
-            <a:srgbClr val="0D1621"/>
-          </a:solidFill>
-          <a:ln w="8255">
-            <a:solidFill>
-              <a:srgbClr val="33445B"/>
-            </a:solidFill>
-            <a:prstDash val="solid"/>
-          </a:ln>
-        </p:spPr>
-      </p:sp>
-      <p:sp>
-        <p:nvSpPr>
-          <p:cNvPr id="60" name="Text 58"/>
-          <p:cNvSpPr/>
-          <p:nvPr/>
-        </p:nvSpPr>
-        <p:spPr>
-          <a:xfrm>
-            <a:off x="10341864" y="4636008"/>
-            <a:ext cx="1060704" cy="438912"/>
-          </a:xfrm>
-          <a:prstGeom prst="rect">
-            <a:avLst/>
-          </a:prstGeom>
-          <a:noFill/>
-          <a:ln/>
-        </p:spPr>
-        <p:txBody>
-          <a:bodyPr wrap="square" lIns="0" tIns="0" rIns="0" bIns="0" rtlCol="0" anchor="ctr">
-            <a:normAutofit/>
-          </a:bodyPr>
-          <a:lstStyle/>
-          <a:p>
-            <a:pPr algn="ctr" indent="0" marL="0">
-              <a:buNone/>
-            </a:pPr>
-            <a:r>
-              <a:rPr lang="en-US" sz="920" b="1" dirty="0">
-                <a:solidFill>
-                  <a:srgbClr val="2DD4BF"/>
-                </a:solidFill>
-                <a:latin typeface="Noto Sans KR" pitchFamily="34" charset="0"/>
-                <a:ea typeface="Noto Sans KR" pitchFamily="34" charset="-122"/>
-                <a:cs typeface="Noto Sans KR" pitchFamily="34" charset="-120"/>
-              </a:rPr>
-              <a:t>약 122%↑</a:t>
-            </a:r>
-            <a:endParaRPr lang="en-US" sz="920" dirty="0"/>
-          </a:p>
-        </p:txBody>
-      </p:sp>
-      <p:sp>
-        <p:nvSpPr>
-          <p:cNvPr id="61" name="Shape 59"/>
-          <p:cNvSpPr/>
-          <p:nvPr/>
-        </p:nvSpPr>
-        <p:spPr>
-          <a:xfrm>
-            <a:off x="512064" y="5129784"/>
-            <a:ext cx="2322576" cy="539496"/>
-          </a:xfrm>
-          <a:prstGeom prst="rect">
-            <a:avLst/>
-          </a:prstGeom>
-          <a:solidFill>
-            <a:srgbClr val="101925"/>
-          </a:solidFill>
-          <a:ln w="8255">
-            <a:solidFill>
-              <a:srgbClr val="33445B"/>
-            </a:solidFill>
-            <a:prstDash val="solid"/>
-          </a:ln>
-        </p:spPr>
-      </p:sp>
-      <p:sp>
-        <p:nvSpPr>
-          <p:cNvPr id="62" name="Text 60"/>
-          <p:cNvSpPr/>
-          <p:nvPr/>
-        </p:nvSpPr>
-        <p:spPr>
-          <a:xfrm>
-            <a:off x="612648" y="5175504"/>
-            <a:ext cx="2121408" cy="438912"/>
-          </a:xfrm>
-          <a:prstGeom prst="rect">
-            <a:avLst/>
-          </a:prstGeom>
-          <a:noFill/>
-          <a:ln/>
-        </p:spPr>
-        <p:txBody>
-          <a:bodyPr wrap="square" lIns="0" tIns="0" rIns="0" bIns="0" rtlCol="0" anchor="ctr">
-            <a:normAutofit/>
-          </a:bodyPr>
-          <a:lstStyle/>
-          <a:p>
-            <a:pPr algn="l" indent="0" marL="0">
-              <a:buNone/>
-            </a:pPr>
-            <a:r>
-              <a:rPr lang="en-US" sz="960" b="1" dirty="0">
-                <a:solidFill>
-                  <a:srgbClr val="F7F9FC"/>
-                </a:solidFill>
-                <a:latin typeface="Noto Sans KR" pitchFamily="34" charset="0"/>
-                <a:ea typeface="Noto Sans KR" pitchFamily="34" charset="-122"/>
-                <a:cs typeface="Noto Sans KR" pitchFamily="34" charset="-120"/>
-              </a:rPr>
-              <a:t>Max SQL Read / Write IOPS</a:t>
-            </a:r>
-            <a:endParaRPr lang="en-US" sz="960" dirty="0"/>
-          </a:p>
-        </p:txBody>
-      </p:sp>
-      <p:sp>
-        <p:nvSpPr>
-          <p:cNvPr id="63" name="Shape 61"/>
-          <p:cNvSpPr/>
-          <p:nvPr/>
-        </p:nvSpPr>
-        <p:spPr>
-          <a:xfrm>
-            <a:off x="2834640" y="5129784"/>
-            <a:ext cx="3703320" cy="539496"/>
-          </a:xfrm>
-          <a:prstGeom prst="rect">
-            <a:avLst/>
-          </a:prstGeom>
-          <a:solidFill>
-            <a:srgbClr val="101925"/>
-          </a:solidFill>
-          <a:ln w="8255">
-            <a:solidFill>
-              <a:srgbClr val="33445B"/>
-            </a:solidFill>
-            <a:prstDash val="solid"/>
-          </a:ln>
-        </p:spPr>
-      </p:sp>
-      <p:sp>
-        <p:nvSpPr>
-          <p:cNvPr id="64" name="Text 62"/>
-          <p:cNvSpPr/>
-          <p:nvPr/>
-        </p:nvSpPr>
-        <p:spPr>
-          <a:xfrm>
-            <a:off x="2935224" y="5175504"/>
-            <a:ext cx="3502152" cy="438912"/>
-          </a:xfrm>
-          <a:prstGeom prst="rect">
-            <a:avLst/>
-          </a:prstGeom>
-          <a:noFill/>
-          <a:ln/>
-        </p:spPr>
-        <p:txBody>
-          <a:bodyPr wrap="square" lIns="0" tIns="0" rIns="0" bIns="0" rtlCol="0" anchor="ctr">
-            <a:normAutofit/>
-          </a:bodyPr>
-          <a:lstStyle/>
-          <a:p>
-            <a:pPr algn="l" indent="0" marL="0">
-              <a:buNone/>
-            </a:pPr>
-            <a:r>
-              <a:rPr lang="en-US" sz="960" dirty="0">
-                <a:solidFill>
-                  <a:srgbClr val="D9E1EC"/>
-                </a:solidFill>
-                <a:latin typeface="Noto Sans KR" pitchFamily="34" charset="0"/>
-                <a:ea typeface="Noto Sans KR" pitchFamily="34" charset="-122"/>
-                <a:cs typeface="Noto Sans KR" pitchFamily="34" charset="-120"/>
-              </a:rPr>
-              <a:t>5.6M / 1.842M</a:t>
-            </a:r>
-            <a:endParaRPr lang="en-US" sz="960" dirty="0"/>
-          </a:p>
-        </p:txBody>
-      </p:sp>
-      <p:sp>
-        <p:nvSpPr>
-          <p:cNvPr id="65" name="Shape 63"/>
-          <p:cNvSpPr/>
-          <p:nvPr/>
-        </p:nvSpPr>
-        <p:spPr>
-          <a:xfrm>
-            <a:off x="6537960" y="5129784"/>
-            <a:ext cx="3703320" cy="539496"/>
-          </a:xfrm>
-          <a:prstGeom prst="rect">
-            <a:avLst/>
-          </a:prstGeom>
-          <a:solidFill>
-            <a:srgbClr val="101925"/>
-          </a:solidFill>
-          <a:ln w="8255">
-            <a:solidFill>
-              <a:srgbClr val="33445B"/>
-            </a:solidFill>
-            <a:prstDash val="solid"/>
-          </a:ln>
-        </p:spPr>
-      </p:sp>
-      <p:sp>
-        <p:nvSpPr>
-          <p:cNvPr id="66" name="Text 64"/>
-          <p:cNvSpPr/>
-          <p:nvPr/>
-        </p:nvSpPr>
-        <p:spPr>
-          <a:xfrm>
-            <a:off x="6638544" y="5175504"/>
-            <a:ext cx="3502152" cy="438912"/>
-          </a:xfrm>
-          <a:prstGeom prst="rect">
-            <a:avLst/>
-          </a:prstGeom>
-          <a:noFill/>
-          <a:ln/>
-        </p:spPr>
-        <p:txBody>
-          <a:bodyPr wrap="square" lIns="0" tIns="0" rIns="0" bIns="0" rtlCol="0" anchor="ctr">
-            <a:normAutofit/>
-          </a:bodyPr>
-          <a:lstStyle/>
-          <a:p>
-            <a:pPr algn="l" indent="0" marL="0">
-              <a:buNone/>
-            </a:pPr>
-            <a:r>
-              <a:rPr lang="en-US" sz="960" dirty="0">
-                <a:solidFill>
-                  <a:srgbClr val="D9E1EC"/>
-                </a:solidFill>
-                <a:latin typeface="Noto Sans KR" pitchFamily="34" charset="0"/>
-                <a:ea typeface="Noto Sans KR" pitchFamily="34" charset="-122"/>
-                <a:cs typeface="Noto Sans KR" pitchFamily="34" charset="-120"/>
-              </a:rPr>
-              <a:t>5.6M / 3.0M</a:t>
-            </a:r>
-            <a:endParaRPr lang="en-US" sz="960" dirty="0"/>
-          </a:p>
-        </p:txBody>
-      </p:sp>
-      <p:sp>
-        <p:nvSpPr>
-          <p:cNvPr id="67" name="Shape 65"/>
-          <p:cNvSpPr/>
-          <p:nvPr/>
-        </p:nvSpPr>
-        <p:spPr>
-          <a:xfrm>
-            <a:off x="10241280" y="5129784"/>
-            <a:ext cx="1261872" cy="539496"/>
-          </a:xfrm>
-          <a:prstGeom prst="rect">
-            <a:avLst/>
-          </a:prstGeom>
-          <a:solidFill>
-            <a:srgbClr val="101925"/>
-          </a:solidFill>
-          <a:ln w="8255">
-            <a:solidFill>
-              <a:srgbClr val="33445B"/>
-            </a:solidFill>
-            <a:prstDash val="solid"/>
-          </a:ln>
-        </p:spPr>
-      </p:sp>
-      <p:sp>
-        <p:nvSpPr>
-          <p:cNvPr id="68" name="Text 66"/>
-          <p:cNvSpPr/>
-          <p:nvPr/>
-        </p:nvSpPr>
-        <p:spPr>
-          <a:xfrm>
-            <a:off x="10341864" y="5175504"/>
-            <a:ext cx="1060704" cy="438912"/>
-          </a:xfrm>
-          <a:prstGeom prst="rect">
-            <a:avLst/>
-          </a:prstGeom>
-          <a:noFill/>
-          <a:ln/>
-        </p:spPr>
-        <p:txBody>
-          <a:bodyPr wrap="square" lIns="0" tIns="0" rIns="0" bIns="0" rtlCol="0" anchor="ctr">
-            <a:normAutofit/>
-          </a:bodyPr>
-          <a:lstStyle/>
-          <a:p>
-            <a:pPr algn="ctr" indent="0" marL="0">
-              <a:buNone/>
-            </a:pPr>
-            <a:r>
-              <a:rPr lang="en-US" sz="920" b="1" dirty="0">
-                <a:solidFill>
-                  <a:srgbClr val="2DD4BF"/>
-                </a:solidFill>
-                <a:latin typeface="Noto Sans KR" pitchFamily="34" charset="0"/>
-                <a:ea typeface="Noto Sans KR" pitchFamily="34" charset="-122"/>
-                <a:cs typeface="Noto Sans KR" pitchFamily="34" charset="-120"/>
-              </a:rPr>
-              <a:t>읽기 동일</a:t>
-            </a:r>
-            <a:endParaRPr lang="en-US" sz="920" dirty="0"/>
-          </a:p>
-          <a:p>
-            <a:pPr algn="ctr" indent="0" marL="0">
-              <a:buNone/>
-            </a:pPr>
-            <a:r>
-              <a:rPr lang="en-US" sz="920" b="1" dirty="0">
-                <a:solidFill>
-                  <a:srgbClr val="2DD4BF"/>
-                </a:solidFill>
-                <a:latin typeface="Noto Sans KR" pitchFamily="34" charset="0"/>
-                <a:ea typeface="Noto Sans KR" pitchFamily="34" charset="-122"/>
-                <a:cs typeface="Noto Sans KR" pitchFamily="34" charset="-120"/>
-              </a:rPr>
-              <a:t>쓰기 약 63%↑</a:t>
-            </a:r>
-            <a:endParaRPr lang="en-US" sz="920" dirty="0"/>
-          </a:p>
-        </p:txBody>
-      </p:sp>
-      <p:sp>
-        <p:nvSpPr>
-          <p:cNvPr id="69" name="Shape 67"/>
-          <p:cNvSpPr/>
-          <p:nvPr/>
-        </p:nvSpPr>
-        <p:spPr>
-          <a:xfrm>
-            <a:off x="512064" y="5669280"/>
-            <a:ext cx="2322576" cy="539496"/>
-          </a:xfrm>
-          <a:prstGeom prst="rect">
-            <a:avLst/>
-          </a:prstGeom>
-          <a:solidFill>
-            <a:srgbClr val="0D1621"/>
-          </a:solidFill>
-          <a:ln w="8255">
-            <a:solidFill>
-              <a:srgbClr val="33445B"/>
-            </a:solidFill>
-            <a:prstDash val="solid"/>
-          </a:ln>
-        </p:spPr>
-      </p:sp>
-      <p:sp>
-        <p:nvSpPr>
-          <p:cNvPr id="70" name="Text 68"/>
-          <p:cNvSpPr/>
-          <p:nvPr/>
-        </p:nvSpPr>
-        <p:spPr>
-          <a:xfrm>
-            <a:off x="612648" y="5715000"/>
-            <a:ext cx="2121408" cy="438912"/>
-          </a:xfrm>
-          <a:prstGeom prst="rect">
-            <a:avLst/>
-          </a:prstGeom>
-          <a:noFill/>
-          <a:ln/>
-        </p:spPr>
-        <p:txBody>
-          <a:bodyPr wrap="square" lIns="0" tIns="0" rIns="0" bIns="0" rtlCol="0" anchor="ctr">
-            <a:normAutofit/>
-          </a:bodyPr>
-          <a:lstStyle/>
-          <a:p>
-            <a:pPr algn="l" indent="0" marL="0">
-              <a:buNone/>
-            </a:pPr>
-            <a:r>
-              <a:rPr lang="en-US" sz="960" b="1" dirty="0">
-                <a:solidFill>
-                  <a:srgbClr val="F7F9FC"/>
-                </a:solidFill>
-                <a:latin typeface="Noto Sans KR" pitchFamily="34" charset="0"/>
-                <a:ea typeface="Noto Sans KR" pitchFamily="34" charset="-122"/>
-                <a:cs typeface="Noto Sans KR" pitchFamily="34" charset="-120"/>
-              </a:rPr>
-              <a:t>VM Cluster / Network</a:t>
-            </a:r>
-            <a:endParaRPr lang="en-US" sz="960" dirty="0"/>
-          </a:p>
-        </p:txBody>
-      </p:sp>
-      <p:sp>
-        <p:nvSpPr>
-          <p:cNvPr id="71" name="Shape 69"/>
-          <p:cNvSpPr/>
-          <p:nvPr/>
-        </p:nvSpPr>
-        <p:spPr>
-          <a:xfrm>
-            <a:off x="2834640" y="5669280"/>
-            <a:ext cx="3703320" cy="539496"/>
-          </a:xfrm>
-          <a:prstGeom prst="rect">
-            <a:avLst/>
-          </a:prstGeom>
-          <a:solidFill>
-            <a:srgbClr val="0D1621"/>
-          </a:solidFill>
-          <a:ln w="8255">
-            <a:solidFill>
-              <a:srgbClr val="33445B"/>
-            </a:solidFill>
-            <a:prstDash val="solid"/>
-          </a:ln>
-        </p:spPr>
-      </p:sp>
-      <p:sp>
-        <p:nvSpPr>
-          <p:cNvPr id="72" name="Text 70"/>
-          <p:cNvSpPr/>
-          <p:nvPr/>
-        </p:nvSpPr>
-        <p:spPr>
-          <a:xfrm>
-            <a:off x="2935224" y="5715000"/>
-            <a:ext cx="3502152" cy="438912"/>
-          </a:xfrm>
-          <a:prstGeom prst="rect">
-            <a:avLst/>
-          </a:prstGeom>
-          <a:noFill/>
-          <a:ln/>
-        </p:spPr>
-        <p:txBody>
-          <a:bodyPr wrap="square" lIns="0" tIns="0" rIns="0" bIns="0" rtlCol="0" anchor="ctr">
-            <a:normAutofit/>
-          </a:bodyPr>
-          <a:lstStyle/>
-          <a:p>
-            <a:pPr algn="l" indent="0" marL="0">
-              <a:buNone/>
-            </a:pPr>
-            <a:r>
-              <a:rPr lang="en-US" sz="960" dirty="0">
-                <a:solidFill>
-                  <a:srgbClr val="D9E1EC"/>
-                </a:solidFill>
-                <a:latin typeface="Noto Sans KR" pitchFamily="34" charset="0"/>
-                <a:ea typeface="Noto Sans KR" pitchFamily="34" charset="-122"/>
-                <a:cs typeface="Noto Sans KR" pitchFamily="34" charset="-120"/>
-              </a:rPr>
-              <a:t>최대 8 · 50 GbE</a:t>
-            </a:r>
-            <a:endParaRPr lang="en-US" sz="960" dirty="0"/>
-          </a:p>
-        </p:txBody>
-      </p:sp>
-      <p:sp>
-        <p:nvSpPr>
-          <p:cNvPr id="73" name="Shape 71"/>
-          <p:cNvSpPr/>
-          <p:nvPr/>
-        </p:nvSpPr>
-        <p:spPr>
-          <a:xfrm>
-            <a:off x="6537960" y="5669280"/>
-            <a:ext cx="3703320" cy="539496"/>
-          </a:xfrm>
-          <a:prstGeom prst="rect">
-            <a:avLst/>
-          </a:prstGeom>
-          <a:solidFill>
-            <a:srgbClr val="0D1621"/>
-          </a:solidFill>
-          <a:ln w="8255">
-            <a:solidFill>
-              <a:srgbClr val="33445B"/>
-            </a:solidFill>
-            <a:prstDash val="solid"/>
-          </a:ln>
-        </p:spPr>
-      </p:sp>
-      <p:sp>
-        <p:nvSpPr>
-          <p:cNvPr id="74" name="Text 72"/>
-          <p:cNvSpPr/>
-          <p:nvPr/>
-        </p:nvSpPr>
-        <p:spPr>
-          <a:xfrm>
-            <a:off x="6638544" y="5715000"/>
-            <a:ext cx="3502152" cy="438912"/>
-          </a:xfrm>
-          <a:prstGeom prst="rect">
-            <a:avLst/>
-          </a:prstGeom>
-          <a:noFill/>
-          <a:ln/>
-        </p:spPr>
-        <p:txBody>
-          <a:bodyPr wrap="square" lIns="0" tIns="0" rIns="0" bIns="0" rtlCol="0" anchor="ctr">
-            <a:normAutofit/>
-          </a:bodyPr>
-          <a:lstStyle/>
-          <a:p>
-            <a:pPr algn="l" indent="0" marL="0">
-              <a:buNone/>
-            </a:pPr>
-            <a:r>
-              <a:rPr lang="en-US" sz="960" dirty="0">
-                <a:solidFill>
-                  <a:srgbClr val="D9E1EC"/>
-                </a:solidFill>
-                <a:latin typeface="Noto Sans KR" pitchFamily="34" charset="0"/>
-                <a:ea typeface="Noto Sans KR" pitchFamily="34" charset="-122"/>
-                <a:cs typeface="Noto Sans KR" pitchFamily="34" charset="-120"/>
-              </a:rPr>
-              <a:t>최대 12 · 25/100 GbE</a:t>
-            </a:r>
-            <a:endParaRPr lang="en-US" sz="960" dirty="0"/>
-          </a:p>
-        </p:txBody>
-      </p:sp>
-      <p:sp>
-        <p:nvSpPr>
-          <p:cNvPr id="75" name="Shape 73"/>
-          <p:cNvSpPr/>
-          <p:nvPr/>
-        </p:nvSpPr>
-        <p:spPr>
-          <a:xfrm>
-            <a:off x="10241280" y="5669280"/>
-            <a:ext cx="1261872" cy="539496"/>
-          </a:xfrm>
-          <a:prstGeom prst="rect">
-            <a:avLst/>
-          </a:prstGeom>
-          <a:solidFill>
-            <a:srgbClr val="0D1621"/>
-          </a:solidFill>
-          <a:ln w="8255">
-            <a:solidFill>
-              <a:srgbClr val="33445B"/>
-            </a:solidFill>
-            <a:prstDash val="solid"/>
-          </a:ln>
-        </p:spPr>
-      </p:sp>
-      <p:sp>
-        <p:nvSpPr>
-          <p:cNvPr id="76" name="Text 74"/>
-          <p:cNvSpPr/>
-          <p:nvPr/>
-        </p:nvSpPr>
-        <p:spPr>
-          <a:xfrm>
-            <a:off x="10341864" y="5715000"/>
-            <a:ext cx="1060704" cy="438912"/>
-          </a:xfrm>
-          <a:prstGeom prst="rect">
-            <a:avLst/>
-          </a:prstGeom>
-          <a:noFill/>
-          <a:ln/>
-        </p:spPr>
-        <p:txBody>
-          <a:bodyPr wrap="square" lIns="0" tIns="0" rIns="0" bIns="0" rtlCol="0" anchor="ctr">
-            <a:normAutofit/>
-          </a:bodyPr>
-          <a:lstStyle/>
-          <a:p>
-            <a:pPr algn="ctr" indent="0" marL="0">
-              <a:buNone/>
-            </a:pPr>
-            <a:r>
-              <a:rPr lang="en-US" sz="920" b="1" dirty="0">
-                <a:solidFill>
-                  <a:srgbClr val="F6B44B"/>
-                </a:solidFill>
-                <a:latin typeface="Noto Sans KR" pitchFamily="34" charset="0"/>
-                <a:ea typeface="Noto Sans KR" pitchFamily="34" charset="-122"/>
-                <a:cs typeface="Noto Sans KR" pitchFamily="34" charset="-120"/>
-              </a:rPr>
-              <a:t>확장</a:t>
-            </a:r>
-            <a:endParaRPr lang="en-US" sz="920" dirty="0"/>
-          </a:p>
-        </p:txBody>
-      </p:sp>
-      <p:sp>
-        <p:nvSpPr>
-          <p:cNvPr id="77" name="Shape 75"/>
-          <p:cNvSpPr/>
-          <p:nvPr/>
-        </p:nvSpPr>
-        <p:spPr>
-          <a:xfrm>
-            <a:off x="512064" y="6263640"/>
-            <a:ext cx="11173968" cy="164592"/>
+              <a:t>7.5 TB/hr</a:t>
+            </a:r>
+            <a:endParaRPr lang="en-US" sz="890" dirty="0"/>
+          </a:p>
+        </p:txBody>
+      </p:sp>
+      <p:sp>
+        <p:nvSpPr>
+          <p:cNvPr id="85" name="Shape 83"/>
+          <p:cNvSpPr/>
+          <p:nvPr/>
+        </p:nvSpPr>
+        <p:spPr>
+          <a:xfrm>
+            <a:off x="512064" y="6108192"/>
+            <a:ext cx="11009376" cy="246888"/>
           </a:xfrm>
           <a:prstGeom prst="roundRect">
             <a:avLst>
-              <a:gd name="adj" fmla="val 11111"/>
+              <a:gd name="adj" fmla="val 7407"/>
             </a:avLst>
           </a:prstGeom>
           <a:solidFill>
@@ -8854,14 +9220,14 @@
       </p:sp>
       <p:sp>
         <p:nvSpPr>
-          <p:cNvPr id="78" name="Text 76"/>
-          <p:cNvSpPr/>
-          <p:nvPr/>
-        </p:nvSpPr>
-        <p:spPr>
-          <a:xfrm>
-            <a:off x="621792" y="6254496"/>
-            <a:ext cx="10881360" cy="155448"/>
+          <p:cNvPr id="86" name="Text 84"/>
+          <p:cNvSpPr/>
+          <p:nvPr/>
+        </p:nvSpPr>
+        <p:spPr>
+          <a:xfrm>
+            <a:off x="621792" y="6144768"/>
+            <a:ext cx="10789920" cy="164592"/>
           </a:xfrm>
           <a:prstGeom prst="rect">
             <a:avLst/>
@@ -8887,7 +9253,7 @@
                 <a:ea typeface="Noto Sans KR" pitchFamily="34" charset="-122"/>
                 <a:cs typeface="Noto Sans KR" pitchFamily="34" charset="-120"/>
               </a:rPr>
-              <a:t>ExaCC X11M에는 공식 Quarter Rack shape가 없음 · 본 장표는 2 Standard DB + 3 HC w/XRMEM Elastic 구성 비교 · OCPU/ECPU 직접 등가 비교 불가</a:t>
+              <a:t>¹ ASM High Redundancy usable · X9M physical core와 ExaC@C usable core/ECPU는 직접 등가 비교 불가 · X11M에는 공식 Quarter Rack shape가 없음</a:t>
             </a:r>
             <a:endParaRPr lang="en-US" sz="810" dirty="0"/>
           </a:p>
@@ -8895,7 +9261,7 @@
       </p:sp>
       <p:sp>
         <p:nvSpPr>
-          <p:cNvPr id="79" name="Shape 77"/>
+          <p:cNvPr id="87" name="Shape 85"/>
           <p:cNvSpPr/>
           <p:nvPr/>
         </p:nvSpPr>
@@ -8918,7 +9284,7 @@
       </p:sp>
       <p:sp>
         <p:nvSpPr>
-          <p:cNvPr id="80" name="Text 78"/>
+          <p:cNvPr id="88" name="Text 86"/>
           <p:cNvSpPr/>
           <p:nvPr/>
         </p:nvSpPr>
@@ -8959,7 +9325,7 @@
       </p:sp>
       <p:sp>
         <p:nvSpPr>
-          <p:cNvPr id="81" name="Text 79"/>
+          <p:cNvPr id="89" name="Text 87"/>
           <p:cNvSpPr/>
           <p:nvPr/>
         </p:nvSpPr>
@@ -8992,7 +9358,7 @@
                 <a:ea typeface="Noto Sans KR" pitchFamily="34" charset="-122"/>
                 <a:cs typeface="Noto Sans KR" pitchFamily="34" charset="-120"/>
               </a:rPr>
-              <a:t>Sources: 첨부 X9M Cloud Infrastructure DS v1.11 Table 1 · ExaCC X11M DS v1.5 Table 1</a:t>
+              <a:t>Sources: Oracle Exadata Database Machine X9M-2 DS (2023) pp.20–23 · ExaC@C X11M DS v1.5 Table 1</a:t>
             </a:r>
             <a:endParaRPr lang="en-US" sz="680" dirty="0"/>
           </a:p>

</xml_diff>

<commit_message>
docs: apply independent QA to Exadata comparison
</commit_message>
<xml_diff>
--- a/hermes_docs/exadata-x9m-to-exacc-x11m-transition.pptx
+++ b/hermes_docs/exadata-x9m-to-exacc-x11m-transition.pptx
@@ -6351,7 +6351,7 @@
                 <a:ea typeface="Noto Sans KR" pitchFamily="34" charset="-122"/>
                 <a:cs typeface="Noto Sans KR" pitchFamily="34" charset="-120"/>
               </a:rPr>
-              <a:t>온프레미스 최소 구성과 Cloud@Customer의 Base 및 Quarter 상당 2+3 Elastic 구성을 동일 지표로 비교</a:t>
+              <a:t>온프레미스 최소 구성과 Cloud@Customer Base 및 공식 Quarter shape가 아닌 2 DB + 3 Storage Elastic 비교</a:t>
             </a:r>
             <a:endParaRPr lang="en-US" sz="1050" dirty="0"/>
           </a:p>
@@ -6376,7 +6376,7 @@
           </a:solidFill>
           <a:ln w="8890">
             <a:solidFill>
-              <a:srgbClr val="36465C"/>
+              <a:srgbClr val="4B6078"/>
             </a:solidFill>
             <a:prstDash val="solid"/>
           </a:ln>
@@ -6438,11 +6438,11 @@
             <a:avLst/>
           </a:prstGeom>
           <a:solidFill>
-            <a:srgbClr val="263449"/>
+            <a:srgbClr val="2C405E"/>
           </a:solidFill>
           <a:ln w="8890">
             <a:solidFill>
-              <a:srgbClr val="36465C"/>
+              <a:srgbClr val="4B6078"/>
             </a:solidFill>
             <a:prstDash val="solid"/>
           </a:ln>
@@ -6521,11 +6521,11 @@
             <a:avLst/>
           </a:prstGeom>
           <a:solidFill>
-            <a:srgbClr val="203247"/>
+            <a:srgbClr val="244860"/>
           </a:solidFill>
           <a:ln w="8890">
             <a:solidFill>
-              <a:srgbClr val="36465C"/>
+              <a:srgbClr val="4B6078"/>
             </a:solidFill>
             <a:prstDash val="solid"/>
           </a:ln>
@@ -6604,11 +6604,11 @@
             <a:avLst/>
           </a:prstGeom>
           <a:solidFill>
-            <a:srgbClr val="173A3D"/>
+            <a:srgbClr val="16504A"/>
           </a:solidFill>
           <a:ln w="8890">
             <a:solidFill>
-              <a:srgbClr val="36465C"/>
+              <a:srgbClr val="4B6078"/>
             </a:solidFill>
             <a:prstDash val="solid"/>
           </a:ln>
@@ -6691,7 +6691,7 @@
           </a:solidFill>
           <a:ln w="8255">
             <a:solidFill>
-              <a:srgbClr val="33445B"/>
+              <a:srgbClr val="3D5169"/>
             </a:solidFill>
             <a:prstDash val="solid"/>
           </a:ln>
@@ -6724,7 +6724,7 @@
               <a:buNone/>
             </a:pPr>
             <a:r>
-              <a:rPr lang="en-US" sz="900" b="1" dirty="0">
+              <a:rPr lang="en-US" sz="910" b="1" dirty="0">
                 <a:solidFill>
                   <a:srgbClr val="F7F9FC"/>
                 </a:solidFill>
@@ -6734,7 +6734,7 @@
               </a:rPr>
               <a:t>물리 구성</a:t>
             </a:r>
-            <a:endParaRPr lang="en-US" sz="900" dirty="0"/>
+            <a:endParaRPr lang="en-US" sz="910" dirty="0"/>
           </a:p>
         </p:txBody>
       </p:sp>
@@ -6757,7 +6757,7 @@
           </a:solidFill>
           <a:ln w="8255">
             <a:solidFill>
-              <a:srgbClr val="33445B"/>
+              <a:srgbClr val="3D5169"/>
             </a:solidFill>
             <a:prstDash val="solid"/>
           </a:ln>
@@ -6790,9 +6790,9 @@
               <a:buNone/>
             </a:pPr>
             <a:r>
-              <a:rPr lang="en-US" sz="890" dirty="0">
-                <a:solidFill>
-                  <a:srgbClr val="D9E1EC"/>
+              <a:rPr lang="en-US" sz="900" dirty="0">
+                <a:solidFill>
+                  <a:srgbClr val="CAD5E3"/>
                 </a:solidFill>
                 <a:latin typeface="Noto Sans KR" pitchFamily="34" charset="0"/>
                 <a:ea typeface="Noto Sans KR" pitchFamily="34" charset="-122"/>
@@ -6800,7 +6800,7 @@
               </a:rPr>
               <a:t>2 DB + 3 Eighth HC</a:t>
             </a:r>
-            <a:endParaRPr lang="en-US" sz="890" dirty="0"/>
+            <a:endParaRPr lang="en-US" sz="900" dirty="0"/>
           </a:p>
         </p:txBody>
       </p:sp>
@@ -6823,7 +6823,7 @@
           </a:solidFill>
           <a:ln w="8255">
             <a:solidFill>
-              <a:srgbClr val="33445B"/>
+              <a:srgbClr val="3D5169"/>
             </a:solidFill>
             <a:prstDash val="solid"/>
           </a:ln>
@@ -6856,9 +6856,9 @@
               <a:buNone/>
             </a:pPr>
             <a:r>
-              <a:rPr lang="en-US" sz="890" dirty="0">
-                <a:solidFill>
-                  <a:srgbClr val="D9E1EC"/>
+              <a:rPr lang="en-US" sz="900" dirty="0">
+                <a:solidFill>
+                  <a:srgbClr val="CAD5E3"/>
                 </a:solidFill>
                 <a:latin typeface="Noto Sans KR" pitchFamily="34" charset="0"/>
                 <a:ea typeface="Noto Sans KR" pitchFamily="34" charset="-122"/>
@@ -6866,7 +6866,7 @@
               </a:rPr>
               <a:t>2 Base DB + 3 Base Storage</a:t>
             </a:r>
-            <a:endParaRPr lang="en-US" sz="890" dirty="0"/>
+            <a:endParaRPr lang="en-US" sz="900" dirty="0"/>
           </a:p>
         </p:txBody>
       </p:sp>
@@ -6889,7 +6889,7 @@
           </a:solidFill>
           <a:ln w="8255">
             <a:solidFill>
-              <a:srgbClr val="33445B"/>
+              <a:srgbClr val="3D5169"/>
             </a:solidFill>
             <a:prstDash val="solid"/>
           </a:ln>
@@ -6922,7 +6922,7 @@
               <a:buNone/>
             </a:pPr>
             <a:r>
-              <a:rPr lang="en-US" sz="890" dirty="0">
+              <a:rPr lang="en-US" sz="900" dirty="0">
                 <a:solidFill>
                   <a:srgbClr val="2DD4BF"/>
                 </a:solidFill>
@@ -6932,7 +6932,7 @@
               </a:rPr>
               <a:t>2 Standard DB + 3 HC w/XRMEM</a:t>
             </a:r>
-            <a:endParaRPr lang="en-US" sz="890" dirty="0"/>
+            <a:endParaRPr lang="en-US" sz="900" dirty="0"/>
           </a:p>
         </p:txBody>
       </p:sp>
@@ -6955,7 +6955,7 @@
           </a:solidFill>
           <a:ln w="8255">
             <a:solidFill>
-              <a:srgbClr val="33445B"/>
+              <a:srgbClr val="3D5169"/>
             </a:solidFill>
             <a:prstDash val="solid"/>
           </a:ln>
@@ -6988,7 +6988,7 @@
               <a:buNone/>
             </a:pPr>
             <a:r>
-              <a:rPr lang="en-US" sz="900" b="1" dirty="0">
+              <a:rPr lang="en-US" sz="910" b="1" dirty="0">
                 <a:solidFill>
                   <a:srgbClr val="F7F9FC"/>
                 </a:solidFill>
@@ -6996,9 +6996,9 @@
                 <a:ea typeface="Noto Sans KR" pitchFamily="34" charset="-122"/>
                 <a:cs typeface="Noto Sans KR" pitchFamily="34" charset="-120"/>
               </a:rPr>
-              <a:t>DB compute</a:t>
-            </a:r>
-            <a:endParaRPr lang="en-US" sz="900" dirty="0"/>
+              <a:t>DB CPU¹</a:t>
+            </a:r>
+            <a:endParaRPr lang="en-US" sz="910" dirty="0"/>
           </a:p>
         </p:txBody>
       </p:sp>
@@ -7021,7 +7021,7 @@
           </a:solidFill>
           <a:ln w="8255">
             <a:solidFill>
-              <a:srgbClr val="33445B"/>
+              <a:srgbClr val="3D5169"/>
             </a:solidFill>
             <a:prstDash val="solid"/>
           </a:ln>
@@ -7054,17 +7054,17 @@
               <a:buNone/>
             </a:pPr>
             <a:r>
-              <a:rPr lang="en-US" sz="890" dirty="0">
-                <a:solidFill>
-                  <a:srgbClr val="D9E1EC"/>
-                </a:solidFill>
-                <a:latin typeface="Noto Sans KR" pitchFamily="34" charset="0"/>
-                <a:ea typeface="Noto Sans KR" pitchFamily="34" charset="-122"/>
-                <a:cs typeface="Noto Sans KR" pitchFamily="34" charset="-120"/>
-              </a:rPr>
-              <a:t>64 physical cores</a:t>
-            </a:r>
-            <a:endParaRPr lang="en-US" sz="890" dirty="0"/>
+              <a:rPr lang="en-US" sz="900" dirty="0">
+                <a:solidFill>
+                  <a:srgbClr val="CAD5E3"/>
+                </a:solidFill>
+                <a:latin typeface="Noto Sans KR" pitchFamily="34" charset="0"/>
+                <a:ea typeface="Noto Sans KR" pitchFamily="34" charset="-122"/>
+                <a:cs typeface="Noto Sans KR" pitchFamily="34" charset="-120"/>
+              </a:rPr>
+              <a:t>64 physical cores¹</a:t>
+            </a:r>
+            <a:endParaRPr lang="en-US" sz="900" dirty="0"/>
           </a:p>
         </p:txBody>
       </p:sp>
@@ -7087,7 +7087,7 @@
           </a:solidFill>
           <a:ln w="8255">
             <a:solidFill>
-              <a:srgbClr val="33445B"/>
+              <a:srgbClr val="3D5169"/>
             </a:solidFill>
             <a:prstDash val="solid"/>
           </a:ln>
@@ -7120,9 +7120,9 @@
               <a:buNone/>
             </a:pPr>
             <a:r>
-              <a:rPr lang="en-US" sz="890" dirty="0">
-                <a:solidFill>
-                  <a:srgbClr val="D9E1EC"/>
+              <a:rPr lang="en-US" sz="900" dirty="0">
+                <a:solidFill>
+                  <a:srgbClr val="CAD5E3"/>
                 </a:solidFill>
                 <a:latin typeface="Noto Sans KR" pitchFamily="34" charset="0"/>
                 <a:ea typeface="Noto Sans KR" pitchFamily="34" charset="-122"/>
@@ -7130,24 +7130,24 @@
               </a:rPr>
               <a:t>60 usable cores</a:t>
             </a:r>
-            <a:endParaRPr lang="en-US" sz="890" dirty="0"/>
+            <a:endParaRPr lang="en-US" sz="900" dirty="0"/>
           </a:p>
           <a:p>
             <a:pPr algn="ctr" indent="0" marL="0">
               <a:buNone/>
             </a:pPr>
             <a:r>
-              <a:rPr lang="en-US" sz="890" dirty="0">
-                <a:solidFill>
-                  <a:srgbClr val="D9E1EC"/>
-                </a:solidFill>
-                <a:latin typeface="Noto Sans KR" pitchFamily="34" charset="0"/>
-                <a:ea typeface="Noto Sans KR" pitchFamily="34" charset="-122"/>
-                <a:cs typeface="Noto Sans KR" pitchFamily="34" charset="-120"/>
-              </a:rPr>
-              <a:t>240 ECPUs</a:t>
-            </a:r>
-            <a:endParaRPr lang="en-US" sz="890" dirty="0"/>
+              <a:rPr lang="en-US" sz="900" dirty="0">
+                <a:solidFill>
+                  <a:srgbClr val="CAD5E3"/>
+                </a:solidFill>
+                <a:latin typeface="Noto Sans KR" pitchFamily="34" charset="0"/>
+                <a:ea typeface="Noto Sans KR" pitchFamily="34" charset="-122"/>
+                <a:cs typeface="Noto Sans KR" pitchFamily="34" charset="-120"/>
+              </a:rPr>
+              <a:t>240 ECPUs¹</a:t>
+            </a:r>
+            <a:endParaRPr lang="en-US" sz="900" dirty="0"/>
           </a:p>
         </p:txBody>
       </p:sp>
@@ -7170,7 +7170,7 @@
           </a:solidFill>
           <a:ln w="8255">
             <a:solidFill>
-              <a:srgbClr val="33445B"/>
+              <a:srgbClr val="3D5169"/>
             </a:solidFill>
             <a:prstDash val="solid"/>
           </a:ln>
@@ -7203,7 +7203,7 @@
               <a:buNone/>
             </a:pPr>
             <a:r>
-              <a:rPr lang="en-US" sz="890" dirty="0">
+              <a:rPr lang="en-US" sz="900" dirty="0">
                 <a:solidFill>
                   <a:srgbClr val="2DD4BF"/>
                 </a:solidFill>
@@ -7213,14 +7213,14 @@
               </a:rPr>
               <a:t>380 usable cores</a:t>
             </a:r>
-            <a:endParaRPr lang="en-US" sz="890" dirty="0"/>
+            <a:endParaRPr lang="en-US" sz="900" dirty="0"/>
           </a:p>
           <a:p>
             <a:pPr algn="ctr" indent="0" marL="0">
               <a:buNone/>
             </a:pPr>
             <a:r>
-              <a:rPr lang="en-US" sz="890" dirty="0">
+              <a:rPr lang="en-US" sz="900" dirty="0">
                 <a:solidFill>
                   <a:srgbClr val="2DD4BF"/>
                 </a:solidFill>
@@ -7228,9 +7228,9 @@
                 <a:ea typeface="Noto Sans KR" pitchFamily="34" charset="-122"/>
                 <a:cs typeface="Noto Sans KR" pitchFamily="34" charset="-120"/>
               </a:rPr>
-              <a:t>1,520 ECPUs</a:t>
-            </a:r>
-            <a:endParaRPr lang="en-US" sz="890" dirty="0"/>
+              <a:t>1,520 ECPUs¹</a:t>
+            </a:r>
+            <a:endParaRPr lang="en-US" sz="900" dirty="0"/>
           </a:p>
         </p:txBody>
       </p:sp>
@@ -7253,7 +7253,7 @@
           </a:solidFill>
           <a:ln w="8255">
             <a:solidFill>
-              <a:srgbClr val="33445B"/>
+              <a:srgbClr val="3D5169"/>
             </a:solidFill>
             <a:prstDash val="solid"/>
           </a:ln>
@@ -7286,7 +7286,7 @@
               <a:buNone/>
             </a:pPr>
             <a:r>
-              <a:rPr lang="en-US" sz="900" b="1" dirty="0">
+              <a:rPr lang="en-US" sz="910" b="1" dirty="0">
                 <a:solidFill>
                   <a:srgbClr val="F7F9FC"/>
                 </a:solidFill>
@@ -7296,7 +7296,7 @@
               </a:rPr>
               <a:t>DB memory</a:t>
             </a:r>
-            <a:endParaRPr lang="en-US" sz="900" dirty="0"/>
+            <a:endParaRPr lang="en-US" sz="910" dirty="0"/>
           </a:p>
         </p:txBody>
       </p:sp>
@@ -7319,7 +7319,7 @@
           </a:solidFill>
           <a:ln w="8255">
             <a:solidFill>
-              <a:srgbClr val="33445B"/>
+              <a:srgbClr val="3D5169"/>
             </a:solidFill>
             <a:prstDash val="solid"/>
           </a:ln>
@@ -7352,9 +7352,9 @@
               <a:buNone/>
             </a:pPr>
             <a:r>
-              <a:rPr lang="en-US" sz="890" dirty="0">
-                <a:solidFill>
-                  <a:srgbClr val="D9E1EC"/>
+              <a:rPr lang="en-US" sz="900" dirty="0">
+                <a:solidFill>
+                  <a:srgbClr val="CAD5E3"/>
                 </a:solidFill>
                 <a:latin typeface="Noto Sans KR" pitchFamily="34" charset="0"/>
                 <a:ea typeface="Noto Sans KR" pitchFamily="34" charset="-122"/>
@@ -7362,16 +7362,16 @@
               </a:rPr>
               <a:t>768 GB default</a:t>
             </a:r>
-            <a:endParaRPr lang="en-US" sz="890" dirty="0"/>
+            <a:endParaRPr lang="en-US" sz="900" dirty="0"/>
           </a:p>
           <a:p>
             <a:pPr algn="ctr" indent="0" marL="0">
               <a:buNone/>
             </a:pPr>
             <a:r>
-              <a:rPr lang="en-US" sz="890" dirty="0">
-                <a:solidFill>
-                  <a:srgbClr val="D9E1EC"/>
+              <a:rPr lang="en-US" sz="900" dirty="0">
+                <a:solidFill>
+                  <a:srgbClr val="CAD5E3"/>
                 </a:solidFill>
                 <a:latin typeface="Noto Sans KR" pitchFamily="34" charset="0"/>
                 <a:ea typeface="Noto Sans KR" pitchFamily="34" charset="-122"/>
@@ -7379,7 +7379,7 @@
               </a:rPr>
               <a:t>최대 2,048 GB</a:t>
             </a:r>
-            <a:endParaRPr lang="en-US" sz="890" dirty="0"/>
+            <a:endParaRPr lang="en-US" sz="900" dirty="0"/>
           </a:p>
         </p:txBody>
       </p:sp>
@@ -7402,7 +7402,7 @@
           </a:solidFill>
           <a:ln w="8255">
             <a:solidFill>
-              <a:srgbClr val="33445B"/>
+              <a:srgbClr val="3D5169"/>
             </a:solidFill>
             <a:prstDash val="solid"/>
           </a:ln>
@@ -7435,9 +7435,9 @@
               <a:buNone/>
             </a:pPr>
             <a:r>
-              <a:rPr lang="en-US" sz="890" dirty="0">
-                <a:solidFill>
-                  <a:srgbClr val="D9E1EC"/>
+              <a:rPr lang="en-US" sz="900" dirty="0">
+                <a:solidFill>
+                  <a:srgbClr val="CAD5E3"/>
                 </a:solidFill>
                 <a:latin typeface="Noto Sans KR" pitchFamily="34" charset="0"/>
                 <a:ea typeface="Noto Sans KR" pitchFamily="34" charset="-122"/>
@@ -7445,16 +7445,16 @@
               </a:rPr>
               <a:t>1,320 GB</a:t>
             </a:r>
-            <a:endParaRPr lang="en-US" sz="890" dirty="0"/>
+            <a:endParaRPr lang="en-US" sz="900" dirty="0"/>
           </a:p>
           <a:p>
             <a:pPr algn="ctr" indent="0" marL="0">
               <a:buNone/>
             </a:pPr>
             <a:r>
-              <a:rPr lang="en-US" sz="890" dirty="0">
-                <a:solidFill>
-                  <a:srgbClr val="D9E1EC"/>
+              <a:rPr lang="en-US" sz="900" dirty="0">
+                <a:solidFill>
+                  <a:srgbClr val="CAD5E3"/>
                 </a:solidFill>
                 <a:latin typeface="Noto Sans KR" pitchFamily="34" charset="0"/>
                 <a:ea typeface="Noto Sans KR" pitchFamily="34" charset="-122"/>
@@ -7462,7 +7462,7 @@
               </a:rPr>
               <a:t>available to VMs</a:t>
             </a:r>
-            <a:endParaRPr lang="en-US" sz="890" dirty="0"/>
+            <a:endParaRPr lang="en-US" sz="900" dirty="0"/>
           </a:p>
         </p:txBody>
       </p:sp>
@@ -7485,7 +7485,7 @@
           </a:solidFill>
           <a:ln w="8255">
             <a:solidFill>
-              <a:srgbClr val="33445B"/>
+              <a:srgbClr val="3D5169"/>
             </a:solidFill>
             <a:prstDash val="solid"/>
           </a:ln>
@@ -7518,7 +7518,7 @@
               <a:buNone/>
             </a:pPr>
             <a:r>
-              <a:rPr lang="en-US" sz="890" dirty="0">
+              <a:rPr lang="en-US" sz="900" dirty="0">
                 <a:solidFill>
                   <a:srgbClr val="2DD4BF"/>
                 </a:solidFill>
@@ -7528,14 +7528,14 @@
               </a:rPr>
               <a:t>2,780 GB</a:t>
             </a:r>
-            <a:endParaRPr lang="en-US" sz="890" dirty="0"/>
+            <a:endParaRPr lang="en-US" sz="900" dirty="0"/>
           </a:p>
           <a:p>
             <a:pPr algn="ctr" indent="0" marL="0">
               <a:buNone/>
             </a:pPr>
             <a:r>
-              <a:rPr lang="en-US" sz="890" dirty="0">
+              <a:rPr lang="en-US" sz="900" dirty="0">
                 <a:solidFill>
                   <a:srgbClr val="2DD4BF"/>
                 </a:solidFill>
@@ -7545,7 +7545,7 @@
               </a:rPr>
               <a:t>available to VMs</a:t>
             </a:r>
-            <a:endParaRPr lang="en-US" sz="890" dirty="0"/>
+            <a:endParaRPr lang="en-US" sz="900" dirty="0"/>
           </a:p>
         </p:txBody>
       </p:sp>
@@ -7568,7 +7568,7 @@
           </a:solidFill>
           <a:ln w="8255">
             <a:solidFill>
-              <a:srgbClr val="33445B"/>
+              <a:srgbClr val="3D5169"/>
             </a:solidFill>
             <a:prstDash val="solid"/>
           </a:ln>
@@ -7601,7 +7601,7 @@
               <a:buNone/>
             </a:pPr>
             <a:r>
-              <a:rPr lang="en-US" sz="900" b="1" dirty="0">
+              <a:rPr lang="en-US" sz="910" b="1" dirty="0">
                 <a:solidFill>
                   <a:srgbClr val="F7F9FC"/>
                 </a:solidFill>
@@ -7611,7 +7611,7 @@
               </a:rPr>
               <a:t>Storage compute</a:t>
             </a:r>
-            <a:endParaRPr lang="en-US" sz="900" dirty="0"/>
+            <a:endParaRPr lang="en-US" sz="910" dirty="0"/>
           </a:p>
         </p:txBody>
       </p:sp>
@@ -7634,7 +7634,7 @@
           </a:solidFill>
           <a:ln w="8255">
             <a:solidFill>
-              <a:srgbClr val="33445B"/>
+              <a:srgbClr val="3D5169"/>
             </a:solidFill>
             <a:prstDash val="solid"/>
           </a:ln>
@@ -7667,9 +7667,9 @@
               <a:buNone/>
             </a:pPr>
             <a:r>
-              <a:rPr lang="en-US" sz="890" dirty="0">
-                <a:solidFill>
-                  <a:srgbClr val="D9E1EC"/>
+              <a:rPr lang="en-US" sz="900" dirty="0">
+                <a:solidFill>
+                  <a:srgbClr val="CAD5E3"/>
                 </a:solidFill>
                 <a:latin typeface="Noto Sans KR" pitchFamily="34" charset="0"/>
                 <a:ea typeface="Noto Sans KR" pitchFamily="34" charset="-122"/>
@@ -7677,7 +7677,7 @@
               </a:rPr>
               <a:t>48 storage cores</a:t>
             </a:r>
-            <a:endParaRPr lang="en-US" sz="890" dirty="0"/>
+            <a:endParaRPr lang="en-US" sz="900" dirty="0"/>
           </a:p>
         </p:txBody>
       </p:sp>
@@ -7700,7 +7700,7 @@
           </a:solidFill>
           <a:ln w="8255">
             <a:solidFill>
-              <a:srgbClr val="33445B"/>
+              <a:srgbClr val="3D5169"/>
             </a:solidFill>
             <a:prstDash val="solid"/>
           </a:ln>
@@ -7733,9 +7733,9 @@
               <a:buNone/>
             </a:pPr>
             <a:r>
-              <a:rPr lang="en-US" sz="890" dirty="0">
-                <a:solidFill>
-                  <a:srgbClr val="D9E1EC"/>
+              <a:rPr lang="en-US" sz="900" dirty="0">
+                <a:solidFill>
+                  <a:srgbClr val="CAD5E3"/>
                 </a:solidFill>
                 <a:latin typeface="Noto Sans KR" pitchFamily="34" charset="0"/>
                 <a:ea typeface="Noto Sans KR" pitchFamily="34" charset="-122"/>
@@ -7743,7 +7743,7 @@
               </a:rPr>
               <a:t>96 storage cores</a:t>
             </a:r>
-            <a:endParaRPr lang="en-US" sz="890" dirty="0"/>
+            <a:endParaRPr lang="en-US" sz="900" dirty="0"/>
           </a:p>
         </p:txBody>
       </p:sp>
@@ -7766,7 +7766,7 @@
           </a:solidFill>
           <a:ln w="8255">
             <a:solidFill>
-              <a:srgbClr val="33445B"/>
+              <a:srgbClr val="3D5169"/>
             </a:solidFill>
             <a:prstDash val="solid"/>
           </a:ln>
@@ -7799,7 +7799,7 @@
               <a:buNone/>
             </a:pPr>
             <a:r>
-              <a:rPr lang="en-US" sz="890" dirty="0">
+              <a:rPr lang="en-US" sz="900" dirty="0">
                 <a:solidFill>
                   <a:srgbClr val="2DD4BF"/>
                 </a:solidFill>
@@ -7809,7 +7809,7 @@
               </a:rPr>
               <a:t>192 storage cores</a:t>
             </a:r>
-            <a:endParaRPr lang="en-US" sz="890" dirty="0"/>
+            <a:endParaRPr lang="en-US" sz="900" dirty="0"/>
           </a:p>
         </p:txBody>
       </p:sp>
@@ -7832,7 +7832,7 @@
           </a:solidFill>
           <a:ln w="8255">
             <a:solidFill>
-              <a:srgbClr val="33445B"/>
+              <a:srgbClr val="3D5169"/>
             </a:solidFill>
             <a:prstDash val="solid"/>
           </a:ln>
@@ -7865,7 +7865,7 @@
               <a:buNone/>
             </a:pPr>
             <a:r>
-              <a:rPr lang="en-US" sz="900" b="1" dirty="0">
+              <a:rPr lang="en-US" sz="910" b="1" dirty="0">
                 <a:solidFill>
                   <a:srgbClr val="F7F9FC"/>
                 </a:solidFill>
@@ -7875,7 +7875,7 @@
               </a:rPr>
               <a:t>HC usable (ASM HR)¹</a:t>
             </a:r>
-            <a:endParaRPr lang="en-US" sz="900" dirty="0"/>
+            <a:endParaRPr lang="en-US" sz="910" dirty="0"/>
           </a:p>
         </p:txBody>
       </p:sp>
@@ -7898,7 +7898,7 @@
           </a:solidFill>
           <a:ln w="8255">
             <a:solidFill>
-              <a:srgbClr val="33445B"/>
+              <a:srgbClr val="3D5169"/>
             </a:solidFill>
             <a:prstDash val="solid"/>
           </a:ln>
@@ -7931,9 +7931,9 @@
               <a:buNone/>
             </a:pPr>
             <a:r>
-              <a:rPr lang="en-US" sz="890" dirty="0">
-                <a:solidFill>
-                  <a:srgbClr val="D9E1EC"/>
+              <a:rPr lang="en-US" sz="900" dirty="0">
+                <a:solidFill>
+                  <a:srgbClr val="CAD5E3"/>
                 </a:solidFill>
                 <a:latin typeface="Noto Sans KR" pitchFamily="34" charset="0"/>
                 <a:ea typeface="Noto Sans KR" pitchFamily="34" charset="-122"/>
@@ -7941,7 +7941,7 @@
               </a:rPr>
               <a:t>96.2 TB</a:t>
             </a:r>
-            <a:endParaRPr lang="en-US" sz="890" dirty="0"/>
+            <a:endParaRPr lang="en-US" sz="900" dirty="0"/>
           </a:p>
         </p:txBody>
       </p:sp>
@@ -7964,7 +7964,7 @@
           </a:solidFill>
           <a:ln w="8255">
             <a:solidFill>
-              <a:srgbClr val="33445B"/>
+              <a:srgbClr val="3D5169"/>
             </a:solidFill>
             <a:prstDash val="solid"/>
           </a:ln>
@@ -7997,9 +7997,9 @@
               <a:buNone/>
             </a:pPr>
             <a:r>
-              <a:rPr lang="en-US" sz="890" dirty="0">
-                <a:solidFill>
-                  <a:srgbClr val="D9E1EC"/>
+              <a:rPr lang="en-US" sz="900" dirty="0">
+                <a:solidFill>
+                  <a:srgbClr val="CAD5E3"/>
                 </a:solidFill>
                 <a:latin typeface="Noto Sans KR" pitchFamily="34" charset="0"/>
                 <a:ea typeface="Noto Sans KR" pitchFamily="34" charset="-122"/>
@@ -8007,7 +8007,7 @@
               </a:rPr>
               <a:t>106 TB</a:t>
             </a:r>
-            <a:endParaRPr lang="en-US" sz="890" dirty="0"/>
+            <a:endParaRPr lang="en-US" sz="900" dirty="0"/>
           </a:p>
         </p:txBody>
       </p:sp>
@@ -8030,7 +8030,7 @@
           </a:solidFill>
           <a:ln w="8255">
             <a:solidFill>
-              <a:srgbClr val="33445B"/>
+              <a:srgbClr val="3D5169"/>
             </a:solidFill>
             <a:prstDash val="solid"/>
           </a:ln>
@@ -8063,7 +8063,7 @@
               <a:buNone/>
             </a:pPr>
             <a:r>
-              <a:rPr lang="en-US" sz="890" dirty="0">
+              <a:rPr lang="en-US" sz="900" dirty="0">
                 <a:solidFill>
                   <a:srgbClr val="2DD4BF"/>
                 </a:solidFill>
@@ -8073,7 +8073,7 @@
               </a:rPr>
               <a:t>240 TB</a:t>
             </a:r>
-            <a:endParaRPr lang="en-US" sz="890" dirty="0"/>
+            <a:endParaRPr lang="en-US" sz="900" dirty="0"/>
           </a:p>
         </p:txBody>
       </p:sp>
@@ -8096,7 +8096,7 @@
           </a:solidFill>
           <a:ln w="8255">
             <a:solidFill>
-              <a:srgbClr val="33445B"/>
+              <a:srgbClr val="3D5169"/>
             </a:solidFill>
             <a:prstDash val="solid"/>
           </a:ln>
@@ -8129,7 +8129,7 @@
               <a:buNone/>
             </a:pPr>
             <a:r>
-              <a:rPr lang="en-US" sz="900" b="1" dirty="0">
+              <a:rPr lang="en-US" sz="910" b="1" dirty="0">
                 <a:solidFill>
                   <a:srgbClr val="F7F9FC"/>
                 </a:solidFill>
@@ -8139,7 +8139,7 @@
               </a:rPr>
               <a:t>Flash · PMEM/XRMEM</a:t>
             </a:r>
-            <a:endParaRPr lang="en-US" sz="900" dirty="0"/>
+            <a:endParaRPr lang="en-US" sz="910" dirty="0"/>
           </a:p>
         </p:txBody>
       </p:sp>
@@ -8162,7 +8162,7 @@
           </a:solidFill>
           <a:ln w="8255">
             <a:solidFill>
-              <a:srgbClr val="33445B"/>
+              <a:srgbClr val="3D5169"/>
             </a:solidFill>
             <a:prstDash val="solid"/>
           </a:ln>
@@ -8195,9 +8195,9 @@
               <a:buNone/>
             </a:pPr>
             <a:r>
-              <a:rPr lang="en-US" sz="890" dirty="0">
-                <a:solidFill>
-                  <a:srgbClr val="D9E1EC"/>
+              <a:rPr lang="en-US" sz="900" dirty="0">
+                <a:solidFill>
+                  <a:srgbClr val="CAD5E3"/>
                 </a:solidFill>
                 <a:latin typeface="Noto Sans KR" pitchFamily="34" charset="0"/>
                 <a:ea typeface="Noto Sans KR" pitchFamily="34" charset="-122"/>
@@ -8205,7 +8205,7 @@
               </a:rPr>
               <a:t>38.4 TB · 2.3 TB PMEM</a:t>
             </a:r>
-            <a:endParaRPr lang="en-US" sz="890" dirty="0"/>
+            <a:endParaRPr lang="en-US" sz="900" dirty="0"/>
           </a:p>
         </p:txBody>
       </p:sp>
@@ -8228,7 +8228,7 @@
           </a:solidFill>
           <a:ln w="8255">
             <a:solidFill>
-              <a:srgbClr val="33445B"/>
+              <a:srgbClr val="3D5169"/>
             </a:solidFill>
             <a:prstDash val="solid"/>
           </a:ln>
@@ -8261,9 +8261,9 @@
               <a:buNone/>
             </a:pPr>
             <a:r>
-              <a:rPr lang="en-US" sz="890" dirty="0">
-                <a:solidFill>
-                  <a:srgbClr val="D9E1EC"/>
+              <a:rPr lang="en-US" sz="900" dirty="0">
+                <a:solidFill>
+                  <a:srgbClr val="CAD5E3"/>
                 </a:solidFill>
                 <a:latin typeface="Noto Sans KR" pitchFamily="34" charset="0"/>
                 <a:ea typeface="Noto Sans KR" pitchFamily="34" charset="-122"/>
@@ -8271,7 +8271,7 @@
               </a:rPr>
               <a:t>38.4 TB · XRMEM 없음</a:t>
             </a:r>
-            <a:endParaRPr lang="en-US" sz="890" dirty="0"/>
+            <a:endParaRPr lang="en-US" sz="900" dirty="0"/>
           </a:p>
         </p:txBody>
       </p:sp>
@@ -8294,7 +8294,7 @@
           </a:solidFill>
           <a:ln w="8255">
             <a:solidFill>
-              <a:srgbClr val="33445B"/>
+              <a:srgbClr val="3D5169"/>
             </a:solidFill>
             <a:prstDash val="solid"/>
           </a:ln>
@@ -8327,7 +8327,7 @@
               <a:buNone/>
             </a:pPr>
             <a:r>
-              <a:rPr lang="en-US" sz="890" dirty="0">
+              <a:rPr lang="en-US" sz="900" dirty="0">
                 <a:solidFill>
                   <a:srgbClr val="2DD4BF"/>
                 </a:solidFill>
@@ -8337,7 +8337,7 @@
               </a:rPr>
               <a:t>81.6 TB · 3.75 TB XRMEM</a:t>
             </a:r>
-            <a:endParaRPr lang="en-US" sz="890" dirty="0"/>
+            <a:endParaRPr lang="en-US" sz="900" dirty="0"/>
           </a:p>
         </p:txBody>
       </p:sp>
@@ -8360,7 +8360,7 @@
           </a:solidFill>
           <a:ln w="8255">
             <a:solidFill>
-              <a:srgbClr val="33445B"/>
+              <a:srgbClr val="3D5169"/>
             </a:solidFill>
             <a:prstDash val="solid"/>
           </a:ln>
@@ -8393,7 +8393,7 @@
               <a:buNone/>
             </a:pPr>
             <a:r>
-              <a:rPr lang="en-US" sz="900" b="1" dirty="0">
+              <a:rPr lang="en-US" sz="910" b="1" dirty="0">
                 <a:solidFill>
                   <a:srgbClr val="F7F9FC"/>
                 </a:solidFill>
@@ -8403,7 +8403,7 @@
               </a:rPr>
               <a:t>Max SQL flash BW</a:t>
             </a:r>
-            <a:endParaRPr lang="en-US" sz="900" dirty="0"/>
+            <a:endParaRPr lang="en-US" sz="910" dirty="0"/>
           </a:p>
         </p:txBody>
       </p:sp>
@@ -8426,7 +8426,7 @@
           </a:solidFill>
           <a:ln w="8255">
             <a:solidFill>
-              <a:srgbClr val="33445B"/>
+              <a:srgbClr val="3D5169"/>
             </a:solidFill>
             <a:prstDash val="solid"/>
           </a:ln>
@@ -8459,9 +8459,9 @@
               <a:buNone/>
             </a:pPr>
             <a:r>
-              <a:rPr lang="en-US" sz="890" dirty="0">
-                <a:solidFill>
-                  <a:srgbClr val="D9E1EC"/>
+              <a:rPr lang="en-US" sz="900" dirty="0">
+                <a:solidFill>
+                  <a:srgbClr val="CAD5E3"/>
                 </a:solidFill>
                 <a:latin typeface="Noto Sans KR" pitchFamily="34" charset="0"/>
                 <a:ea typeface="Noto Sans KR" pitchFamily="34" charset="-122"/>
@@ -8469,7 +8469,7 @@
               </a:rPr>
               <a:t>67.5 GB/s</a:t>
             </a:r>
-            <a:endParaRPr lang="en-US" sz="890" dirty="0"/>
+            <a:endParaRPr lang="en-US" sz="900" dirty="0"/>
           </a:p>
         </p:txBody>
       </p:sp>
@@ -8492,7 +8492,7 @@
           </a:solidFill>
           <a:ln w="8255">
             <a:solidFill>
-              <a:srgbClr val="33445B"/>
+              <a:srgbClr val="3D5169"/>
             </a:solidFill>
             <a:prstDash val="solid"/>
           </a:ln>
@@ -8525,9 +8525,9 @@
               <a:buNone/>
             </a:pPr>
             <a:r>
-              <a:rPr lang="en-US" sz="890" dirty="0">
-                <a:solidFill>
-                  <a:srgbClr val="D9E1EC"/>
+              <a:rPr lang="en-US" sz="900" dirty="0">
+                <a:solidFill>
+                  <a:srgbClr val="CAD5E3"/>
                 </a:solidFill>
                 <a:latin typeface="Noto Sans KR" pitchFamily="34" charset="0"/>
                 <a:ea typeface="Noto Sans KR" pitchFamily="34" charset="-122"/>
@@ -8535,7 +8535,7 @@
               </a:rPr>
               <a:t>37.5 GB/s</a:t>
             </a:r>
-            <a:endParaRPr lang="en-US" sz="890" dirty="0"/>
+            <a:endParaRPr lang="en-US" sz="900" dirty="0"/>
           </a:p>
         </p:txBody>
       </p:sp>
@@ -8558,7 +8558,7 @@
           </a:solidFill>
           <a:ln w="8255">
             <a:solidFill>
-              <a:srgbClr val="33445B"/>
+              <a:srgbClr val="3D5169"/>
             </a:solidFill>
             <a:prstDash val="solid"/>
           </a:ln>
@@ -8591,7 +8591,7 @@
               <a:buNone/>
             </a:pPr>
             <a:r>
-              <a:rPr lang="en-US" sz="890" dirty="0">
+              <a:rPr lang="en-US" sz="900" dirty="0">
                 <a:solidFill>
                   <a:srgbClr val="2DD4BF"/>
                 </a:solidFill>
@@ -8601,7 +8601,7 @@
               </a:rPr>
               <a:t>300 GB/s</a:t>
             </a:r>
-            <a:endParaRPr lang="en-US" sz="890" dirty="0"/>
+            <a:endParaRPr lang="en-US" sz="900" dirty="0"/>
           </a:p>
         </p:txBody>
       </p:sp>
@@ -8624,7 +8624,7 @@
           </a:solidFill>
           <a:ln w="8255">
             <a:solidFill>
-              <a:srgbClr val="33445B"/>
+              <a:srgbClr val="3D5169"/>
             </a:solidFill>
             <a:prstDash val="solid"/>
           </a:ln>
@@ -8657,7 +8657,7 @@
               <a:buNone/>
             </a:pPr>
             <a:r>
-              <a:rPr lang="en-US" sz="900" b="1" dirty="0">
+              <a:rPr lang="en-US" sz="910" b="1" dirty="0">
                 <a:solidFill>
                   <a:srgbClr val="F7F9FC"/>
                 </a:solidFill>
@@ -8667,7 +8667,7 @@
               </a:rPr>
               <a:t>SQL Read / Write IOPS</a:t>
             </a:r>
-            <a:endParaRPr lang="en-US" sz="900" dirty="0"/>
+            <a:endParaRPr lang="en-US" sz="910" dirty="0"/>
           </a:p>
         </p:txBody>
       </p:sp>
@@ -8690,7 +8690,7 @@
           </a:solidFill>
           <a:ln w="8255">
             <a:solidFill>
-              <a:srgbClr val="33445B"/>
+              <a:srgbClr val="3D5169"/>
             </a:solidFill>
             <a:prstDash val="solid"/>
           </a:ln>
@@ -8723,9 +8723,9 @@
               <a:buNone/>
             </a:pPr>
             <a:r>
-              <a:rPr lang="en-US" sz="890" dirty="0">
-                <a:solidFill>
-                  <a:srgbClr val="D9E1EC"/>
+              <a:rPr lang="en-US" sz="900" dirty="0">
+                <a:solidFill>
+                  <a:srgbClr val="CAD5E3"/>
                 </a:solidFill>
                 <a:latin typeface="Noto Sans KR" pitchFamily="34" charset="0"/>
                 <a:ea typeface="Noto Sans KR" pitchFamily="34" charset="-122"/>
@@ -8733,7 +8733,7 @@
               </a:rPr>
               <a:t>2.8M / 921K</a:t>
             </a:r>
-            <a:endParaRPr lang="en-US" sz="890" dirty="0"/>
+            <a:endParaRPr lang="en-US" sz="900" dirty="0"/>
           </a:p>
         </p:txBody>
       </p:sp>
@@ -8756,7 +8756,7 @@
           </a:solidFill>
           <a:ln w="8255">
             <a:solidFill>
-              <a:srgbClr val="33445B"/>
+              <a:srgbClr val="3D5169"/>
             </a:solidFill>
             <a:prstDash val="solid"/>
           </a:ln>
@@ -8789,9 +8789,9 @@
               <a:buNone/>
             </a:pPr>
             <a:r>
-              <a:rPr lang="en-US" sz="890" dirty="0">
-                <a:solidFill>
-                  <a:srgbClr val="D9E1EC"/>
+              <a:rPr lang="en-US" sz="900" dirty="0">
+                <a:solidFill>
+                  <a:srgbClr val="CAD5E3"/>
                 </a:solidFill>
                 <a:latin typeface="Noto Sans KR" pitchFamily="34" charset="0"/>
                 <a:ea typeface="Noto Sans KR" pitchFamily="34" charset="-122"/>
@@ -8799,7 +8799,7 @@
               </a:rPr>
               <a:t>597K / 544K</a:t>
             </a:r>
-            <a:endParaRPr lang="en-US" sz="890" dirty="0"/>
+            <a:endParaRPr lang="en-US" sz="900" dirty="0"/>
           </a:p>
         </p:txBody>
       </p:sp>
@@ -8822,7 +8822,7 @@
           </a:solidFill>
           <a:ln w="8255">
             <a:solidFill>
-              <a:srgbClr val="33445B"/>
+              <a:srgbClr val="3D5169"/>
             </a:solidFill>
             <a:prstDash val="solid"/>
           </a:ln>
@@ -8855,7 +8855,7 @@
               <a:buNone/>
             </a:pPr>
             <a:r>
-              <a:rPr lang="en-US" sz="890" dirty="0">
+              <a:rPr lang="en-US" sz="900" dirty="0">
                 <a:solidFill>
                   <a:srgbClr val="2DD4BF"/>
                 </a:solidFill>
@@ -8865,7 +8865,7 @@
               </a:rPr>
               <a:t>5.6M / 3.0M</a:t>
             </a:r>
-            <a:endParaRPr lang="en-US" sz="890" dirty="0"/>
+            <a:endParaRPr lang="en-US" sz="900" dirty="0"/>
           </a:p>
         </p:txBody>
       </p:sp>
@@ -8888,7 +8888,7 @@
           </a:solidFill>
           <a:ln w="8255">
             <a:solidFill>
-              <a:srgbClr val="33445B"/>
+              <a:srgbClr val="3D5169"/>
             </a:solidFill>
             <a:prstDash val="solid"/>
           </a:ln>
@@ -8921,7 +8921,7 @@
               <a:buNone/>
             </a:pPr>
             <a:r>
-              <a:rPr lang="en-US" sz="900" b="1" dirty="0">
+              <a:rPr lang="en-US" sz="910" b="1" dirty="0">
                 <a:solidFill>
                   <a:srgbClr val="F7F9FC"/>
                 </a:solidFill>
@@ -8931,7 +8931,7 @@
               </a:rPr>
               <a:t>Disk BW · IOPS · Load</a:t>
             </a:r>
-            <a:endParaRPr lang="en-US" sz="900" dirty="0"/>
+            <a:endParaRPr lang="en-US" sz="910" dirty="0"/>
           </a:p>
         </p:txBody>
       </p:sp>
@@ -8954,7 +8954,7 @@
           </a:solidFill>
           <a:ln w="8255">
             <a:solidFill>
-              <a:srgbClr val="33445B"/>
+              <a:srgbClr val="3D5169"/>
             </a:solidFill>
             <a:prstDash val="solid"/>
           </a:ln>
@@ -8987,9 +8987,9 @@
               <a:buNone/>
             </a:pPr>
             <a:r>
-              <a:rPr lang="en-US" sz="890" dirty="0">
-                <a:solidFill>
-                  <a:srgbClr val="D9E1EC"/>
+              <a:rPr lang="en-US" sz="900" dirty="0">
+                <a:solidFill>
+                  <a:srgbClr val="CAD5E3"/>
                 </a:solidFill>
                 <a:latin typeface="Noto Sans KR" pitchFamily="34" charset="0"/>
                 <a:ea typeface="Noto Sans KR" pitchFamily="34" charset="-122"/>
@@ -8997,16 +8997,16 @@
               </a:rPr>
               <a:t>2.7 GB/s · 3,900</a:t>
             </a:r>
-            <a:endParaRPr lang="en-US" sz="890" dirty="0"/>
+            <a:endParaRPr lang="en-US" sz="900" dirty="0"/>
           </a:p>
           <a:p>
             <a:pPr algn="ctr" indent="0" marL="0">
               <a:buNone/>
             </a:pPr>
             <a:r>
-              <a:rPr lang="en-US" sz="890" dirty="0">
-                <a:solidFill>
-                  <a:srgbClr val="D9E1EC"/>
+              <a:rPr lang="en-US" sz="900" dirty="0">
+                <a:solidFill>
+                  <a:srgbClr val="CAD5E3"/>
                 </a:solidFill>
                 <a:latin typeface="Noto Sans KR" pitchFamily="34" charset="0"/>
                 <a:ea typeface="Noto Sans KR" pitchFamily="34" charset="-122"/>
@@ -9014,7 +9014,7 @@
               </a:rPr>
               <a:t>3.8 TB/hr</a:t>
             </a:r>
-            <a:endParaRPr lang="en-US" sz="890" dirty="0"/>
+            <a:endParaRPr lang="en-US" sz="900" dirty="0"/>
           </a:p>
         </p:txBody>
       </p:sp>
@@ -9037,7 +9037,7 @@
           </a:solidFill>
           <a:ln w="8255">
             <a:solidFill>
-              <a:srgbClr val="33445B"/>
+              <a:srgbClr val="3D5169"/>
             </a:solidFill>
             <a:prstDash val="solid"/>
           </a:ln>
@@ -9070,9 +9070,9 @@
               <a:buNone/>
             </a:pPr>
             <a:r>
-              <a:rPr lang="en-US" sz="890" dirty="0">
-                <a:solidFill>
-                  <a:srgbClr val="D9E1EC"/>
+              <a:rPr lang="en-US" sz="900" dirty="0">
+                <a:solidFill>
+                  <a:srgbClr val="CAD5E3"/>
                 </a:solidFill>
                 <a:latin typeface="Noto Sans KR" pitchFamily="34" charset="0"/>
                 <a:ea typeface="Noto Sans KR" pitchFamily="34" charset="-122"/>
@@ -9080,16 +9080,16 @@
               </a:rPr>
               <a:t>2.7 GB/s · 3,900</a:t>
             </a:r>
-            <a:endParaRPr lang="en-US" sz="890" dirty="0"/>
+            <a:endParaRPr lang="en-US" sz="900" dirty="0"/>
           </a:p>
           <a:p>
             <a:pPr algn="ctr" indent="0" marL="0">
               <a:buNone/>
             </a:pPr>
             <a:r>
-              <a:rPr lang="en-US" sz="890" dirty="0">
-                <a:solidFill>
-                  <a:srgbClr val="D9E1EC"/>
+              <a:rPr lang="en-US" sz="900" dirty="0">
+                <a:solidFill>
+                  <a:srgbClr val="CAD5E3"/>
                 </a:solidFill>
                 <a:latin typeface="Noto Sans KR" pitchFamily="34" charset="0"/>
                 <a:ea typeface="Noto Sans KR" pitchFamily="34" charset="-122"/>
@@ -9097,7 +9097,7 @@
               </a:rPr>
               <a:t>3.8 TB/hr</a:t>
             </a:r>
-            <a:endParaRPr lang="en-US" sz="890" dirty="0"/>
+            <a:endParaRPr lang="en-US" sz="900" dirty="0"/>
           </a:p>
         </p:txBody>
       </p:sp>
@@ -9120,7 +9120,7 @@
           </a:solidFill>
           <a:ln w="8255">
             <a:solidFill>
-              <a:srgbClr val="33445B"/>
+              <a:srgbClr val="3D5169"/>
             </a:solidFill>
             <a:prstDash val="solid"/>
           </a:ln>
@@ -9153,7 +9153,7 @@
               <a:buNone/>
             </a:pPr>
             <a:r>
-              <a:rPr lang="en-US" sz="890" dirty="0">
+              <a:rPr lang="en-US" sz="900" dirty="0">
                 <a:solidFill>
                   <a:srgbClr val="2DD4BF"/>
                 </a:solidFill>
@@ -9163,14 +9163,14 @@
               </a:rPr>
               <a:t>5.4 GB/s · 7,800</a:t>
             </a:r>
-            <a:endParaRPr lang="en-US" sz="890" dirty="0"/>
+            <a:endParaRPr lang="en-US" sz="900" dirty="0"/>
           </a:p>
           <a:p>
             <a:pPr algn="ctr" indent="0" marL="0">
               <a:buNone/>
             </a:pPr>
             <a:r>
-              <a:rPr lang="en-US" sz="890" dirty="0">
+              <a:rPr lang="en-US" sz="900" dirty="0">
                 <a:solidFill>
                   <a:srgbClr val="2DD4BF"/>
                 </a:solidFill>
@@ -9180,7 +9180,7 @@
               </a:rPr>
               <a:t>7.5 TB/hr</a:t>
             </a:r>
-            <a:endParaRPr lang="en-US" sz="890" dirty="0"/>
+            <a:endParaRPr lang="en-US" sz="900" dirty="0"/>
           </a:p>
         </p:txBody>
       </p:sp>
@@ -9193,19 +9193,19 @@
         <p:spPr>
           <a:xfrm>
             <a:off x="512064" y="6108192"/>
-            <a:ext cx="11009376" cy="246888"/>
+            <a:ext cx="11009376" cy="310896"/>
           </a:xfrm>
           <a:prstGeom prst="roundRect">
             <a:avLst>
-              <a:gd name="adj" fmla="val 7407"/>
+              <a:gd name="adj" fmla="val 5882"/>
             </a:avLst>
           </a:prstGeom>
           <a:solidFill>
-            <a:srgbClr val="161E2A"/>
+            <a:srgbClr val="202A36"/>
           </a:solidFill>
           <a:ln w="12700">
             <a:solidFill>
-              <a:srgbClr val="161E2A"/>
+              <a:srgbClr val="4D6075"/>
             </a:solidFill>
             <a:prstDash val="solid"/>
           </a:ln>
@@ -9226,8 +9226,8 @@
         </p:nvSpPr>
         <p:spPr>
           <a:xfrm>
-            <a:off x="621792" y="6144768"/>
-            <a:ext cx="10789920" cy="164592"/>
+            <a:off x="621792" y="6140196"/>
+            <a:ext cx="10789920" cy="237744"/>
           </a:xfrm>
           <a:prstGeom prst="rect">
             <a:avLst/>
@@ -9245,17 +9245,34 @@
               <a:buNone/>
             </a:pPr>
             <a:r>
-              <a:rPr lang="en-US" sz="810" b="1" dirty="0">
-                <a:solidFill>
-                  <a:srgbClr val="D9E1EC"/>
-                </a:solidFill>
-                <a:latin typeface="Noto Sans KR" pitchFamily="34" charset="0"/>
-                <a:ea typeface="Noto Sans KR" pitchFamily="34" charset="-122"/>
-                <a:cs typeface="Noto Sans KR" pitchFamily="34" charset="-120"/>
-              </a:rPr>
-              <a:t>¹ ASM High Redundancy usable · X9M physical core와 ExaC@C usable core/ECPU는 직접 등가 비교 불가 · X11M에는 공식 Quarter Rack shape가 없음</a:t>
-            </a:r>
-            <a:endParaRPr lang="en-US" sz="810" dirty="0"/>
+              <a:rPr lang="en-US" sz="820" b="1" dirty="0">
+                <a:solidFill>
+                  <a:srgbClr val="F6B44B"/>
+                </a:solidFill>
+                <a:latin typeface="Noto Sans KR" pitchFamily="34" charset="0"/>
+                <a:ea typeface="Noto Sans KR" pitchFamily="34" charset="-122"/>
+                <a:cs typeface="Noto Sans KR" pitchFamily="34" charset="-120"/>
+              </a:rPr>
+              <a:t>¹ CPU 단위 주의: X9M physical core와 ExaC@C usable core/ECPU는 직접 비교 불가</a:t>
+            </a:r>
+            <a:endParaRPr lang="en-US" sz="820" dirty="0"/>
+          </a:p>
+          <a:p>
+            <a:pPr algn="l" indent="0" marL="0">
+              <a:buNone/>
+            </a:pPr>
+            <a:r>
+              <a:rPr lang="en-US" sz="820" b="1" dirty="0">
+                <a:solidFill>
+                  <a:srgbClr val="F6B44B"/>
+                </a:solidFill>
+                <a:latin typeface="Noto Sans KR" pitchFamily="34" charset="0"/>
+                <a:ea typeface="Noto Sans KR" pitchFamily="34" charset="-122"/>
+                <a:cs typeface="Noto Sans KR" pitchFamily="34" charset="-120"/>
+              </a:rPr>
+              <a:t>용량은 ASM High Redundancy usable · X11M에는 공식 Quarter Rack shape 없음(Elastic 2 DB + 3 Storage는 비공식 비교 기준)</a:t>
+            </a:r>
+            <a:endParaRPr lang="en-US" sz="820" dirty="0"/>
           </a:p>
         </p:txBody>
       </p:sp>
@@ -9358,7 +9375,7 @@
                 <a:ea typeface="Noto Sans KR" pitchFamily="34" charset="-122"/>
                 <a:cs typeface="Noto Sans KR" pitchFamily="34" charset="-120"/>
               </a:rPr>
-              <a:t>Sources: Oracle Exadata Database Machine X9M-2 DS (2023) pp.20–23 · ExaC@C X11M DS v1.5 Table 1</a:t>
+              <a:t>Sources: Oracle Exadata Database Machine X9M-2 DS (Copyright © 2021) pp.20–23 · ExaC@C X11M DS v1.5 Table 1</a:t>
             </a:r>
             <a:endParaRPr lang="en-US" sz="680" dirty="0"/>
           </a:p>

</xml_diff>